<commit_message>
docs: restyle EasyPilot iOS deck (blue accent, icon-grid tech stack)
- Blue accent instead of tan; accent underline on title; line through the
  "Was ist EasyPilot iOS" section.
- Tech stack reworked into an icon grid of understandable technologies
  (Swift, SwiftUI, WLAN, WebSocket, 3D-Simulator, ESP32) with icons.
- Added make_icons.py + generated wifi/websocket/cube3d/chip icons.

Co-Authored-By: Claude Opus 4.8 <noreply@anthropic.com>
</commit_message>
<xml_diff>
--- a/docs/presentation-ios/EasyPilot-iOS.pptx
+++ b/docs/presentation-ios/EasyPilot-iOS.pptx
@@ -3143,8 +3143,8 @@
         </p:nvSpPr>
         <p:spPr>
           <a:xfrm>
-            <a:off x="0" y="2743200"/>
-            <a:ext cx="12191695" cy="4114800"/>
+            <a:off x="0" y="2880360"/>
+            <a:ext cx="12191695" cy="3977640"/>
           </a:xfrm>
           <a:custGeom>
             <a:avLst/>
@@ -3153,7 +3153,7 @@
             <a:cxnLst/>
             <a:rect l="l" t="t" r="r" b="b"/>
             <a:pathLst>
-              <a:path w="12191695" h="4114800">
+              <a:path w="12191695" h="3977640">
                 <a:moveTo>
                   <a:pt x="0" y="2606040"/>
                 </a:moveTo>
@@ -3161,10 +3161,10 @@
                   <a:pt x="12191695" y="0"/>
                 </a:lnTo>
                 <a:lnTo>
-                  <a:pt x="12191695" y="4114800"/>
+                  <a:pt x="12191695" y="3977640"/>
                 </a:lnTo>
                 <a:lnTo>
-                  <a:pt x="0" y="4114800"/>
+                  <a:pt x="0" y="3977640"/>
                 </a:lnTo>
                 <a:close/>
               </a:path>
@@ -3245,7 +3245,7 @@
             <a:r>
               <a:rPr sz="6000" b="0">
                 <a:solidFill>
-                  <a:srgbClr val="C9B79C"/>
+                  <a:srgbClr val="2F80ED"/>
                 </a:solidFill>
                 <a:latin typeface="Georgia"/>
               </a:rPr>
@@ -3256,14 +3256,58 @@
       </p:sp>
       <p:sp>
         <p:nvSpPr>
-          <p:cNvPr id="5" name="TextBox 4"/>
+          <p:cNvPr id="5" name="Rectangle 4"/>
+          <p:cNvSpPr/>
+          <p:nvPr/>
+        </p:nvSpPr>
+        <p:spPr>
+          <a:xfrm>
+            <a:off x="868680" y="1938528"/>
+            <a:ext cx="2103120" cy="44450"/>
+          </a:xfrm>
+          <a:prstGeom prst="rect">
+            <a:avLst/>
+          </a:prstGeom>
+          <a:solidFill>
+            <a:srgbClr val="2F80ED"/>
+          </a:solidFill>
+          <a:ln>
+            <a:noFill/>
+          </a:ln>
+          <a:effectLst/>
+        </p:spPr>
+        <p:style>
+          <a:lnRef idx="1">
+            <a:schemeClr val="accent1"/>
+          </a:lnRef>
+          <a:fillRef idx="3">
+            <a:schemeClr val="accent1"/>
+          </a:fillRef>
+          <a:effectRef idx="2">
+            <a:schemeClr val="accent1"/>
+          </a:effectRef>
+          <a:fontRef idx="minor">
+            <a:schemeClr val="lt1"/>
+          </a:fontRef>
+        </p:style>
+        <p:txBody>
+          <a:bodyPr rtlCol="0" anchor="ctr"/>
+          <a:lstStyle/>
+          <a:p>
+            <a:pPr algn="ctr"/>
+          </a:p>
+        </p:txBody>
+      </p:sp>
+      <p:sp>
+        <p:nvSpPr>
+          <p:cNvPr id="6" name="TextBox 5"/>
           <p:cNvSpPr txBox="1"/>
           <p:nvPr/>
         </p:nvSpPr>
         <p:spPr>
           <a:xfrm>
-            <a:off x="868680" y="2148840"/>
-            <a:ext cx="9601200" cy="731520"/>
+            <a:off x="868680" y="2240280"/>
+            <a:ext cx="9692640" cy="822960"/>
           </a:xfrm>
           <a:prstGeom prst="rect">
             <a:avLst/>
@@ -3323,13 +3367,13 @@
       </p:sp>
       <p:sp>
         <p:nvSpPr>
-          <p:cNvPr id="6" name="TextBox 5"/>
+          <p:cNvPr id="7" name="TextBox 6"/>
           <p:cNvSpPr txBox="1"/>
           <p:nvPr/>
         </p:nvSpPr>
         <p:spPr>
           <a:xfrm>
-            <a:off x="868680" y="3383280"/>
+            <a:off x="868680" y="3520440"/>
             <a:ext cx="7315200" cy="822960"/>
           </a:xfrm>
           <a:prstGeom prst="rect">
@@ -3452,45 +3496,46 @@
       </p:sp>
       <p:sp>
         <p:nvSpPr>
-          <p:cNvPr id="3" name="Rectangle 2"/>
-          <p:cNvSpPr/>
+          <p:cNvPr id="3" name="TextBox 2"/>
+          <p:cNvSpPr txBox="1"/>
           <p:nvPr/>
         </p:nvSpPr>
         <p:spPr>
           <a:xfrm>
-            <a:off x="0" y="0"/>
-            <a:ext cx="5852160" cy="6858000"/>
+            <a:off x="777240" y="640080"/>
+            <a:ext cx="10607040" cy="914400"/>
           </a:xfrm>
           <a:prstGeom prst="rect">
             <a:avLst/>
           </a:prstGeom>
-          <a:solidFill>
-            <a:srgbClr val="2C3649"/>
-          </a:solidFill>
-          <a:ln>
-            <a:noFill/>
-          </a:ln>
-          <a:effectLst/>
-        </p:spPr>
-        <p:style>
-          <a:lnRef idx="1">
-            <a:schemeClr val="accent1"/>
-          </a:lnRef>
-          <a:fillRef idx="3">
-            <a:schemeClr val="accent1"/>
-          </a:fillRef>
-          <a:effectRef idx="2">
-            <a:schemeClr val="accent1"/>
-          </a:effectRef>
-          <a:fontRef idx="minor">
-            <a:schemeClr val="lt1"/>
-          </a:fontRef>
-        </p:style>
-        <p:txBody>
-          <a:bodyPr rtlCol="0" anchor="ctr"/>
-          <a:lstStyle/>
-          <a:p>
-            <a:pPr algn="ctr"/>
+          <a:noFill/>
+        </p:spPr>
+        <p:txBody>
+          <a:bodyPr wrap="square" anchor="t" lIns="0" rIns="0" tIns="0" bIns="0">
+            <a:spAutoFit/>
+          </a:bodyPr>
+          <a:lstStyle/>
+          <a:p>
+            <a:pPr algn="l">
+              <a:lnSpc>
+                <a:spcPct val="100000"/>
+              </a:lnSpc>
+              <a:spcBef>
+                <a:spcPts val="0"/>
+              </a:spcBef>
+              <a:spcAft>
+                <a:spcPts val="800"/>
+              </a:spcAft>
+            </a:pPr>
+            <a:r>
+              <a:rPr sz="3600" b="0">
+                <a:solidFill>
+                  <a:srgbClr val="103A50"/>
+                </a:solidFill>
+                <a:latin typeface="Georgia"/>
+              </a:rPr>
+              <a:t>Was ist EasyPilot iOS</a:t>
+            </a:r>
           </a:p>
         </p:txBody>
       </p:sp>
@@ -3501,16 +3546,16 @@
           <p:nvPr/>
         </p:nvCxnSpPr>
         <p:spPr>
-          <a:xfrm flipV="1">
-            <a:off x="0" y="4251960"/>
-            <a:ext cx="5852160" cy="1645920"/>
+          <a:xfrm>
+            <a:off x="777240" y="1600200"/>
+            <a:ext cx="10634472" cy="0"/>
           </a:xfrm>
           <a:prstGeom prst="line">
             <a:avLst/>
           </a:prstGeom>
-          <a:ln w="31750">
+          <a:ln w="28575">
             <a:solidFill>
-              <a:srgbClr val="C9B79C"/>
+              <a:srgbClr val="2F80ED"/>
             </a:solidFill>
           </a:ln>
           <a:effectLst/>
@@ -3538,8 +3583,8 @@
         </p:nvSpPr>
         <p:spPr>
           <a:xfrm>
-            <a:off x="548640" y="685800"/>
-            <a:ext cx="4937760" cy="914400"/>
+            <a:off x="777240" y="2057400"/>
+            <a:ext cx="5852160" cy="4206240"/>
           </a:xfrm>
           <a:prstGeom prst="rect">
             <a:avLst/>
@@ -3554,184 +3599,139 @@
           <a:p>
             <a:pPr algn="l">
               <a:lnSpc>
-                <a:spcPct val="100000"/>
+                <a:spcPct val="108000"/>
               </a:lnSpc>
               <a:spcBef>
                 <a:spcPts val="0"/>
               </a:spcBef>
               <a:spcAft>
-                <a:spcPts val="800"/>
+                <a:spcPts val="1600"/>
               </a:spcAft>
             </a:pPr>
             <a:r>
-              <a:rPr sz="3400" b="0">
+              <a:rPr sz="1400" b="1">
                 <a:solidFill>
-                  <a:srgbClr val="FFFFFF"/>
+                  <a:srgbClr val="2F80ED"/>
                 </a:solidFill>
-                <a:latin typeface="Georgia"/>
+                <a:latin typeface="Calibri"/>
               </a:rPr>
-              <a:t>Was ist EasyPilot iOS</a:t>
-            </a:r>
-          </a:p>
-        </p:txBody>
-      </p:sp>
-      <p:sp>
-        <p:nvSpPr>
-          <p:cNvPr id="6" name="TextBox 5"/>
-          <p:cNvSpPr txBox="1"/>
-          <p:nvPr/>
-        </p:nvSpPr>
-        <p:spPr>
-          <a:xfrm>
-            <a:off x="566928" y="1783080"/>
-            <a:ext cx="4937760" cy="4206240"/>
-          </a:xfrm>
-          <a:prstGeom prst="rect">
-            <a:avLst/>
-          </a:prstGeom>
-          <a:noFill/>
-        </p:spPr>
-        <p:txBody>
-          <a:bodyPr wrap="square" anchor="t" lIns="0" rIns="0" tIns="0" bIns="0">
-            <a:spAutoFit/>
-          </a:bodyPr>
-          <a:lstStyle/>
+              <a:t>●  </a:t>
+            </a:r>
+            <a:r>
+              <a:rPr sz="1650" b="0">
+                <a:solidFill>
+                  <a:srgbClr val="333B47"/>
+                </a:solidFill>
+                <a:latin typeface="Calibri"/>
+              </a:rPr>
+              <a:t>EasyPilot ist unser 4AHITM-Drohnenprojekt: eine selbstgebaute Drohne mit ESP32-Steuerung.</a:t>
+            </a:r>
+          </a:p>
           <a:p>
             <a:pPr algn="l">
               <a:lnSpc>
-                <a:spcPct val="105000"/>
+                <a:spcPct val="108000"/>
               </a:lnSpc>
               <a:spcBef>
                 <a:spcPts val="0"/>
               </a:spcBef>
               <a:spcAft>
-                <a:spcPts val="1400"/>
+                <a:spcPts val="1600"/>
               </a:spcAft>
             </a:pPr>
             <a:r>
               <a:rPr sz="1400" b="1">
                 <a:solidFill>
-                  <a:srgbClr val="C9B79C"/>
+                  <a:srgbClr val="2F80ED"/>
                 </a:solidFill>
                 <a:latin typeface="Calibri"/>
               </a:rPr>
               <a:t>●  </a:t>
             </a:r>
             <a:r>
-              <a:rPr sz="1600" b="0">
+              <a:rPr sz="1650" b="0">
                 <a:solidFill>
-                  <a:srgbClr val="D7DCE3"/>
+                  <a:srgbClr val="333B47"/>
                 </a:solidFill>
                 <a:latin typeface="Calibri"/>
               </a:rPr>
-              <a:t>EasyPilot ist unser 4AHITM-Drohnenprojekt: eine selbstgebaute Drohne mit ESP32-Steuerung.</a:t>
+              <a:t>Die iOS-App ist der mobile Co-Pilot – komplett in SwiftUI, nur mit Apple-Frameworks.</a:t>
             </a:r>
           </a:p>
           <a:p>
             <a:pPr algn="l">
               <a:lnSpc>
-                <a:spcPct val="105000"/>
+                <a:spcPct val="108000"/>
               </a:lnSpc>
               <a:spcBef>
                 <a:spcPts val="0"/>
               </a:spcBef>
               <a:spcAft>
-                <a:spcPts val="1400"/>
+                <a:spcPts val="1600"/>
               </a:spcAft>
             </a:pPr>
             <a:r>
               <a:rPr sz="1400" b="1">
                 <a:solidFill>
-                  <a:srgbClr val="C9B79C"/>
+                  <a:srgbClr val="2F80ED"/>
                 </a:solidFill>
                 <a:latin typeface="Calibri"/>
               </a:rPr>
               <a:t>●  </a:t>
             </a:r>
             <a:r>
-              <a:rPr sz="1600" b="0">
+              <a:rPr sz="1650" b="0">
                 <a:solidFill>
-                  <a:srgbClr val="D7DCE3"/>
+                  <a:srgbClr val="333B47"/>
                 </a:solidFill>
                 <a:latin typeface="Calibri"/>
               </a:rPr>
-              <a:t>Die iOS-App ist der mobile Co-Pilot – komplett in SwiftUI mit reinen Apple-Frameworks, ohne Fremd-Bibliotheken.</a:t>
+              <a:t>Sie findet die Drohne automatisch im WLAN – ohne Eintippen einer IP-Adresse.</a:t>
             </a:r>
           </a:p>
           <a:p>
             <a:pPr algn="l">
               <a:lnSpc>
-                <a:spcPct val="105000"/>
+                <a:spcPct val="108000"/>
               </a:lnSpc>
               <a:spcBef>
                 <a:spcPts val="0"/>
               </a:spcBef>
               <a:spcAft>
-                <a:spcPts val="1400"/>
+                <a:spcPts val="1600"/>
               </a:spcAft>
             </a:pPr>
             <a:r>
               <a:rPr sz="1400" b="1">
                 <a:solidFill>
-                  <a:srgbClr val="C9B79C"/>
+                  <a:srgbClr val="2F80ED"/>
                 </a:solidFill>
                 <a:latin typeface="Calibri"/>
               </a:rPr>
               <a:t>●  </a:t>
             </a:r>
             <a:r>
-              <a:rPr sz="1600" b="0">
+              <a:rPr sz="1650" b="0">
                 <a:solidFill>
-                  <a:srgbClr val="D7DCE3"/>
+                  <a:srgbClr val="333B47"/>
                 </a:solidFill>
                 <a:latin typeface="Calibri"/>
               </a:rPr>
-              <a:t>Sie findet die Drohne automatisch im WLAN (kein Eintippen einer IP) und verbindet sich per WebSocket.</a:t>
-            </a:r>
-          </a:p>
-          <a:p>
-            <a:pPr algn="l">
-              <a:lnSpc>
-                <a:spcPct val="105000"/>
-              </a:lnSpc>
-              <a:spcBef>
-                <a:spcPts val="0"/>
-              </a:spcBef>
-              <a:spcAft>
-                <a:spcPts val="1400"/>
-              </a:spcAft>
-            </a:pPr>
-            <a:r>
-              <a:rPr sz="1400" b="1">
-                <a:solidFill>
-                  <a:srgbClr val="C9B79C"/>
-                </a:solidFill>
-                <a:latin typeface="Calibri"/>
-              </a:rPr>
-              <a:t>●  </a:t>
-            </a:r>
-            <a:r>
-              <a:rPr sz="1600" b="0">
-                <a:solidFill>
-                  <a:srgbClr val="D7DCE3"/>
-                </a:solidFill>
-                <a:latin typeface="Calibri"/>
-              </a:rPr>
-              <a:t>Live-Telemetrie mit 10 Hz, ein 3D-Flugsimulator und das Senden von Flugbefehlen – alles auf dem iPhone.</a:t>
-            </a:r>
-          </a:p>
-        </p:txBody>
-      </p:sp>
-      <p:sp>
-        <p:nvSpPr>
-          <p:cNvPr id="7" name="Rounded Rectangle 6"/>
+              <a:t>Live-Telemetrie mit 10 Hz, ein 3D-Flugsimulator und das Senden von Flugbefehlen – alles auf dem iPhone.</a:t>
+            </a:r>
+          </a:p>
+        </p:txBody>
+      </p:sp>
+      <p:sp>
+        <p:nvSpPr>
+          <p:cNvPr id="6" name="Rounded Rectangle 5"/>
           <p:cNvSpPr/>
           <p:nvPr/>
         </p:nvSpPr>
         <p:spPr>
           <a:xfrm>
-            <a:off x="6858000" y="1554480"/>
-            <a:ext cx="4206240" cy="1143000"/>
+            <a:off x="7315200" y="2240280"/>
+            <a:ext cx="4023360" cy="1143000"/>
           </a:xfrm>
           <a:prstGeom prst="roundRect">
             <a:avLst>
@@ -3743,7 +3743,7 @@
           </a:solidFill>
           <a:ln w="25400">
             <a:solidFill>
-              <a:srgbClr val="103A50"/>
+              <a:srgbClr val="2F80ED"/>
             </a:solidFill>
           </a:ln>
           <a:effectLst/>
@@ -3772,14 +3772,14 @@
       </p:sp>
       <p:sp>
         <p:nvSpPr>
-          <p:cNvPr id="8" name="TextBox 7"/>
+          <p:cNvPr id="7" name="TextBox 6"/>
           <p:cNvSpPr txBox="1"/>
           <p:nvPr/>
         </p:nvSpPr>
         <p:spPr>
           <a:xfrm>
-            <a:off x="6858000" y="1554480"/>
-            <a:ext cx="4206240" cy="1143000"/>
+            <a:off x="7315200" y="2240280"/>
+            <a:ext cx="4023360" cy="1143000"/>
           </a:xfrm>
           <a:prstGeom prst="rect">
             <a:avLst/>
@@ -3839,14 +3839,14 @@
       </p:sp>
       <p:sp>
         <p:nvSpPr>
-          <p:cNvPr id="9" name="Rounded Rectangle 8"/>
+          <p:cNvPr id="8" name="Rounded Rectangle 7"/>
           <p:cNvSpPr/>
           <p:nvPr/>
         </p:nvSpPr>
         <p:spPr>
           <a:xfrm>
-            <a:off x="6858000" y="4480560"/>
-            <a:ext cx="4206240" cy="1143000"/>
+            <a:off x="7315200" y="4983480"/>
+            <a:ext cx="4023360" cy="1143000"/>
           </a:xfrm>
           <a:prstGeom prst="roundRect">
             <a:avLst>
@@ -3858,7 +3858,7 @@
           </a:solidFill>
           <a:ln w="25400">
             <a:solidFill>
-              <a:srgbClr val="C9B79C"/>
+              <a:srgbClr val="2C3649"/>
             </a:solidFill>
           </a:ln>
           <a:effectLst/>
@@ -3887,14 +3887,14 @@
       </p:sp>
       <p:sp>
         <p:nvSpPr>
-          <p:cNvPr id="10" name="TextBox 9"/>
+          <p:cNvPr id="9" name="TextBox 8"/>
           <p:cNvSpPr txBox="1"/>
           <p:nvPr/>
         </p:nvSpPr>
         <p:spPr>
           <a:xfrm>
-            <a:off x="6858000" y="4480560"/>
-            <a:ext cx="4206240" cy="1143000"/>
+            <a:off x="7315200" y="4983480"/>
+            <a:ext cx="4023360" cy="1143000"/>
           </a:xfrm>
           <a:prstGeom prst="rect">
             <a:avLst/>
@@ -3954,14 +3954,14 @@
       </p:sp>
       <p:cxnSp>
         <p:nvCxnSpPr>
-          <p:cNvPr id="11" name="Connector 10"/>
+          <p:cNvPr id="10" name="Connector 9"/>
           <p:cNvCxnSpPr/>
           <p:nvPr/>
         </p:nvCxnSpPr>
         <p:spPr>
           <a:xfrm>
-            <a:off x="8595360" y="2697480"/>
-            <a:ext cx="0" cy="1783080"/>
+            <a:off x="8001000" y="3383280"/>
+            <a:ext cx="0" cy="1600200"/>
           </a:xfrm>
           <a:prstGeom prst="line">
             <a:avLst/>
@@ -3991,14 +3991,14 @@
       </p:cxnSp>
       <p:cxnSp>
         <p:nvCxnSpPr>
-          <p:cNvPr id="12" name="Connector 11"/>
+          <p:cNvPr id="11" name="Connector 10"/>
           <p:cNvCxnSpPr/>
           <p:nvPr/>
         </p:nvCxnSpPr>
         <p:spPr>
           <a:xfrm flipV="1">
-            <a:off x="9326880" y="2697480"/>
-            <a:ext cx="0" cy="1783080"/>
+            <a:off x="10652760" y="3383280"/>
+            <a:ext cx="0" cy="1600200"/>
           </a:xfrm>
           <a:prstGeom prst="line">
             <a:avLst/>
@@ -4028,14 +4028,14 @@
       </p:cxnSp>
       <p:sp>
         <p:nvSpPr>
-          <p:cNvPr id="13" name="TextBox 12"/>
+          <p:cNvPr id="12" name="TextBox 11"/>
           <p:cNvSpPr txBox="1"/>
           <p:nvPr/>
         </p:nvSpPr>
         <p:spPr>
           <a:xfrm>
-            <a:off x="6858000" y="3063240"/>
-            <a:ext cx="4206240" cy="1280160"/>
+            <a:off x="7315200" y="3749039"/>
+            <a:ext cx="4023360" cy="1097280"/>
           </a:xfrm>
           <a:prstGeom prst="rect">
             <a:avLst/>
@@ -4066,7 +4066,7 @@
                 </a:solidFill>
                 <a:latin typeface="Calibri"/>
               </a:rPr>
-              <a:t>UDP-Discovery · Port 4242</a:t>
+              <a:t>WLAN-Discovery · 10 Hz</a:t>
             </a:r>
           </a:p>
           <a:p>
@@ -4088,7 +4088,7 @@
                 </a:solidFill>
                 <a:latin typeface="Calibri"/>
               </a:rPr>
-              <a:t>WebSocket · Port 81 · 10 Hz</a:t>
+              <a:t>Befehle ↑ · Telemetrie ↓</a:t>
             </a:r>
           </a:p>
         </p:txBody>
@@ -4164,7 +4164,7 @@
         <p:spPr>
           <a:xfrm>
             <a:off x="0" y="0"/>
-            <a:ext cx="12191695" cy="1600200"/>
+            <a:ext cx="12191695" cy="1463040"/>
           </a:xfrm>
           <a:prstGeom prst="rect">
             <a:avLst/>
@@ -4208,7 +4208,7 @@
         <p:spPr>
           <a:xfrm>
             <a:off x="777240" y="0"/>
-            <a:ext cx="10058400" cy="1600200"/>
+            <a:ext cx="10058400" cy="1463040"/>
           </a:xfrm>
           <a:prstGeom prst="rect">
             <a:avLst/>
@@ -4246,112 +4246,22 @@
       </p:sp>
       <p:sp>
         <p:nvSpPr>
-          <p:cNvPr id="5" name="TextBox 4"/>
-          <p:cNvSpPr txBox="1"/>
-          <p:nvPr/>
-        </p:nvSpPr>
-        <p:spPr>
-          <a:xfrm>
-            <a:off x="777240" y="1965960"/>
-            <a:ext cx="5029200" cy="365760"/>
-          </a:xfrm>
-          <a:prstGeom prst="rect">
-            <a:avLst/>
-          </a:prstGeom>
-          <a:noFill/>
-        </p:spPr>
-        <p:txBody>
-          <a:bodyPr wrap="square" anchor="t" lIns="0" rIns="0" tIns="0" bIns="0">
-            <a:spAutoFit/>
-          </a:bodyPr>
-          <a:lstStyle/>
-          <a:p>
-            <a:pPr algn="l">
-              <a:lnSpc>
-                <a:spcPct val="100000"/>
-              </a:lnSpc>
-              <a:spcBef>
-                <a:spcPts val="0"/>
-              </a:spcBef>
-              <a:spcAft>
-                <a:spcPts val="800"/>
-              </a:spcAft>
-            </a:pPr>
-            <a:r>
-              <a:rPr sz="1300" b="1">
-                <a:solidFill>
-                  <a:srgbClr val="103A50"/>
-                </a:solidFill>
-                <a:latin typeface="Calibri"/>
-              </a:rPr>
-              <a:t>APP · iPHONE</a:t>
-            </a:r>
-          </a:p>
-        </p:txBody>
-      </p:sp>
-      <p:sp>
-        <p:nvSpPr>
-          <p:cNvPr id="6" name="TextBox 5"/>
-          <p:cNvSpPr txBox="1"/>
-          <p:nvPr/>
-        </p:nvSpPr>
-        <p:spPr>
-          <a:xfrm>
-            <a:off x="6766560" y="1965960"/>
-            <a:ext cx="5029200" cy="365760"/>
-          </a:xfrm>
-          <a:prstGeom prst="rect">
-            <a:avLst/>
-          </a:prstGeom>
-          <a:noFill/>
-        </p:spPr>
-        <p:txBody>
-          <a:bodyPr wrap="square" anchor="t" lIns="0" rIns="0" tIns="0" bIns="0">
-            <a:spAutoFit/>
-          </a:bodyPr>
-          <a:lstStyle/>
-          <a:p>
-            <a:pPr algn="l">
-              <a:lnSpc>
-                <a:spcPct val="100000"/>
-              </a:lnSpc>
-              <a:spcBef>
-                <a:spcPts val="0"/>
-              </a:spcBef>
-              <a:spcAft>
-                <a:spcPts val="800"/>
-              </a:spcAft>
-            </a:pPr>
-            <a:r>
-              <a:rPr sz="1300" b="1">
-                <a:solidFill>
-                  <a:srgbClr val="C9B79C"/>
-                </a:solidFill>
-                <a:latin typeface="Calibri"/>
-              </a:rPr>
-              <a:t>DROHNE · ESP32-C3</a:t>
-            </a:r>
-          </a:p>
-        </p:txBody>
-      </p:sp>
-      <p:sp>
-        <p:nvSpPr>
-          <p:cNvPr id="7" name="Rounded Rectangle 6"/>
+          <p:cNvPr id="5" name="Rounded Rectangle 4"/>
           <p:cNvSpPr/>
           <p:nvPr/>
         </p:nvSpPr>
         <p:spPr>
           <a:xfrm>
-            <a:off x="777240" y="2423160"/>
-            <a:ext cx="4937760" cy="731520"/>
+            <a:off x="777240" y="1828800"/>
+            <a:ext cx="3271418" cy="2148840"/>
           </a:xfrm>
           <a:prstGeom prst="roundRect">
             <a:avLst>
-              <a:gd name="adj" fmla="val 10000"/>
+              <a:gd name="adj" fmla="val 6000"/>
             </a:avLst>
           </a:prstGeom>
           <a:solidFill>
-            <a:srgbClr val="F3F5F8"/>
+            <a:srgbClr val="F6F8FB"/>
           </a:solidFill>
           <a:ln w="12700">
             <a:solidFill>
@@ -4382,25 +4292,143 @@
           </a:p>
         </p:txBody>
       </p:sp>
-      <p:sp>
-        <p:nvSpPr>
-          <p:cNvPr id="8" name="Rectangle 7"/>
-          <p:cNvSpPr/>
+      <p:pic>
+        <p:nvPicPr>
+          <p:cNvPr id="6" name="Picture 5" descr="swift.png"/>
+          <p:cNvPicPr>
+            <a:picLocks noChangeAspect="1"/>
+          </p:cNvPicPr>
           <p:nvPr/>
-        </p:nvSpPr>
-        <p:spPr>
-          <a:xfrm>
-            <a:off x="777240" y="2423160"/>
-            <a:ext cx="73152" cy="731520"/>
+        </p:nvPicPr>
+        <p:blipFill>
+          <a:blip r:embed="rId2"/>
+          <a:stretch>
+            <a:fillRect/>
+          </a:stretch>
+        </p:blipFill>
+        <p:spPr>
+          <a:xfrm>
+            <a:off x="1727149" y="2367153"/>
+            <a:ext cx="1371600" cy="422909"/>
           </a:xfrm>
           <a:prstGeom prst="rect">
             <a:avLst/>
           </a:prstGeom>
+        </p:spPr>
+      </p:pic>
+      <p:sp>
+        <p:nvSpPr>
+          <p:cNvPr id="7" name="TextBox 6"/>
+          <p:cNvSpPr txBox="1"/>
+          <p:nvPr/>
+        </p:nvSpPr>
+        <p:spPr>
+          <a:xfrm>
+            <a:off x="777240" y="3200400"/>
+            <a:ext cx="3271418" cy="457200"/>
+          </a:xfrm>
+          <a:prstGeom prst="rect">
+            <a:avLst/>
+          </a:prstGeom>
+          <a:noFill/>
+        </p:spPr>
+        <p:txBody>
+          <a:bodyPr wrap="square" anchor="t" lIns="0" rIns="0" tIns="0" bIns="0">
+            <a:spAutoFit/>
+          </a:bodyPr>
+          <a:lstStyle/>
+          <a:p>
+            <a:pPr algn="ctr">
+              <a:lnSpc>
+                <a:spcPct val="100000"/>
+              </a:lnSpc>
+              <a:spcBef>
+                <a:spcPts val="0"/>
+              </a:spcBef>
+              <a:spcAft>
+                <a:spcPts val="800"/>
+              </a:spcAft>
+            </a:pPr>
+            <a:r>
+              <a:rPr sz="1800" b="1">
+                <a:solidFill>
+                  <a:srgbClr val="103A50"/>
+                </a:solidFill>
+                <a:latin typeface="Calibri"/>
+              </a:rPr>
+              <a:t>Swift</a:t>
+            </a:r>
+          </a:p>
+        </p:txBody>
+      </p:sp>
+      <p:sp>
+        <p:nvSpPr>
+          <p:cNvPr id="8" name="TextBox 7"/>
+          <p:cNvSpPr txBox="1"/>
+          <p:nvPr/>
+        </p:nvSpPr>
+        <p:spPr>
+          <a:xfrm>
+            <a:off x="777240" y="3584448"/>
+            <a:ext cx="3271418" cy="365760"/>
+          </a:xfrm>
+          <a:prstGeom prst="rect">
+            <a:avLst/>
+          </a:prstGeom>
+          <a:noFill/>
+        </p:spPr>
+        <p:txBody>
+          <a:bodyPr wrap="square" anchor="t" lIns="0" rIns="0" tIns="0" bIns="0">
+            <a:spAutoFit/>
+          </a:bodyPr>
+          <a:lstStyle/>
+          <a:p>
+            <a:pPr algn="ctr">
+              <a:lnSpc>
+                <a:spcPct val="100000"/>
+              </a:lnSpc>
+              <a:spcBef>
+                <a:spcPts val="0"/>
+              </a:spcBef>
+              <a:spcAft>
+                <a:spcPts val="800"/>
+              </a:spcAft>
+            </a:pPr>
+            <a:r>
+              <a:rPr sz="1250" b="0">
+                <a:solidFill>
+                  <a:srgbClr val="6B7482"/>
+                </a:solidFill>
+                <a:latin typeface="Calibri"/>
+              </a:rPr>
+              <a:t>Sprache der App</a:t>
+            </a:r>
+          </a:p>
+        </p:txBody>
+      </p:sp>
+      <p:sp>
+        <p:nvSpPr>
+          <p:cNvPr id="9" name="Rounded Rectangle 8"/>
+          <p:cNvSpPr/>
+          <p:nvPr/>
+        </p:nvSpPr>
+        <p:spPr>
+          <a:xfrm>
+            <a:off x="4460138" y="1828800"/>
+            <a:ext cx="3271418" cy="2148840"/>
+          </a:xfrm>
+          <a:prstGeom prst="roundRect">
+            <a:avLst>
+              <a:gd name="adj" fmla="val 6000"/>
+            </a:avLst>
+          </a:prstGeom>
           <a:solidFill>
-            <a:srgbClr val="103A50"/>
+            <a:srgbClr val="F6F8FB"/>
           </a:solidFill>
-          <a:ln>
-            <a:noFill/>
+          <a:ln w="12700">
+            <a:solidFill>
+              <a:srgbClr val="DDE1E7"/>
+            </a:solidFill>
           </a:ln>
           <a:effectLst/>
         </p:spPr>
@@ -4426,16 +4454,40 @@
           </a:p>
         </p:txBody>
       </p:sp>
-      <p:sp>
-        <p:nvSpPr>
-          <p:cNvPr id="9" name="TextBox 8"/>
+      <p:pic>
+        <p:nvPicPr>
+          <p:cNvPr id="10" name="Picture 9" descr="swiftui.png"/>
+          <p:cNvPicPr>
+            <a:picLocks noChangeAspect="1"/>
+          </p:cNvPicPr>
+          <p:nvPr/>
+        </p:nvPicPr>
+        <p:blipFill>
+          <a:blip r:embed="rId3"/>
+          <a:stretch>
+            <a:fillRect/>
+          </a:stretch>
+        </p:blipFill>
+        <p:spPr>
+          <a:xfrm>
+            <a:off x="5638647" y="2121408"/>
+            <a:ext cx="914400" cy="914400"/>
+          </a:xfrm>
+          <a:prstGeom prst="rect">
+            <a:avLst/>
+          </a:prstGeom>
+        </p:spPr>
+      </p:pic>
+      <p:sp>
+        <p:nvSpPr>
+          <p:cNvPr id="11" name="TextBox 10"/>
           <p:cNvSpPr txBox="1"/>
           <p:nvPr/>
         </p:nvSpPr>
         <p:spPr>
           <a:xfrm>
-            <a:off x="1033272" y="2423160"/>
-            <a:ext cx="4553712" cy="731520"/>
+            <a:off x="4460138" y="3200400"/>
+            <a:ext cx="3271418" cy="457200"/>
           </a:xfrm>
           <a:prstGeom prst="rect">
             <a:avLst/>
@@ -4443,12 +4495,12 @@
           <a:noFill/>
         </p:spPr>
         <p:txBody>
-          <a:bodyPr wrap="square" anchor="ctr" lIns="0" rIns="0" tIns="0" bIns="0">
+          <a:bodyPr wrap="square" anchor="t" lIns="0" rIns="0" tIns="0" bIns="0">
             <a:spAutoFit/>
           </a:bodyPr>
           <a:lstStyle/>
           <a:p>
-            <a:pPr algn="l">
+            <a:pPr algn="ctr">
               <a:lnSpc>
                 <a:spcPct val="100000"/>
               </a:lnSpc>
@@ -4456,21 +4508,44 @@
                 <a:spcPts val="0"/>
               </a:spcBef>
               <a:spcAft>
-                <a:spcPts val="200"/>
+                <a:spcPts val="800"/>
               </a:spcAft>
             </a:pPr>
             <a:r>
-              <a:rPr sz="1600" b="1">
+              <a:rPr sz="1800" b="1">
                 <a:solidFill>
                   <a:srgbClr val="103A50"/>
                 </a:solidFill>
                 <a:latin typeface="Calibri"/>
               </a:rPr>
-              <a:t>Swift</a:t>
-            </a:r>
-          </a:p>
-          <a:p>
-            <a:pPr algn="l">
+              <a:t>SwiftUI</a:t>
+            </a:r>
+          </a:p>
+        </p:txBody>
+      </p:sp>
+      <p:sp>
+        <p:nvSpPr>
+          <p:cNvPr id="12" name="TextBox 11"/>
+          <p:cNvSpPr txBox="1"/>
+          <p:nvPr/>
+        </p:nvSpPr>
+        <p:spPr>
+          <a:xfrm>
+            <a:off x="4460138" y="3584448"/>
+            <a:ext cx="3271418" cy="365760"/>
+          </a:xfrm>
+          <a:prstGeom prst="rect">
+            <a:avLst/>
+          </a:prstGeom>
+          <a:noFill/>
+        </p:spPr>
+        <p:txBody>
+          <a:bodyPr wrap="square" anchor="t" lIns="0" rIns="0" tIns="0" bIns="0">
+            <a:spAutoFit/>
+          </a:bodyPr>
+          <a:lstStyle/>
+          <a:p>
+            <a:pPr algn="ctr">
               <a:lnSpc>
                 <a:spcPct val="100000"/>
               </a:lnSpc>
@@ -4478,39 +4553,39 @@
                 <a:spcPts val="0"/>
               </a:spcBef>
               <a:spcAft>
-                <a:spcPts val="200"/>
+                <a:spcPts val="800"/>
               </a:spcAft>
             </a:pPr>
             <a:r>
-              <a:rPr sz="1150" b="0">
+              <a:rPr sz="1250" b="0">
                 <a:solidFill>
                   <a:srgbClr val="6B7482"/>
                 </a:solidFill>
                 <a:latin typeface="Calibri"/>
               </a:rPr>
-              <a:t>Programmiersprache der App</a:t>
-            </a:r>
-          </a:p>
-        </p:txBody>
-      </p:sp>
-      <p:sp>
-        <p:nvSpPr>
-          <p:cNvPr id="10" name="Rounded Rectangle 9"/>
+              <a:t>Benutzeroberfläche</a:t>
+            </a:r>
+          </a:p>
+        </p:txBody>
+      </p:sp>
+      <p:sp>
+        <p:nvSpPr>
+          <p:cNvPr id="13" name="Rounded Rectangle 12"/>
           <p:cNvSpPr/>
           <p:nvPr/>
         </p:nvSpPr>
         <p:spPr>
           <a:xfrm>
-            <a:off x="777240" y="3273552"/>
-            <a:ext cx="4937760" cy="731520"/>
+            <a:off x="8143036" y="1828800"/>
+            <a:ext cx="3271418" cy="2148840"/>
           </a:xfrm>
           <a:prstGeom prst="roundRect">
             <a:avLst>
-              <a:gd name="adj" fmla="val 10000"/>
+              <a:gd name="adj" fmla="val 6000"/>
             </a:avLst>
           </a:prstGeom>
           <a:solidFill>
-            <a:srgbClr val="F3F5F8"/>
+            <a:srgbClr val="F6F8FB"/>
           </a:solidFill>
           <a:ln w="12700">
             <a:solidFill>
@@ -4541,25 +4616,143 @@
           </a:p>
         </p:txBody>
       </p:sp>
-      <p:sp>
-        <p:nvSpPr>
-          <p:cNvPr id="11" name="Rectangle 10"/>
-          <p:cNvSpPr/>
+      <p:pic>
+        <p:nvPicPr>
+          <p:cNvPr id="14" name="Picture 13" descr="wifi.png"/>
+          <p:cNvPicPr>
+            <a:picLocks noChangeAspect="1"/>
+          </p:cNvPicPr>
           <p:nvPr/>
-        </p:nvSpPr>
-        <p:spPr>
-          <a:xfrm>
-            <a:off x="777240" y="3273552"/>
-            <a:ext cx="73152" cy="731520"/>
+        </p:nvPicPr>
+        <p:blipFill>
+          <a:blip r:embed="rId4"/>
+          <a:stretch>
+            <a:fillRect/>
+          </a:stretch>
+        </p:blipFill>
+        <p:spPr>
+          <a:xfrm>
+            <a:off x="9321546" y="2121408"/>
+            <a:ext cx="914400" cy="914400"/>
           </a:xfrm>
           <a:prstGeom prst="rect">
             <a:avLst/>
           </a:prstGeom>
+        </p:spPr>
+      </p:pic>
+      <p:sp>
+        <p:nvSpPr>
+          <p:cNvPr id="15" name="TextBox 14"/>
+          <p:cNvSpPr txBox="1"/>
+          <p:nvPr/>
+        </p:nvSpPr>
+        <p:spPr>
+          <a:xfrm>
+            <a:off x="8143036" y="3200400"/>
+            <a:ext cx="3271418" cy="457200"/>
+          </a:xfrm>
+          <a:prstGeom prst="rect">
+            <a:avLst/>
+          </a:prstGeom>
+          <a:noFill/>
+        </p:spPr>
+        <p:txBody>
+          <a:bodyPr wrap="square" anchor="t" lIns="0" rIns="0" tIns="0" bIns="0">
+            <a:spAutoFit/>
+          </a:bodyPr>
+          <a:lstStyle/>
+          <a:p>
+            <a:pPr algn="ctr">
+              <a:lnSpc>
+                <a:spcPct val="100000"/>
+              </a:lnSpc>
+              <a:spcBef>
+                <a:spcPts val="0"/>
+              </a:spcBef>
+              <a:spcAft>
+                <a:spcPts val="800"/>
+              </a:spcAft>
+            </a:pPr>
+            <a:r>
+              <a:rPr sz="1800" b="1">
+                <a:solidFill>
+                  <a:srgbClr val="103A50"/>
+                </a:solidFill>
+                <a:latin typeface="Calibri"/>
+              </a:rPr>
+              <a:t>WLAN</a:t>
+            </a:r>
+          </a:p>
+        </p:txBody>
+      </p:sp>
+      <p:sp>
+        <p:nvSpPr>
+          <p:cNvPr id="16" name="TextBox 15"/>
+          <p:cNvSpPr txBox="1"/>
+          <p:nvPr/>
+        </p:nvSpPr>
+        <p:spPr>
+          <a:xfrm>
+            <a:off x="8143036" y="3584448"/>
+            <a:ext cx="3271418" cy="365760"/>
+          </a:xfrm>
+          <a:prstGeom prst="rect">
+            <a:avLst/>
+          </a:prstGeom>
+          <a:noFill/>
+        </p:spPr>
+        <p:txBody>
+          <a:bodyPr wrap="square" anchor="t" lIns="0" rIns="0" tIns="0" bIns="0">
+            <a:spAutoFit/>
+          </a:bodyPr>
+          <a:lstStyle/>
+          <a:p>
+            <a:pPr algn="ctr">
+              <a:lnSpc>
+                <a:spcPct val="100000"/>
+              </a:lnSpc>
+              <a:spcBef>
+                <a:spcPts val="0"/>
+              </a:spcBef>
+              <a:spcAft>
+                <a:spcPts val="800"/>
+              </a:spcAft>
+            </a:pPr>
+            <a:r>
+              <a:rPr sz="1250" b="0">
+                <a:solidFill>
+                  <a:srgbClr val="6B7482"/>
+                </a:solidFill>
+                <a:latin typeface="Calibri"/>
+              </a:rPr>
+              <a:t>Findet die Drohne automatisch</a:t>
+            </a:r>
+          </a:p>
+        </p:txBody>
+      </p:sp>
+      <p:sp>
+        <p:nvSpPr>
+          <p:cNvPr id="17" name="Rounded Rectangle 16"/>
+          <p:cNvSpPr/>
+          <p:nvPr/>
+        </p:nvSpPr>
+        <p:spPr>
+          <a:xfrm>
+            <a:off x="777240" y="4233672"/>
+            <a:ext cx="3271418" cy="2148840"/>
+          </a:xfrm>
+          <a:prstGeom prst="roundRect">
+            <a:avLst>
+              <a:gd name="adj" fmla="val 6000"/>
+            </a:avLst>
+          </a:prstGeom>
           <a:solidFill>
-            <a:srgbClr val="103A50"/>
+            <a:srgbClr val="F6F8FB"/>
           </a:solidFill>
-          <a:ln>
-            <a:noFill/>
+          <a:ln w="12700">
+            <a:solidFill>
+              <a:srgbClr val="DDE1E7"/>
+            </a:solidFill>
           </a:ln>
           <a:effectLst/>
         </p:spPr>
@@ -4585,16 +4778,40 @@
           </a:p>
         </p:txBody>
       </p:sp>
-      <p:sp>
-        <p:nvSpPr>
-          <p:cNvPr id="12" name="TextBox 11"/>
+      <p:pic>
+        <p:nvPicPr>
+          <p:cNvPr id="18" name="Picture 17" descr="websocket.png"/>
+          <p:cNvPicPr>
+            <a:picLocks noChangeAspect="1"/>
+          </p:cNvPicPr>
+          <p:nvPr/>
+        </p:nvPicPr>
+        <p:blipFill>
+          <a:blip r:embed="rId5"/>
+          <a:stretch>
+            <a:fillRect/>
+          </a:stretch>
+        </p:blipFill>
+        <p:spPr>
+          <a:xfrm>
+            <a:off x="1955749" y="4526280"/>
+            <a:ext cx="914400" cy="914400"/>
+          </a:xfrm>
+          <a:prstGeom prst="rect">
+            <a:avLst/>
+          </a:prstGeom>
+        </p:spPr>
+      </p:pic>
+      <p:sp>
+        <p:nvSpPr>
+          <p:cNvPr id="19" name="TextBox 18"/>
           <p:cNvSpPr txBox="1"/>
           <p:nvPr/>
         </p:nvSpPr>
         <p:spPr>
           <a:xfrm>
-            <a:off x="1033272" y="3273552"/>
-            <a:ext cx="4553712" cy="731520"/>
+            <a:off x="777240" y="5605272"/>
+            <a:ext cx="3271418" cy="457200"/>
           </a:xfrm>
           <a:prstGeom prst="rect">
             <a:avLst/>
@@ -4602,12 +4819,12 @@
           <a:noFill/>
         </p:spPr>
         <p:txBody>
-          <a:bodyPr wrap="square" anchor="ctr" lIns="0" rIns="0" tIns="0" bIns="0">
+          <a:bodyPr wrap="square" anchor="t" lIns="0" rIns="0" tIns="0" bIns="0">
             <a:spAutoFit/>
           </a:bodyPr>
           <a:lstStyle/>
           <a:p>
-            <a:pPr algn="l">
+            <a:pPr algn="ctr">
               <a:lnSpc>
                 <a:spcPct val="100000"/>
               </a:lnSpc>
@@ -4615,21 +4832,44 @@
                 <a:spcPts val="0"/>
               </a:spcBef>
               <a:spcAft>
-                <a:spcPts val="200"/>
+                <a:spcPts val="800"/>
               </a:spcAft>
             </a:pPr>
             <a:r>
-              <a:rPr sz="1600" b="1">
+              <a:rPr sz="1800" b="1">
                 <a:solidFill>
                   <a:srgbClr val="103A50"/>
                 </a:solidFill>
                 <a:latin typeface="Calibri"/>
               </a:rPr>
-              <a:t>SwiftUI</a:t>
-            </a:r>
-          </a:p>
-          <a:p>
-            <a:pPr algn="l">
+              <a:t>WebSocket</a:t>
+            </a:r>
+          </a:p>
+        </p:txBody>
+      </p:sp>
+      <p:sp>
+        <p:nvSpPr>
+          <p:cNvPr id="20" name="TextBox 19"/>
+          <p:cNvSpPr txBox="1"/>
+          <p:nvPr/>
+        </p:nvSpPr>
+        <p:spPr>
+          <a:xfrm>
+            <a:off x="777240" y="5989320"/>
+            <a:ext cx="3271418" cy="365760"/>
+          </a:xfrm>
+          <a:prstGeom prst="rect">
+            <a:avLst/>
+          </a:prstGeom>
+          <a:noFill/>
+        </p:spPr>
+        <p:txBody>
+          <a:bodyPr wrap="square" anchor="t" lIns="0" rIns="0" tIns="0" bIns="0">
+            <a:spAutoFit/>
+          </a:bodyPr>
+          <a:lstStyle/>
+          <a:p>
+            <a:pPr algn="ctr">
               <a:lnSpc>
                 <a:spcPct val="100000"/>
               </a:lnSpc>
@@ -4637,39 +4877,39 @@
                 <a:spcPts val="0"/>
               </a:spcBef>
               <a:spcAft>
-                <a:spcPts val="200"/>
+                <a:spcPts val="800"/>
               </a:spcAft>
             </a:pPr>
             <a:r>
-              <a:rPr sz="1150" b="0">
+              <a:rPr sz="1250" b="0">
                 <a:solidFill>
                   <a:srgbClr val="6B7482"/>
                 </a:solidFill>
                 <a:latin typeface="Calibri"/>
               </a:rPr>
-              <a:t>Deklarative UI, Live-Bindings</a:t>
-            </a:r>
-          </a:p>
-        </p:txBody>
-      </p:sp>
-      <p:sp>
-        <p:nvSpPr>
-          <p:cNvPr id="13" name="Rounded Rectangle 12"/>
+              <a:t>Live-Verbindung zur Drohne</a:t>
+            </a:r>
+          </a:p>
+        </p:txBody>
+      </p:sp>
+      <p:sp>
+        <p:nvSpPr>
+          <p:cNvPr id="21" name="Rounded Rectangle 20"/>
           <p:cNvSpPr/>
           <p:nvPr/>
         </p:nvSpPr>
         <p:spPr>
           <a:xfrm>
-            <a:off x="777240" y="4123944"/>
-            <a:ext cx="4937760" cy="731520"/>
+            <a:off x="4460138" y="4233672"/>
+            <a:ext cx="3271418" cy="2148840"/>
           </a:xfrm>
           <a:prstGeom prst="roundRect">
             <a:avLst>
-              <a:gd name="adj" fmla="val 10000"/>
+              <a:gd name="adj" fmla="val 6000"/>
             </a:avLst>
           </a:prstGeom>
           <a:solidFill>
-            <a:srgbClr val="F3F5F8"/>
+            <a:srgbClr val="F6F8FB"/>
           </a:solidFill>
           <a:ln w="12700">
             <a:solidFill>
@@ -4700,25 +4940,143 @@
           </a:p>
         </p:txBody>
       </p:sp>
-      <p:sp>
-        <p:nvSpPr>
-          <p:cNvPr id="14" name="Rectangle 13"/>
-          <p:cNvSpPr/>
+      <p:pic>
+        <p:nvPicPr>
+          <p:cNvPr id="22" name="Picture 21" descr="cube3d.png"/>
+          <p:cNvPicPr>
+            <a:picLocks noChangeAspect="1"/>
+          </p:cNvPicPr>
           <p:nvPr/>
-        </p:nvSpPr>
-        <p:spPr>
-          <a:xfrm>
-            <a:off x="777240" y="4123944"/>
-            <a:ext cx="73152" cy="731520"/>
+        </p:nvPicPr>
+        <p:blipFill>
+          <a:blip r:embed="rId6"/>
+          <a:stretch>
+            <a:fillRect/>
+          </a:stretch>
+        </p:blipFill>
+        <p:spPr>
+          <a:xfrm>
+            <a:off x="5638647" y="4526280"/>
+            <a:ext cx="914400" cy="914400"/>
           </a:xfrm>
           <a:prstGeom prst="rect">
             <a:avLst/>
           </a:prstGeom>
+        </p:spPr>
+      </p:pic>
+      <p:sp>
+        <p:nvSpPr>
+          <p:cNvPr id="23" name="TextBox 22"/>
+          <p:cNvSpPr txBox="1"/>
+          <p:nvPr/>
+        </p:nvSpPr>
+        <p:spPr>
+          <a:xfrm>
+            <a:off x="4460138" y="5605272"/>
+            <a:ext cx="3271418" cy="457200"/>
+          </a:xfrm>
+          <a:prstGeom prst="rect">
+            <a:avLst/>
+          </a:prstGeom>
+          <a:noFill/>
+        </p:spPr>
+        <p:txBody>
+          <a:bodyPr wrap="square" anchor="t" lIns="0" rIns="0" tIns="0" bIns="0">
+            <a:spAutoFit/>
+          </a:bodyPr>
+          <a:lstStyle/>
+          <a:p>
+            <a:pPr algn="ctr">
+              <a:lnSpc>
+                <a:spcPct val="100000"/>
+              </a:lnSpc>
+              <a:spcBef>
+                <a:spcPts val="0"/>
+              </a:spcBef>
+              <a:spcAft>
+                <a:spcPts val="800"/>
+              </a:spcAft>
+            </a:pPr>
+            <a:r>
+              <a:rPr sz="1800" b="1">
+                <a:solidFill>
+                  <a:srgbClr val="103A50"/>
+                </a:solidFill>
+                <a:latin typeface="Calibri"/>
+              </a:rPr>
+              <a:t>3D-Simulator</a:t>
+            </a:r>
+          </a:p>
+        </p:txBody>
+      </p:sp>
+      <p:sp>
+        <p:nvSpPr>
+          <p:cNvPr id="24" name="TextBox 23"/>
+          <p:cNvSpPr txBox="1"/>
+          <p:nvPr/>
+        </p:nvSpPr>
+        <p:spPr>
+          <a:xfrm>
+            <a:off x="4460138" y="5989320"/>
+            <a:ext cx="3271418" cy="365760"/>
+          </a:xfrm>
+          <a:prstGeom prst="rect">
+            <a:avLst/>
+          </a:prstGeom>
+          <a:noFill/>
+        </p:spPr>
+        <p:txBody>
+          <a:bodyPr wrap="square" anchor="t" lIns="0" rIns="0" tIns="0" bIns="0">
+            <a:spAutoFit/>
+          </a:bodyPr>
+          <a:lstStyle/>
+          <a:p>
+            <a:pPr algn="ctr">
+              <a:lnSpc>
+                <a:spcPct val="100000"/>
+              </a:lnSpc>
+              <a:spcBef>
+                <a:spcPts val="0"/>
+              </a:spcBef>
+              <a:spcAft>
+                <a:spcPts val="800"/>
+              </a:spcAft>
+            </a:pPr>
+            <a:r>
+              <a:rPr sz="1250" b="0">
+                <a:solidFill>
+                  <a:srgbClr val="6B7482"/>
+                </a:solidFill>
+                <a:latin typeface="Calibri"/>
+              </a:rPr>
+              <a:t>Flugsimulator am iPhone</a:t>
+            </a:r>
+          </a:p>
+        </p:txBody>
+      </p:sp>
+      <p:sp>
+        <p:nvSpPr>
+          <p:cNvPr id="25" name="Rounded Rectangle 24"/>
+          <p:cNvSpPr/>
+          <p:nvPr/>
+        </p:nvSpPr>
+        <p:spPr>
+          <a:xfrm>
+            <a:off x="8143036" y="4233672"/>
+            <a:ext cx="3271418" cy="2148840"/>
+          </a:xfrm>
+          <a:prstGeom prst="roundRect">
+            <a:avLst>
+              <a:gd name="adj" fmla="val 6000"/>
+            </a:avLst>
+          </a:prstGeom>
           <a:solidFill>
-            <a:srgbClr val="103A50"/>
+            <a:srgbClr val="F6F8FB"/>
           </a:solidFill>
-          <a:ln>
-            <a:noFill/>
+          <a:ln w="12700">
+            <a:solidFill>
+              <a:srgbClr val="DDE1E7"/>
+            </a:solidFill>
           </a:ln>
           <a:effectLst/>
         </p:spPr>
@@ -4744,16 +5102,40 @@
           </a:p>
         </p:txBody>
       </p:sp>
-      <p:sp>
-        <p:nvSpPr>
-          <p:cNvPr id="15" name="TextBox 14"/>
+      <p:pic>
+        <p:nvPicPr>
+          <p:cNvPr id="26" name="Picture 25" descr="chip.png"/>
+          <p:cNvPicPr>
+            <a:picLocks noChangeAspect="1"/>
+          </p:cNvPicPr>
+          <p:nvPr/>
+        </p:nvPicPr>
+        <p:blipFill>
+          <a:blip r:embed="rId7"/>
+          <a:stretch>
+            <a:fillRect/>
+          </a:stretch>
+        </p:blipFill>
+        <p:spPr>
+          <a:xfrm>
+            <a:off x="9321546" y="4526280"/>
+            <a:ext cx="914400" cy="914400"/>
+          </a:xfrm>
+          <a:prstGeom prst="rect">
+            <a:avLst/>
+          </a:prstGeom>
+        </p:spPr>
+      </p:pic>
+      <p:sp>
+        <p:nvSpPr>
+          <p:cNvPr id="27" name="TextBox 26"/>
           <p:cNvSpPr txBox="1"/>
           <p:nvPr/>
         </p:nvSpPr>
         <p:spPr>
           <a:xfrm>
-            <a:off x="1033272" y="4123944"/>
-            <a:ext cx="4553712" cy="731520"/>
+            <a:off x="8143036" y="5605272"/>
+            <a:ext cx="3271418" cy="457200"/>
           </a:xfrm>
           <a:prstGeom prst="rect">
             <a:avLst/>
@@ -4761,12 +5143,12 @@
           <a:noFill/>
         </p:spPr>
         <p:txBody>
-          <a:bodyPr wrap="square" anchor="ctr" lIns="0" rIns="0" tIns="0" bIns="0">
+          <a:bodyPr wrap="square" anchor="t" lIns="0" rIns="0" tIns="0" bIns="0">
             <a:spAutoFit/>
           </a:bodyPr>
           <a:lstStyle/>
           <a:p>
-            <a:pPr algn="l">
+            <a:pPr algn="ctr">
               <a:lnSpc>
                 <a:spcPct val="100000"/>
               </a:lnSpc>
@@ -4774,21 +5156,44 @@
                 <a:spcPts val="0"/>
               </a:spcBef>
               <a:spcAft>
-                <a:spcPts val="200"/>
+                <a:spcPts val="800"/>
               </a:spcAft>
             </a:pPr>
             <a:r>
-              <a:rPr sz="1600" b="1">
+              <a:rPr sz="1800" b="1">
                 <a:solidFill>
                   <a:srgbClr val="103A50"/>
                 </a:solidFill>
                 <a:latin typeface="Calibri"/>
               </a:rPr>
-              <a:t>Network.framework</a:t>
-            </a:r>
-          </a:p>
-          <a:p>
-            <a:pPr algn="l">
+              <a:t>ESP32</a:t>
+            </a:r>
+          </a:p>
+        </p:txBody>
+      </p:sp>
+      <p:sp>
+        <p:nvSpPr>
+          <p:cNvPr id="28" name="TextBox 27"/>
+          <p:cNvSpPr txBox="1"/>
+          <p:nvPr/>
+        </p:nvSpPr>
+        <p:spPr>
+          <a:xfrm>
+            <a:off x="8143036" y="5989320"/>
+            <a:ext cx="3271418" cy="365760"/>
+          </a:xfrm>
+          <a:prstGeom prst="rect">
+            <a:avLst/>
+          </a:prstGeom>
+          <a:noFill/>
+        </p:spPr>
+        <p:txBody>
+          <a:bodyPr wrap="square" anchor="t" lIns="0" rIns="0" tIns="0" bIns="0">
+            <a:spAutoFit/>
+          </a:bodyPr>
+          <a:lstStyle/>
+          <a:p>
+            <a:pPr algn="ctr">
               <a:lnSpc>
                 <a:spcPct val="100000"/>
               </a:lnSpc>
@@ -4796,971 +5201,17 @@
                 <a:spcPts val="0"/>
               </a:spcBef>
               <a:spcAft>
-                <a:spcPts val="200"/>
+                <a:spcPts val="800"/>
               </a:spcAft>
             </a:pPr>
             <a:r>
-              <a:rPr sz="1150" b="0">
+              <a:rPr sz="1250" b="0">
                 <a:solidFill>
                   <a:srgbClr val="6B7482"/>
                 </a:solidFill>
                 <a:latin typeface="Calibri"/>
               </a:rPr>
-              <a:t>UDP-Discovery + WebSocket</a:t>
-            </a:r>
-          </a:p>
-        </p:txBody>
-      </p:sp>
-      <p:sp>
-        <p:nvSpPr>
-          <p:cNvPr id="16" name="Rounded Rectangle 15"/>
-          <p:cNvSpPr/>
-          <p:nvPr/>
-        </p:nvSpPr>
-        <p:spPr>
-          <a:xfrm>
-            <a:off x="777240" y="4974336"/>
-            <a:ext cx="4937760" cy="731520"/>
-          </a:xfrm>
-          <a:prstGeom prst="roundRect">
-            <a:avLst>
-              <a:gd name="adj" fmla="val 10000"/>
-            </a:avLst>
-          </a:prstGeom>
-          <a:solidFill>
-            <a:srgbClr val="F3F5F8"/>
-          </a:solidFill>
-          <a:ln w="12700">
-            <a:solidFill>
-              <a:srgbClr val="DDE1E7"/>
-            </a:solidFill>
-          </a:ln>
-          <a:effectLst/>
-        </p:spPr>
-        <p:style>
-          <a:lnRef idx="1">
-            <a:schemeClr val="accent1"/>
-          </a:lnRef>
-          <a:fillRef idx="3">
-            <a:schemeClr val="accent1"/>
-          </a:fillRef>
-          <a:effectRef idx="2">
-            <a:schemeClr val="accent1"/>
-          </a:effectRef>
-          <a:fontRef idx="minor">
-            <a:schemeClr val="lt1"/>
-          </a:fontRef>
-        </p:style>
-        <p:txBody>
-          <a:bodyPr rtlCol="0" anchor="ctr"/>
-          <a:lstStyle/>
-          <a:p>
-            <a:pPr algn="ctr"/>
-          </a:p>
-        </p:txBody>
-      </p:sp>
-      <p:sp>
-        <p:nvSpPr>
-          <p:cNvPr id="17" name="Rectangle 16"/>
-          <p:cNvSpPr/>
-          <p:nvPr/>
-        </p:nvSpPr>
-        <p:spPr>
-          <a:xfrm>
-            <a:off x="777240" y="4974336"/>
-            <a:ext cx="73152" cy="731520"/>
-          </a:xfrm>
-          <a:prstGeom prst="rect">
-            <a:avLst/>
-          </a:prstGeom>
-          <a:solidFill>
-            <a:srgbClr val="103A50"/>
-          </a:solidFill>
-          <a:ln>
-            <a:noFill/>
-          </a:ln>
-          <a:effectLst/>
-        </p:spPr>
-        <p:style>
-          <a:lnRef idx="1">
-            <a:schemeClr val="accent1"/>
-          </a:lnRef>
-          <a:fillRef idx="3">
-            <a:schemeClr val="accent1"/>
-          </a:fillRef>
-          <a:effectRef idx="2">
-            <a:schemeClr val="accent1"/>
-          </a:effectRef>
-          <a:fontRef idx="minor">
-            <a:schemeClr val="lt1"/>
-          </a:fontRef>
-        </p:style>
-        <p:txBody>
-          <a:bodyPr rtlCol="0" anchor="ctr"/>
-          <a:lstStyle/>
-          <a:p>
-            <a:pPr algn="ctr"/>
-          </a:p>
-        </p:txBody>
-      </p:sp>
-      <p:sp>
-        <p:nvSpPr>
-          <p:cNvPr id="18" name="TextBox 17"/>
-          <p:cNvSpPr txBox="1"/>
-          <p:nvPr/>
-        </p:nvSpPr>
-        <p:spPr>
-          <a:xfrm>
-            <a:off x="1033272" y="4974336"/>
-            <a:ext cx="4553712" cy="731520"/>
-          </a:xfrm>
-          <a:prstGeom prst="rect">
-            <a:avLst/>
-          </a:prstGeom>
-          <a:noFill/>
-        </p:spPr>
-        <p:txBody>
-          <a:bodyPr wrap="square" anchor="ctr" lIns="0" rIns="0" tIns="0" bIns="0">
-            <a:spAutoFit/>
-          </a:bodyPr>
-          <a:lstStyle/>
-          <a:p>
-            <a:pPr algn="l">
-              <a:lnSpc>
-                <a:spcPct val="100000"/>
-              </a:lnSpc>
-              <a:spcBef>
-                <a:spcPts val="0"/>
-              </a:spcBef>
-              <a:spcAft>
-                <a:spcPts val="200"/>
-              </a:spcAft>
-            </a:pPr>
-            <a:r>
-              <a:rPr sz="1600" b="1">
-                <a:solidFill>
-                  <a:srgbClr val="103A50"/>
-                </a:solidFill>
-                <a:latin typeface="Calibri"/>
-              </a:rPr>
-              <a:t>SceneKit</a:t>
-            </a:r>
-          </a:p>
-          <a:p>
-            <a:pPr algn="l">
-              <a:lnSpc>
-                <a:spcPct val="100000"/>
-              </a:lnSpc>
-              <a:spcBef>
-                <a:spcPts val="0"/>
-              </a:spcBef>
-              <a:spcAft>
-                <a:spcPts val="200"/>
-              </a:spcAft>
-            </a:pPr>
-            <a:r>
-              <a:rPr sz="1150" b="0">
-                <a:solidFill>
-                  <a:srgbClr val="6B7482"/>
-                </a:solidFill>
-                <a:latin typeface="Calibri"/>
-              </a:rPr>
-              <a:t>3D-Flugsimulator (.usdz-Modell)</a:t>
-            </a:r>
-          </a:p>
-        </p:txBody>
-      </p:sp>
-      <p:sp>
-        <p:nvSpPr>
-          <p:cNvPr id="19" name="Rounded Rectangle 18"/>
-          <p:cNvSpPr/>
-          <p:nvPr/>
-        </p:nvSpPr>
-        <p:spPr>
-          <a:xfrm>
-            <a:off x="777240" y="5824728"/>
-            <a:ext cx="4937760" cy="731520"/>
-          </a:xfrm>
-          <a:prstGeom prst="roundRect">
-            <a:avLst>
-              <a:gd name="adj" fmla="val 10000"/>
-            </a:avLst>
-          </a:prstGeom>
-          <a:solidFill>
-            <a:srgbClr val="F3F5F8"/>
-          </a:solidFill>
-          <a:ln w="12700">
-            <a:solidFill>
-              <a:srgbClr val="DDE1E7"/>
-            </a:solidFill>
-          </a:ln>
-          <a:effectLst/>
-        </p:spPr>
-        <p:style>
-          <a:lnRef idx="1">
-            <a:schemeClr val="accent1"/>
-          </a:lnRef>
-          <a:fillRef idx="3">
-            <a:schemeClr val="accent1"/>
-          </a:fillRef>
-          <a:effectRef idx="2">
-            <a:schemeClr val="accent1"/>
-          </a:effectRef>
-          <a:fontRef idx="minor">
-            <a:schemeClr val="lt1"/>
-          </a:fontRef>
-        </p:style>
-        <p:txBody>
-          <a:bodyPr rtlCol="0" anchor="ctr"/>
-          <a:lstStyle/>
-          <a:p>
-            <a:pPr algn="ctr"/>
-          </a:p>
-        </p:txBody>
-      </p:sp>
-      <p:sp>
-        <p:nvSpPr>
-          <p:cNvPr id="20" name="Rectangle 19"/>
-          <p:cNvSpPr/>
-          <p:nvPr/>
-        </p:nvSpPr>
-        <p:spPr>
-          <a:xfrm>
-            <a:off x="777240" y="5824728"/>
-            <a:ext cx="73152" cy="731520"/>
-          </a:xfrm>
-          <a:prstGeom prst="rect">
-            <a:avLst/>
-          </a:prstGeom>
-          <a:solidFill>
-            <a:srgbClr val="103A50"/>
-          </a:solidFill>
-          <a:ln>
-            <a:noFill/>
-          </a:ln>
-          <a:effectLst/>
-        </p:spPr>
-        <p:style>
-          <a:lnRef idx="1">
-            <a:schemeClr val="accent1"/>
-          </a:lnRef>
-          <a:fillRef idx="3">
-            <a:schemeClr val="accent1"/>
-          </a:fillRef>
-          <a:effectRef idx="2">
-            <a:schemeClr val="accent1"/>
-          </a:effectRef>
-          <a:fontRef idx="minor">
-            <a:schemeClr val="lt1"/>
-          </a:fontRef>
-        </p:style>
-        <p:txBody>
-          <a:bodyPr rtlCol="0" anchor="ctr"/>
-          <a:lstStyle/>
-          <a:p>
-            <a:pPr algn="ctr"/>
-          </a:p>
-        </p:txBody>
-      </p:sp>
-      <p:sp>
-        <p:nvSpPr>
-          <p:cNvPr id="21" name="TextBox 20"/>
-          <p:cNvSpPr txBox="1"/>
-          <p:nvPr/>
-        </p:nvSpPr>
-        <p:spPr>
-          <a:xfrm>
-            <a:off x="1033272" y="5824728"/>
-            <a:ext cx="4553712" cy="731520"/>
-          </a:xfrm>
-          <a:prstGeom prst="rect">
-            <a:avLst/>
-          </a:prstGeom>
-          <a:noFill/>
-        </p:spPr>
-        <p:txBody>
-          <a:bodyPr wrap="square" anchor="ctr" lIns="0" rIns="0" tIns="0" bIns="0">
-            <a:spAutoFit/>
-          </a:bodyPr>
-          <a:lstStyle/>
-          <a:p>
-            <a:pPr algn="l">
-              <a:lnSpc>
-                <a:spcPct val="100000"/>
-              </a:lnSpc>
-              <a:spcBef>
-                <a:spcPts val="0"/>
-              </a:spcBef>
-              <a:spcAft>
-                <a:spcPts val="200"/>
-              </a:spcAft>
-            </a:pPr>
-            <a:r>
-              <a:rPr sz="1600" b="1">
-                <a:solidFill>
-                  <a:srgbClr val="103A50"/>
-                </a:solidFill>
-                <a:latin typeface="Calibri"/>
-              </a:rPr>
-              <a:t>CoreMotion</a:t>
-            </a:r>
-          </a:p>
-          <a:p>
-            <a:pPr algn="l">
-              <a:lnSpc>
-                <a:spcPct val="100000"/>
-              </a:lnSpc>
-              <a:spcBef>
-                <a:spcPts val="0"/>
-              </a:spcBef>
-              <a:spcAft>
-                <a:spcPts val="200"/>
-              </a:spcAft>
-            </a:pPr>
-            <a:r>
-              <a:rPr sz="1150" b="0">
-                <a:solidFill>
-                  <a:srgbClr val="6B7482"/>
-                </a:solidFill>
-                <a:latin typeface="Calibri"/>
-              </a:rPr>
-              <a:t>Gyro/Beschleunigung @ 10 Hz</a:t>
-            </a:r>
-          </a:p>
-        </p:txBody>
-      </p:sp>
-      <p:sp>
-        <p:nvSpPr>
-          <p:cNvPr id="22" name="Rounded Rectangle 21"/>
-          <p:cNvSpPr/>
-          <p:nvPr/>
-        </p:nvSpPr>
-        <p:spPr>
-          <a:xfrm>
-            <a:off x="6766560" y="2423160"/>
-            <a:ext cx="4937760" cy="731520"/>
-          </a:xfrm>
-          <a:prstGeom prst="roundRect">
-            <a:avLst>
-              <a:gd name="adj" fmla="val 10000"/>
-            </a:avLst>
-          </a:prstGeom>
-          <a:solidFill>
-            <a:srgbClr val="F3F5F8"/>
-          </a:solidFill>
-          <a:ln w="12700">
-            <a:solidFill>
-              <a:srgbClr val="DDE1E7"/>
-            </a:solidFill>
-          </a:ln>
-          <a:effectLst/>
-        </p:spPr>
-        <p:style>
-          <a:lnRef idx="1">
-            <a:schemeClr val="accent1"/>
-          </a:lnRef>
-          <a:fillRef idx="3">
-            <a:schemeClr val="accent1"/>
-          </a:fillRef>
-          <a:effectRef idx="2">
-            <a:schemeClr val="accent1"/>
-          </a:effectRef>
-          <a:fontRef idx="minor">
-            <a:schemeClr val="lt1"/>
-          </a:fontRef>
-        </p:style>
-        <p:txBody>
-          <a:bodyPr rtlCol="0" anchor="ctr"/>
-          <a:lstStyle/>
-          <a:p>
-            <a:pPr algn="ctr"/>
-          </a:p>
-        </p:txBody>
-      </p:sp>
-      <p:sp>
-        <p:nvSpPr>
-          <p:cNvPr id="23" name="Rectangle 22"/>
-          <p:cNvSpPr/>
-          <p:nvPr/>
-        </p:nvSpPr>
-        <p:spPr>
-          <a:xfrm>
-            <a:off x="6766560" y="2423160"/>
-            <a:ext cx="73152" cy="731520"/>
-          </a:xfrm>
-          <a:prstGeom prst="rect">
-            <a:avLst/>
-          </a:prstGeom>
-          <a:solidFill>
-            <a:srgbClr val="C9B79C"/>
-          </a:solidFill>
-          <a:ln>
-            <a:noFill/>
-          </a:ln>
-          <a:effectLst/>
-        </p:spPr>
-        <p:style>
-          <a:lnRef idx="1">
-            <a:schemeClr val="accent1"/>
-          </a:lnRef>
-          <a:fillRef idx="3">
-            <a:schemeClr val="accent1"/>
-          </a:fillRef>
-          <a:effectRef idx="2">
-            <a:schemeClr val="accent1"/>
-          </a:effectRef>
-          <a:fontRef idx="minor">
-            <a:schemeClr val="lt1"/>
-          </a:fontRef>
-        </p:style>
-        <p:txBody>
-          <a:bodyPr rtlCol="0" anchor="ctr"/>
-          <a:lstStyle/>
-          <a:p>
-            <a:pPr algn="ctr"/>
-          </a:p>
-        </p:txBody>
-      </p:sp>
-      <p:sp>
-        <p:nvSpPr>
-          <p:cNvPr id="24" name="TextBox 23"/>
-          <p:cNvSpPr txBox="1"/>
-          <p:nvPr/>
-        </p:nvSpPr>
-        <p:spPr>
-          <a:xfrm>
-            <a:off x="7022592" y="2423160"/>
-            <a:ext cx="4553712" cy="731520"/>
-          </a:xfrm>
-          <a:prstGeom prst="rect">
-            <a:avLst/>
-          </a:prstGeom>
-          <a:noFill/>
-        </p:spPr>
-        <p:txBody>
-          <a:bodyPr wrap="square" anchor="ctr" lIns="0" rIns="0" tIns="0" bIns="0">
-            <a:spAutoFit/>
-          </a:bodyPr>
-          <a:lstStyle/>
-          <a:p>
-            <a:pPr algn="l">
-              <a:lnSpc>
-                <a:spcPct val="100000"/>
-              </a:lnSpc>
-              <a:spcBef>
-                <a:spcPts val="0"/>
-              </a:spcBef>
-              <a:spcAft>
-                <a:spcPts val="200"/>
-              </a:spcAft>
-            </a:pPr>
-            <a:r>
-              <a:rPr sz="1600" b="1">
-                <a:solidFill>
-                  <a:srgbClr val="103A50"/>
-                </a:solidFill>
-                <a:latin typeface="Calibri"/>
-              </a:rPr>
-              <a:t>ESP32-C3</a:t>
-            </a:r>
-          </a:p>
-          <a:p>
-            <a:pPr algn="l">
-              <a:lnSpc>
-                <a:spcPct val="100000"/>
-              </a:lnSpc>
-              <a:spcBef>
-                <a:spcPts val="0"/>
-              </a:spcBef>
-              <a:spcAft>
-                <a:spcPts val="200"/>
-              </a:spcAft>
-            </a:pPr>
-            <a:r>
-              <a:rPr sz="1150" b="0">
-                <a:solidFill>
-                  <a:srgbClr val="6B7482"/>
-                </a:solidFill>
-                <a:latin typeface="Calibri"/>
-              </a:rPr>
-              <a:t>WLAN-Mikrocontroller der Drohne</a:t>
-            </a:r>
-          </a:p>
-        </p:txBody>
-      </p:sp>
-      <p:sp>
-        <p:nvSpPr>
-          <p:cNvPr id="25" name="Rounded Rectangle 24"/>
-          <p:cNvSpPr/>
-          <p:nvPr/>
-        </p:nvSpPr>
-        <p:spPr>
-          <a:xfrm>
-            <a:off x="6766560" y="3273552"/>
-            <a:ext cx="4937760" cy="731520"/>
-          </a:xfrm>
-          <a:prstGeom prst="roundRect">
-            <a:avLst>
-              <a:gd name="adj" fmla="val 10000"/>
-            </a:avLst>
-          </a:prstGeom>
-          <a:solidFill>
-            <a:srgbClr val="F3F5F8"/>
-          </a:solidFill>
-          <a:ln w="12700">
-            <a:solidFill>
-              <a:srgbClr val="DDE1E7"/>
-            </a:solidFill>
-          </a:ln>
-          <a:effectLst/>
-        </p:spPr>
-        <p:style>
-          <a:lnRef idx="1">
-            <a:schemeClr val="accent1"/>
-          </a:lnRef>
-          <a:fillRef idx="3">
-            <a:schemeClr val="accent1"/>
-          </a:fillRef>
-          <a:effectRef idx="2">
-            <a:schemeClr val="accent1"/>
-          </a:effectRef>
-          <a:fontRef idx="minor">
-            <a:schemeClr val="lt1"/>
-          </a:fontRef>
-        </p:style>
-        <p:txBody>
-          <a:bodyPr rtlCol="0" anchor="ctr"/>
-          <a:lstStyle/>
-          <a:p>
-            <a:pPr algn="ctr"/>
-          </a:p>
-        </p:txBody>
-      </p:sp>
-      <p:sp>
-        <p:nvSpPr>
-          <p:cNvPr id="26" name="Rectangle 25"/>
-          <p:cNvSpPr/>
-          <p:nvPr/>
-        </p:nvSpPr>
-        <p:spPr>
-          <a:xfrm>
-            <a:off x="6766560" y="3273552"/>
-            <a:ext cx="73152" cy="731520"/>
-          </a:xfrm>
-          <a:prstGeom prst="rect">
-            <a:avLst/>
-          </a:prstGeom>
-          <a:solidFill>
-            <a:srgbClr val="C9B79C"/>
-          </a:solidFill>
-          <a:ln>
-            <a:noFill/>
-          </a:ln>
-          <a:effectLst/>
-        </p:spPr>
-        <p:style>
-          <a:lnRef idx="1">
-            <a:schemeClr val="accent1"/>
-          </a:lnRef>
-          <a:fillRef idx="3">
-            <a:schemeClr val="accent1"/>
-          </a:fillRef>
-          <a:effectRef idx="2">
-            <a:schemeClr val="accent1"/>
-          </a:effectRef>
-          <a:fontRef idx="minor">
-            <a:schemeClr val="lt1"/>
-          </a:fontRef>
-        </p:style>
-        <p:txBody>
-          <a:bodyPr rtlCol="0" anchor="ctr"/>
-          <a:lstStyle/>
-          <a:p>
-            <a:pPr algn="ctr"/>
-          </a:p>
-        </p:txBody>
-      </p:sp>
-      <p:sp>
-        <p:nvSpPr>
-          <p:cNvPr id="27" name="TextBox 26"/>
-          <p:cNvSpPr txBox="1"/>
-          <p:nvPr/>
-        </p:nvSpPr>
-        <p:spPr>
-          <a:xfrm>
-            <a:off x="7022592" y="3273552"/>
-            <a:ext cx="4553712" cy="731520"/>
-          </a:xfrm>
-          <a:prstGeom prst="rect">
-            <a:avLst/>
-          </a:prstGeom>
-          <a:noFill/>
-        </p:spPr>
-        <p:txBody>
-          <a:bodyPr wrap="square" anchor="ctr" lIns="0" rIns="0" tIns="0" bIns="0">
-            <a:spAutoFit/>
-          </a:bodyPr>
-          <a:lstStyle/>
-          <a:p>
-            <a:pPr algn="l">
-              <a:lnSpc>
-                <a:spcPct val="100000"/>
-              </a:lnSpc>
-              <a:spcBef>
-                <a:spcPts val="0"/>
-              </a:spcBef>
-              <a:spcAft>
-                <a:spcPts val="200"/>
-              </a:spcAft>
-            </a:pPr>
-            <a:r>
-              <a:rPr sz="1600" b="1">
-                <a:solidFill>
-                  <a:srgbClr val="103A50"/>
-                </a:solidFill>
-                <a:latin typeface="Calibri"/>
-              </a:rPr>
-              <a:t>WebSocket-Server</a:t>
-            </a:r>
-          </a:p>
-          <a:p>
-            <a:pPr algn="l">
-              <a:lnSpc>
-                <a:spcPct val="100000"/>
-              </a:lnSpc>
-              <a:spcBef>
-                <a:spcPts val="0"/>
-              </a:spcBef>
-              <a:spcAft>
-                <a:spcPts val="200"/>
-              </a:spcAft>
-            </a:pPr>
-            <a:r>
-              <a:rPr sz="1150" b="0">
-                <a:solidFill>
-                  <a:srgbClr val="6B7482"/>
-                </a:solidFill>
-                <a:latin typeface="Calibri"/>
-              </a:rPr>
-              <a:t>Befehle + Telemetrie, Port 81</a:t>
-            </a:r>
-          </a:p>
-        </p:txBody>
-      </p:sp>
-      <p:sp>
-        <p:nvSpPr>
-          <p:cNvPr id="28" name="Rounded Rectangle 27"/>
-          <p:cNvSpPr/>
-          <p:nvPr/>
-        </p:nvSpPr>
-        <p:spPr>
-          <a:xfrm>
-            <a:off x="6766560" y="4123944"/>
-            <a:ext cx="4937760" cy="731520"/>
-          </a:xfrm>
-          <a:prstGeom prst="roundRect">
-            <a:avLst>
-              <a:gd name="adj" fmla="val 10000"/>
-            </a:avLst>
-          </a:prstGeom>
-          <a:solidFill>
-            <a:srgbClr val="F3F5F8"/>
-          </a:solidFill>
-          <a:ln w="12700">
-            <a:solidFill>
-              <a:srgbClr val="DDE1E7"/>
-            </a:solidFill>
-          </a:ln>
-          <a:effectLst/>
-        </p:spPr>
-        <p:style>
-          <a:lnRef idx="1">
-            <a:schemeClr val="accent1"/>
-          </a:lnRef>
-          <a:fillRef idx="3">
-            <a:schemeClr val="accent1"/>
-          </a:fillRef>
-          <a:effectRef idx="2">
-            <a:schemeClr val="accent1"/>
-          </a:effectRef>
-          <a:fontRef idx="minor">
-            <a:schemeClr val="lt1"/>
-          </a:fontRef>
-        </p:style>
-        <p:txBody>
-          <a:bodyPr rtlCol="0" anchor="ctr"/>
-          <a:lstStyle/>
-          <a:p>
-            <a:pPr algn="ctr"/>
-          </a:p>
-        </p:txBody>
-      </p:sp>
-      <p:sp>
-        <p:nvSpPr>
-          <p:cNvPr id="29" name="Rectangle 28"/>
-          <p:cNvSpPr/>
-          <p:nvPr/>
-        </p:nvSpPr>
-        <p:spPr>
-          <a:xfrm>
-            <a:off x="6766560" y="4123944"/>
-            <a:ext cx="73152" cy="731520"/>
-          </a:xfrm>
-          <a:prstGeom prst="rect">
-            <a:avLst/>
-          </a:prstGeom>
-          <a:solidFill>
-            <a:srgbClr val="C9B79C"/>
-          </a:solidFill>
-          <a:ln>
-            <a:noFill/>
-          </a:ln>
-          <a:effectLst/>
-        </p:spPr>
-        <p:style>
-          <a:lnRef idx="1">
-            <a:schemeClr val="accent1"/>
-          </a:lnRef>
-          <a:fillRef idx="3">
-            <a:schemeClr val="accent1"/>
-          </a:fillRef>
-          <a:effectRef idx="2">
-            <a:schemeClr val="accent1"/>
-          </a:effectRef>
-          <a:fontRef idx="minor">
-            <a:schemeClr val="lt1"/>
-          </a:fontRef>
-        </p:style>
-        <p:txBody>
-          <a:bodyPr rtlCol="0" anchor="ctr"/>
-          <a:lstStyle/>
-          <a:p>
-            <a:pPr algn="ctr"/>
-          </a:p>
-        </p:txBody>
-      </p:sp>
-      <p:sp>
-        <p:nvSpPr>
-          <p:cNvPr id="30" name="TextBox 29"/>
-          <p:cNvSpPr txBox="1"/>
-          <p:nvPr/>
-        </p:nvSpPr>
-        <p:spPr>
-          <a:xfrm>
-            <a:off x="7022592" y="4123944"/>
-            <a:ext cx="4553712" cy="731520"/>
-          </a:xfrm>
-          <a:prstGeom prst="rect">
-            <a:avLst/>
-          </a:prstGeom>
-          <a:noFill/>
-        </p:spPr>
-        <p:txBody>
-          <a:bodyPr wrap="square" anchor="ctr" lIns="0" rIns="0" tIns="0" bIns="0">
-            <a:spAutoFit/>
-          </a:bodyPr>
-          <a:lstStyle/>
-          <a:p>
-            <a:pPr algn="l">
-              <a:lnSpc>
-                <a:spcPct val="100000"/>
-              </a:lnSpc>
-              <a:spcBef>
-                <a:spcPts val="0"/>
-              </a:spcBef>
-              <a:spcAft>
-                <a:spcPts val="200"/>
-              </a:spcAft>
-            </a:pPr>
-            <a:r>
-              <a:rPr sz="1600" b="1">
-                <a:solidFill>
-                  <a:srgbClr val="103A50"/>
-                </a:solidFill>
-                <a:latin typeface="Calibri"/>
-              </a:rPr>
-              <a:t>UDP-Beacon</a:t>
-            </a:r>
-          </a:p>
-          <a:p>
-            <a:pPr algn="l">
-              <a:lnSpc>
-                <a:spcPct val="100000"/>
-              </a:lnSpc>
-              <a:spcBef>
-                <a:spcPts val="0"/>
-              </a:spcBef>
-              <a:spcAft>
-                <a:spcPts val="200"/>
-              </a:spcAft>
-            </a:pPr>
-            <a:r>
-              <a:rPr sz="1150" b="0">
-                <a:solidFill>
-                  <a:srgbClr val="6B7482"/>
-                </a:solidFill>
-                <a:latin typeface="Calibri"/>
-              </a:rPr>
-              <a:t>"EASYPILOT:&lt;IP&gt;" · Port 4242</a:t>
-            </a:r>
-          </a:p>
-        </p:txBody>
-      </p:sp>
-      <p:sp>
-        <p:nvSpPr>
-          <p:cNvPr id="31" name="Rounded Rectangle 30"/>
-          <p:cNvSpPr/>
-          <p:nvPr/>
-        </p:nvSpPr>
-        <p:spPr>
-          <a:xfrm>
-            <a:off x="6766560" y="4974336"/>
-            <a:ext cx="4937760" cy="731520"/>
-          </a:xfrm>
-          <a:prstGeom prst="roundRect">
-            <a:avLst>
-              <a:gd name="adj" fmla="val 10000"/>
-            </a:avLst>
-          </a:prstGeom>
-          <a:solidFill>
-            <a:srgbClr val="F3F5F8"/>
-          </a:solidFill>
-          <a:ln w="12700">
-            <a:solidFill>
-              <a:srgbClr val="DDE1E7"/>
-            </a:solidFill>
-          </a:ln>
-          <a:effectLst/>
-        </p:spPr>
-        <p:style>
-          <a:lnRef idx="1">
-            <a:schemeClr val="accent1"/>
-          </a:lnRef>
-          <a:fillRef idx="3">
-            <a:schemeClr val="accent1"/>
-          </a:fillRef>
-          <a:effectRef idx="2">
-            <a:schemeClr val="accent1"/>
-          </a:effectRef>
-          <a:fontRef idx="minor">
-            <a:schemeClr val="lt1"/>
-          </a:fontRef>
-        </p:style>
-        <p:txBody>
-          <a:bodyPr rtlCol="0" anchor="ctr"/>
-          <a:lstStyle/>
-          <a:p>
-            <a:pPr algn="ctr"/>
-          </a:p>
-        </p:txBody>
-      </p:sp>
-      <p:sp>
-        <p:nvSpPr>
-          <p:cNvPr id="32" name="Rectangle 31"/>
-          <p:cNvSpPr/>
-          <p:nvPr/>
-        </p:nvSpPr>
-        <p:spPr>
-          <a:xfrm>
-            <a:off x="6766560" y="4974336"/>
-            <a:ext cx="73152" cy="731520"/>
-          </a:xfrm>
-          <a:prstGeom prst="rect">
-            <a:avLst/>
-          </a:prstGeom>
-          <a:solidFill>
-            <a:srgbClr val="C9B79C"/>
-          </a:solidFill>
-          <a:ln>
-            <a:noFill/>
-          </a:ln>
-          <a:effectLst/>
-        </p:spPr>
-        <p:style>
-          <a:lnRef idx="1">
-            <a:schemeClr val="accent1"/>
-          </a:lnRef>
-          <a:fillRef idx="3">
-            <a:schemeClr val="accent1"/>
-          </a:fillRef>
-          <a:effectRef idx="2">
-            <a:schemeClr val="accent1"/>
-          </a:effectRef>
-          <a:fontRef idx="minor">
-            <a:schemeClr val="lt1"/>
-          </a:fontRef>
-        </p:style>
-        <p:txBody>
-          <a:bodyPr rtlCol="0" anchor="ctr"/>
-          <a:lstStyle/>
-          <a:p>
-            <a:pPr algn="ctr"/>
-          </a:p>
-        </p:txBody>
-      </p:sp>
-      <p:sp>
-        <p:nvSpPr>
-          <p:cNvPr id="33" name="TextBox 32"/>
-          <p:cNvSpPr txBox="1"/>
-          <p:nvPr/>
-        </p:nvSpPr>
-        <p:spPr>
-          <a:xfrm>
-            <a:off x="7022592" y="4974336"/>
-            <a:ext cx="4553712" cy="731520"/>
-          </a:xfrm>
-          <a:prstGeom prst="rect">
-            <a:avLst/>
-          </a:prstGeom>
-          <a:noFill/>
-        </p:spPr>
-        <p:txBody>
-          <a:bodyPr wrap="square" anchor="ctr" lIns="0" rIns="0" tIns="0" bIns="0">
-            <a:spAutoFit/>
-          </a:bodyPr>
-          <a:lstStyle/>
-          <a:p>
-            <a:pPr algn="l">
-              <a:lnSpc>
-                <a:spcPct val="100000"/>
-              </a:lnSpc>
-              <a:spcBef>
-                <a:spcPts val="0"/>
-              </a:spcBef>
-              <a:spcAft>
-                <a:spcPts val="200"/>
-              </a:spcAft>
-            </a:pPr>
-            <a:r>
-              <a:rPr sz="1600" b="1">
-                <a:solidFill>
-                  <a:srgbClr val="103A50"/>
-                </a:solidFill>
-                <a:latin typeface="Calibri"/>
-              </a:rPr>
-              <a:t>Arduino / C++</a:t>
-            </a:r>
-          </a:p>
-          <a:p>
-            <a:pPr algn="l">
-              <a:lnSpc>
-                <a:spcPct val="100000"/>
-              </a:lnSpc>
-              <a:spcBef>
-                <a:spcPts val="0"/>
-              </a:spcBef>
-              <a:spcAft>
-                <a:spcPts val="200"/>
-              </a:spcAft>
-            </a:pPr>
-            <a:r>
-              <a:rPr sz="1150" b="0">
-                <a:solidFill>
-                  <a:srgbClr val="6B7482"/>
-                </a:solidFill>
-                <a:latin typeface="Calibri"/>
-              </a:rPr>
-              <a:t>Firmware &amp; Balancing-Algorithmus</a:t>
+              <a:t>Mikrocontroller der Drohne</a:t>
             </a:r>
           </a:p>
         </p:txBody>
@@ -5836,7 +5287,7 @@
         <p:spPr>
           <a:xfrm>
             <a:off x="868680" y="0"/>
-            <a:ext cx="7315200" cy="6858000"/>
+            <a:ext cx="8229600" cy="6858000"/>
           </a:xfrm>
           <a:prstGeom prst="rect">
             <a:avLst/>
@@ -5881,13 +5332,13 @@
         <p:spPr>
           <a:xfrm>
             <a:off x="914400" y="4160520"/>
-            <a:ext cx="2011680" cy="38100"/>
+            <a:ext cx="2011680" cy="44450"/>
           </a:xfrm>
           <a:prstGeom prst="rect">
             <a:avLst/>
           </a:prstGeom>
           <a:solidFill>
-            <a:srgbClr val="C9B79C"/>
+            <a:srgbClr val="2F80ED"/>
           </a:solidFill>
           <a:ln>
             <a:noFill/>

</xml_diff>

<commit_message>
docs: new visual style for EasyPilot iOS deck + real tech names
- Distinct style (no Franklyn signatures): full-navy title/demo slides,
  sans-serif bold headings, navy header bands with blue square mark + slide
  numbers, square bullet marks, vertical divider. Same navy/white/blue family.
- Tech stack uses real technology names: Swift, SwiftUI, SceneKit, WebSocket,
  Network.framework, ESP32-C3.

Co-Authored-By: Claude Opus 4.8 <noreply@anthropic.com>
</commit_message>
<xml_diff>
--- a/docs/presentation-ios/EasyPilot-iOS.pptx
+++ b/docs/presentation-ios/EasyPilot-iOS.pptx
@@ -3106,7 +3106,7 @@
             <a:avLst/>
           </a:prstGeom>
           <a:solidFill>
-            <a:srgbClr val="FFFFFF"/>
+            <a:srgbClr val="222B3C"/>
           </a:solidFill>
           <a:ln>
             <a:noFill/>
@@ -3137,41 +3137,20 @@
       </p:sp>
       <p:sp>
         <p:nvSpPr>
-          <p:cNvPr id="3" name="Freeform 2"/>
+          <p:cNvPr id="3" name="Rectangle 2"/>
           <p:cNvSpPr/>
           <p:nvPr/>
         </p:nvSpPr>
         <p:spPr>
           <a:xfrm>
-            <a:off x="0" y="2880360"/>
-            <a:ext cx="12191695" cy="3977640"/>
-          </a:xfrm>
-          <a:custGeom>
+            <a:off x="0" y="0"/>
+            <a:ext cx="146304" cy="6858000"/>
+          </a:xfrm>
+          <a:prstGeom prst="rect">
             <a:avLst/>
-            <a:gdLst/>
-            <a:ahLst/>
-            <a:cxnLst/>
-            <a:rect l="l" t="t" r="r" b="b"/>
-            <a:pathLst>
-              <a:path w="12191695" h="3977640">
-                <a:moveTo>
-                  <a:pt x="0" y="2606040"/>
-                </a:moveTo>
-                <a:lnTo>
-                  <a:pt x="12191695" y="0"/>
-                </a:lnTo>
-                <a:lnTo>
-                  <a:pt x="12191695" y="3977640"/>
-                </a:lnTo>
-                <a:lnTo>
-                  <a:pt x="0" y="3977640"/>
-                </a:lnTo>
-                <a:close/>
-              </a:path>
-            </a:pathLst>
-          </a:custGeom>
+          </a:prstGeom>
           <a:solidFill>
-            <a:srgbClr val="2C3649"/>
+            <a:srgbClr val="2F80ED"/>
           </a:solidFill>
           <a:ln>
             <a:noFill/>
@@ -3208,8 +3187,8 @@
         </p:nvSpPr>
         <p:spPr>
           <a:xfrm>
-            <a:off x="822960" y="777240"/>
-            <a:ext cx="10058400" cy="1463040"/>
+            <a:off x="868680" y="1371600"/>
+            <a:ext cx="10058400" cy="457200"/>
           </a:xfrm>
           <a:prstGeom prst="rect">
             <a:avLst/>
@@ -3234,20 +3213,65 @@
               </a:spcAft>
             </a:pPr>
             <a:r>
-              <a:rPr sz="6000" b="0">
-                <a:solidFill>
-                  <a:srgbClr val="103A50"/>
-                </a:solidFill>
-                <a:latin typeface="Georgia"/>
-              </a:rPr>
-              <a:t>EasyPilot </a:t>
-            </a:r>
-            <a:r>
-              <a:rPr sz="6000" b="0">
+              <a:rPr sz="1400" b="1">
                 <a:solidFill>
                   <a:srgbClr val="2F80ED"/>
                 </a:solidFill>
-                <a:latin typeface="Georgia"/>
+                <a:latin typeface="Segoe UI Semibold"/>
+              </a:rPr>
+              <a:t>EASYPILOT  ·  4AHITM DROHNENPROJEKT</a:t>
+            </a:r>
+          </a:p>
+        </p:txBody>
+      </p:sp>
+      <p:sp>
+        <p:nvSpPr>
+          <p:cNvPr id="5" name="TextBox 4"/>
+          <p:cNvSpPr txBox="1"/>
+          <p:nvPr/>
+        </p:nvSpPr>
+        <p:spPr>
+          <a:xfrm>
+            <a:off x="822960" y="2057400"/>
+            <a:ext cx="10515600" cy="1371600"/>
+          </a:xfrm>
+          <a:prstGeom prst="rect">
+            <a:avLst/>
+          </a:prstGeom>
+          <a:noFill/>
+        </p:spPr>
+        <p:txBody>
+          <a:bodyPr wrap="square" anchor="t" lIns="0" rIns="0" tIns="0" bIns="0">
+            <a:spAutoFit/>
+          </a:bodyPr>
+          <a:lstStyle/>
+          <a:p>
+            <a:pPr algn="l">
+              <a:lnSpc>
+                <a:spcPct val="100000"/>
+              </a:lnSpc>
+              <a:spcBef>
+                <a:spcPts val="0"/>
+              </a:spcBef>
+              <a:spcAft>
+                <a:spcPts val="800"/>
+              </a:spcAft>
+            </a:pPr>
+            <a:r>
+              <a:rPr sz="6200" b="1">
+                <a:solidFill>
+                  <a:srgbClr val="FFFFFF"/>
+                </a:solidFill>
+                <a:latin typeface="Segoe UI Semibold"/>
+              </a:rPr>
+              <a:t>EasyPilot </a:t>
+            </a:r>
+            <a:r>
+              <a:rPr sz="6200" b="1">
+                <a:solidFill>
+                  <a:srgbClr val="2F80ED"/>
+                </a:solidFill>
+                <a:latin typeface="Segoe UI Semibold"/>
               </a:rPr>
               <a:t>iOS</a:t>
             </a:r>
@@ -3256,14 +3280,14 @@
       </p:sp>
       <p:sp>
         <p:nvSpPr>
-          <p:cNvPr id="5" name="Rectangle 4"/>
+          <p:cNvPr id="6" name="Rectangle 5"/>
           <p:cNvSpPr/>
           <p:nvPr/>
         </p:nvSpPr>
         <p:spPr>
           <a:xfrm>
-            <a:off x="868680" y="1938528"/>
-            <a:ext cx="2103120" cy="44450"/>
+            <a:off x="868680" y="3310128"/>
+            <a:ext cx="1371600" cy="50800"/>
           </a:xfrm>
           <a:prstGeom prst="rect">
             <a:avLst/>
@@ -3300,14 +3324,14 @@
       </p:sp>
       <p:sp>
         <p:nvSpPr>
-          <p:cNvPr id="6" name="TextBox 5"/>
+          <p:cNvPr id="7" name="TextBox 6"/>
           <p:cNvSpPr txBox="1"/>
           <p:nvPr/>
         </p:nvSpPr>
         <p:spPr>
           <a:xfrm>
-            <a:off x="868680" y="2240280"/>
-            <a:ext cx="9692640" cy="822960"/>
+            <a:off x="868680" y="3611880"/>
+            <a:ext cx="9875520" cy="1097280"/>
           </a:xfrm>
           <a:prstGeom prst="rect">
             <a:avLst/>
@@ -3332,11 +3356,11 @@
               </a:spcAft>
             </a:pPr>
             <a:r>
-              <a:rPr sz="2100" b="0">
+              <a:rPr sz="2000" b="0">
                 <a:solidFill>
-                  <a:srgbClr val="6B7482"/>
+                  <a:srgbClr val="C4CEDE"/>
                 </a:solidFill>
-                <a:latin typeface="Calibri"/>
+                <a:latin typeface="Segoe UI"/>
               </a:rPr>
               <a:t>SwiftUI-Companion-App für die EasyPilot-Drohne – findet die Drohne</a:t>
             </a:r>
@@ -3354,26 +3378,26 @@
               </a:spcAft>
             </a:pPr>
             <a:r>
-              <a:rPr sz="2100" b="0">
+              <a:rPr sz="2000" b="0">
                 <a:solidFill>
-                  <a:srgbClr val="6B7482"/>
+                  <a:srgbClr val="C4CEDE"/>
                 </a:solidFill>
-                <a:latin typeface="Calibri"/>
+                <a:latin typeface="Segoe UI"/>
               </a:rPr>
-              <a:t>selbst im WLAN, zeigt Live-Telemetrie und fliegt einen 3D-Simulator.</a:t>
-            </a:r>
-          </a:p>
-        </p:txBody>
-      </p:sp>
-      <p:sp>
-        <p:nvSpPr>
-          <p:cNvPr id="7" name="TextBox 6"/>
+              <a:t>selbst im WLAN, zeigt Live-Telemetrie und fliegt einen 3D-Flugsimulator.</a:t>
+            </a:r>
+          </a:p>
+        </p:txBody>
+      </p:sp>
+      <p:sp>
+        <p:nvSpPr>
+          <p:cNvPr id="8" name="TextBox 7"/>
           <p:cNvSpPr txBox="1"/>
           <p:nvPr/>
         </p:nvSpPr>
         <p:spPr>
           <a:xfrm>
-            <a:off x="868680" y="3520440"/>
+            <a:off x="868680" y="5577840"/>
             <a:ext cx="7315200" cy="822960"/>
           </a:xfrm>
           <a:prstGeom prst="rect">
@@ -3399,11 +3423,11 @@
               </a:spcAft>
             </a:pPr>
             <a:r>
-              <a:rPr sz="1800" b="0">
+              <a:rPr sz="1900" b="1">
                 <a:solidFill>
-                  <a:srgbClr val="333B47"/>
+                  <a:srgbClr val="FFFFFF"/>
                 </a:solidFill>
-                <a:latin typeface="Calibri"/>
+                <a:latin typeface="Segoe UI Semibold"/>
               </a:rPr>
               <a:t>Simon Eder</a:t>
             </a:r>
@@ -3423,9 +3447,9 @@
             <a:r>
               <a:rPr sz="1400" b="0">
                 <a:solidFill>
-                  <a:srgbClr val="6B7482"/>
+                  <a:srgbClr val="C4CEDE"/>
                 </a:solidFill>
-                <a:latin typeface="Calibri"/>
+                <a:latin typeface="Segoe UI"/>
               </a:rPr>
               <a:t>Creator</a:t>
             </a:r>
@@ -3496,14 +3520,102 @@
       </p:sp>
       <p:sp>
         <p:nvSpPr>
-          <p:cNvPr id="3" name="TextBox 2"/>
+          <p:cNvPr id="3" name="Rectangle 2"/>
+          <p:cNvSpPr/>
+          <p:nvPr/>
+        </p:nvSpPr>
+        <p:spPr>
+          <a:xfrm>
+            <a:off x="0" y="0"/>
+            <a:ext cx="12191695" cy="1234440"/>
+          </a:xfrm>
+          <a:prstGeom prst="rect">
+            <a:avLst/>
+          </a:prstGeom>
+          <a:solidFill>
+            <a:srgbClr val="222B3C"/>
+          </a:solidFill>
+          <a:ln>
+            <a:noFill/>
+          </a:ln>
+          <a:effectLst/>
+        </p:spPr>
+        <p:style>
+          <a:lnRef idx="1">
+            <a:schemeClr val="accent1"/>
+          </a:lnRef>
+          <a:fillRef idx="3">
+            <a:schemeClr val="accent1"/>
+          </a:fillRef>
+          <a:effectRef idx="2">
+            <a:schemeClr val="accent1"/>
+          </a:effectRef>
+          <a:fontRef idx="minor">
+            <a:schemeClr val="lt1"/>
+          </a:fontRef>
+        </p:style>
+        <p:txBody>
+          <a:bodyPr rtlCol="0" anchor="ctr"/>
+          <a:lstStyle/>
+          <a:p>
+            <a:pPr algn="ctr"/>
+          </a:p>
+        </p:txBody>
+      </p:sp>
+      <p:sp>
+        <p:nvSpPr>
+          <p:cNvPr id="4" name="Rectangle 3"/>
+          <p:cNvSpPr/>
+          <p:nvPr/>
+        </p:nvSpPr>
+        <p:spPr>
+          <a:xfrm>
+            <a:off x="777240" y="457200"/>
+            <a:ext cx="310896" cy="310896"/>
+          </a:xfrm>
+          <a:prstGeom prst="rect">
+            <a:avLst/>
+          </a:prstGeom>
+          <a:solidFill>
+            <a:srgbClr val="2F80ED"/>
+          </a:solidFill>
+          <a:ln>
+            <a:noFill/>
+          </a:ln>
+          <a:effectLst/>
+        </p:spPr>
+        <p:style>
+          <a:lnRef idx="1">
+            <a:schemeClr val="accent1"/>
+          </a:lnRef>
+          <a:fillRef idx="3">
+            <a:schemeClr val="accent1"/>
+          </a:fillRef>
+          <a:effectRef idx="2">
+            <a:schemeClr val="accent1"/>
+          </a:effectRef>
+          <a:fontRef idx="minor">
+            <a:schemeClr val="lt1"/>
+          </a:fontRef>
+        </p:style>
+        <p:txBody>
+          <a:bodyPr rtlCol="0" anchor="ctr"/>
+          <a:lstStyle/>
+          <a:p>
+            <a:pPr algn="ctr"/>
+          </a:p>
+        </p:txBody>
+      </p:sp>
+      <p:sp>
+        <p:nvSpPr>
+          <p:cNvPr id="5" name="TextBox 4"/>
           <p:cNvSpPr txBox="1"/>
           <p:nvPr/>
         </p:nvSpPr>
         <p:spPr>
           <a:xfrm>
-            <a:off x="777240" y="640080"/>
-            <a:ext cx="10607040" cy="914400"/>
+            <a:off x="1280160" y="0"/>
+            <a:ext cx="9144000" cy="1234440"/>
           </a:xfrm>
           <a:prstGeom prst="rect">
             <a:avLst/>
@@ -3511,7 +3623,7 @@
           <a:noFill/>
         </p:spPr>
         <p:txBody>
-          <a:bodyPr wrap="square" anchor="t" lIns="0" rIns="0" tIns="0" bIns="0">
+          <a:bodyPr wrap="square" anchor="ctr" lIns="0" rIns="0" tIns="0" bIns="0">
             <a:spAutoFit/>
           </a:bodyPr>
           <a:lstStyle/>
@@ -3528,63 +3640,72 @@
               </a:spcAft>
             </a:pPr>
             <a:r>
-              <a:rPr sz="3600" b="0">
+              <a:rPr sz="3000" b="1">
                 <a:solidFill>
-                  <a:srgbClr val="103A50"/>
+                  <a:srgbClr val="FFFFFF"/>
                 </a:solidFill>
-                <a:latin typeface="Georgia"/>
+                <a:latin typeface="Segoe UI Semibold"/>
               </a:rPr>
               <a:t>Was ist EasyPilot iOS</a:t>
             </a:r>
           </a:p>
         </p:txBody>
       </p:sp>
-      <p:cxnSp>
-        <p:nvCxnSpPr>
-          <p:cNvPr id="4" name="Connector 3"/>
-          <p:cNvCxnSpPr/>
-          <p:nvPr/>
-        </p:nvCxnSpPr>
-        <p:spPr>
-          <a:xfrm>
-            <a:off x="777240" y="1600200"/>
-            <a:ext cx="10634472" cy="0"/>
-          </a:xfrm>
-          <a:prstGeom prst="line">
-            <a:avLst/>
-          </a:prstGeom>
-          <a:ln w="28575">
-            <a:solidFill>
-              <a:srgbClr val="2F80ED"/>
-            </a:solidFill>
-          </a:ln>
-          <a:effectLst/>
-        </p:spPr>
-        <p:style>
-          <a:lnRef idx="2">
-            <a:schemeClr val="accent1"/>
-          </a:lnRef>
-          <a:fillRef idx="0">
-            <a:schemeClr val="accent1"/>
-          </a:fillRef>
-          <a:effectRef idx="1">
-            <a:schemeClr val="accent1"/>
-          </a:effectRef>
-          <a:fontRef idx="minor">
-            <a:schemeClr val="tx1"/>
-          </a:fontRef>
-        </p:style>
-      </p:cxnSp>
-      <p:sp>
-        <p:nvSpPr>
-          <p:cNvPr id="5" name="TextBox 4"/>
+      <p:sp>
+        <p:nvSpPr>
+          <p:cNvPr id="6" name="TextBox 5"/>
           <p:cNvSpPr txBox="1"/>
           <p:nvPr/>
         </p:nvSpPr>
         <p:spPr>
           <a:xfrm>
-            <a:off x="777240" y="2057400"/>
-            <a:ext cx="5852160" cy="4206240"/>
+            <a:off x="10972800" y="0"/>
+            <a:ext cx="822960" cy="1234440"/>
+          </a:xfrm>
+          <a:prstGeom prst="rect">
+            <a:avLst/>
+          </a:prstGeom>
+          <a:noFill/>
+        </p:spPr>
+        <p:txBody>
+          <a:bodyPr wrap="square" anchor="ctr" lIns="0" rIns="0" tIns="0" bIns="0">
+            <a:spAutoFit/>
+          </a:bodyPr>
+          <a:lstStyle/>
+          <a:p>
+            <a:pPr algn="r">
+              <a:lnSpc>
+                <a:spcPct val="100000"/>
+              </a:lnSpc>
+              <a:spcBef>
+                <a:spcPts val="0"/>
+              </a:spcBef>
+              <a:spcAft>
+                <a:spcPts val="800"/>
+              </a:spcAft>
+            </a:pPr>
+            <a:r>
+              <a:rPr sz="1600" b="1">
+                <a:solidFill>
+                  <a:srgbClr val="2F80ED"/>
+                </a:solidFill>
+                <a:latin typeface="Segoe UI Semibold"/>
+              </a:rPr>
+              <a:t>02</a:t>
+            </a:r>
+          </a:p>
+        </p:txBody>
+      </p:sp>
+      <p:sp>
+        <p:nvSpPr>
+          <p:cNvPr id="7" name="TextBox 6"/>
+          <p:cNvSpPr txBox="1"/>
+          <p:nvPr/>
+        </p:nvSpPr>
+        <p:spPr>
+          <a:xfrm>
+            <a:off x="777240" y="1783080"/>
+            <a:ext cx="5760720" cy="4389120"/>
           </a:xfrm>
           <a:prstGeom prst="rect">
             <a:avLst/>
@@ -3599,7 +3720,7 @@
           <a:p>
             <a:pPr algn="l">
               <a:lnSpc>
-                <a:spcPct val="108000"/>
+                <a:spcPct val="110000"/>
               </a:lnSpc>
               <a:spcBef>
                 <a:spcPts val="0"/>
@@ -3609,20 +3730,20 @@
               </a:spcAft>
             </a:pPr>
             <a:r>
-              <a:rPr sz="1400" b="1">
+              <a:rPr sz="1500" b="1">
                 <a:solidFill>
                   <a:srgbClr val="2F80ED"/>
                 </a:solidFill>
-                <a:latin typeface="Calibri"/>
+                <a:latin typeface="Segoe UI"/>
               </a:rPr>
-              <a:t>●  </a:t>
+              <a:t>▪  </a:t>
             </a:r>
             <a:r>
               <a:rPr sz="1650" b="0">
                 <a:solidFill>
-                  <a:srgbClr val="333B47"/>
+                  <a:srgbClr val="2B3340"/>
                 </a:solidFill>
-                <a:latin typeface="Calibri"/>
+                <a:latin typeface="Segoe UI"/>
               </a:rPr>
               <a:t>EasyPilot ist unser 4AHITM-Drohnenprojekt: eine selbstgebaute Drohne mit ESP32-Steuerung.</a:t>
             </a:r>
@@ -3630,7 +3751,7 @@
           <a:p>
             <a:pPr algn="l">
               <a:lnSpc>
-                <a:spcPct val="108000"/>
+                <a:spcPct val="110000"/>
               </a:lnSpc>
               <a:spcBef>
                 <a:spcPts val="0"/>
@@ -3640,20 +3761,20 @@
               </a:spcAft>
             </a:pPr>
             <a:r>
-              <a:rPr sz="1400" b="1">
+              <a:rPr sz="1500" b="1">
                 <a:solidFill>
                   <a:srgbClr val="2F80ED"/>
                 </a:solidFill>
-                <a:latin typeface="Calibri"/>
+                <a:latin typeface="Segoe UI"/>
               </a:rPr>
-              <a:t>●  </a:t>
+              <a:t>▪  </a:t>
             </a:r>
             <a:r>
               <a:rPr sz="1650" b="0">
                 <a:solidFill>
-                  <a:srgbClr val="333B47"/>
+                  <a:srgbClr val="2B3340"/>
                 </a:solidFill>
-                <a:latin typeface="Calibri"/>
+                <a:latin typeface="Segoe UI"/>
               </a:rPr>
               <a:t>Die iOS-App ist der mobile Co-Pilot – komplett in SwiftUI, nur mit Apple-Frameworks.</a:t>
             </a:r>
@@ -3661,7 +3782,7 @@
           <a:p>
             <a:pPr algn="l">
               <a:lnSpc>
-                <a:spcPct val="108000"/>
+                <a:spcPct val="110000"/>
               </a:lnSpc>
               <a:spcBef>
                 <a:spcPts val="0"/>
@@ -3671,20 +3792,20 @@
               </a:spcAft>
             </a:pPr>
             <a:r>
-              <a:rPr sz="1400" b="1">
+              <a:rPr sz="1500" b="1">
                 <a:solidFill>
                   <a:srgbClr val="2F80ED"/>
                 </a:solidFill>
-                <a:latin typeface="Calibri"/>
+                <a:latin typeface="Segoe UI"/>
               </a:rPr>
-              <a:t>●  </a:t>
+              <a:t>▪  </a:t>
             </a:r>
             <a:r>
               <a:rPr sz="1650" b="0">
                 <a:solidFill>
-                  <a:srgbClr val="333B47"/>
+                  <a:srgbClr val="2B3340"/>
                 </a:solidFill>
-                <a:latin typeface="Calibri"/>
+                <a:latin typeface="Segoe UI"/>
               </a:rPr>
               <a:t>Sie findet die Drohne automatisch im WLAN – ohne Eintippen einer IP-Adresse.</a:t>
             </a:r>
@@ -3692,7 +3813,7 @@
           <a:p>
             <a:pPr algn="l">
               <a:lnSpc>
-                <a:spcPct val="108000"/>
+                <a:spcPct val="110000"/>
               </a:lnSpc>
               <a:spcBef>
                 <a:spcPts val="0"/>
@@ -3702,46 +3823,41 @@
               </a:spcAft>
             </a:pPr>
             <a:r>
-              <a:rPr sz="1400" b="1">
+              <a:rPr sz="1500" b="1">
                 <a:solidFill>
                   <a:srgbClr val="2F80ED"/>
                 </a:solidFill>
-                <a:latin typeface="Calibri"/>
+                <a:latin typeface="Segoe UI"/>
               </a:rPr>
-              <a:t>●  </a:t>
+              <a:t>▪  </a:t>
             </a:r>
             <a:r>
               <a:rPr sz="1650" b="0">
                 <a:solidFill>
-                  <a:srgbClr val="333B47"/>
+                  <a:srgbClr val="2B3340"/>
                 </a:solidFill>
-                <a:latin typeface="Calibri"/>
+                <a:latin typeface="Segoe UI"/>
               </a:rPr>
               <a:t>Live-Telemetrie mit 10 Hz, ein 3D-Flugsimulator und das Senden von Flugbefehlen – alles auf dem iPhone.</a:t>
             </a:r>
           </a:p>
         </p:txBody>
       </p:sp>
-      <p:sp>
-        <p:nvSpPr>
-          <p:cNvPr id="6" name="Rounded Rectangle 5"/>
-          <p:cNvSpPr/>
+      <p:cxnSp>
+        <p:nvCxnSpPr>
+          <p:cNvPr id="8" name="Connector 7"/>
+          <p:cNvCxnSpPr/>
           <p:nvPr/>
-        </p:nvSpPr>
-        <p:spPr>
-          <a:xfrm>
-            <a:off x="7315200" y="2240280"/>
-            <a:ext cx="4023360" cy="1143000"/>
-          </a:xfrm>
-          <a:prstGeom prst="roundRect">
-            <a:avLst>
-              <a:gd name="adj" fmla="val 12000"/>
-            </a:avLst>
-          </a:prstGeom>
-          <a:solidFill>
-            <a:srgbClr val="FFFFFF"/>
-          </a:solidFill>
-          <a:ln w="25400">
+        </p:nvCxnSpPr>
+        <p:spPr>
+          <a:xfrm>
+            <a:off x="6903720" y="1874519"/>
+            <a:ext cx="0" cy="4206240"/>
+          </a:xfrm>
+          <a:prstGeom prst="line">
+            <a:avLst/>
+          </a:prstGeom>
+          <a:ln w="22225">
             <a:solidFill>
               <a:srgbClr val="2F80ED"/>
             </a:solidFill>
@@ -3749,6 +3865,47 @@
           <a:effectLst/>
         </p:spPr>
         <p:style>
+          <a:lnRef idx="2">
+            <a:schemeClr val="accent1"/>
+          </a:lnRef>
+          <a:fillRef idx="0">
+            <a:schemeClr val="accent1"/>
+          </a:fillRef>
+          <a:effectRef idx="1">
+            <a:schemeClr val="accent1"/>
+          </a:effectRef>
+          <a:fontRef idx="minor">
+            <a:schemeClr val="tx1"/>
+          </a:fontRef>
+        </p:style>
+      </p:cxnSp>
+      <p:sp>
+        <p:nvSpPr>
+          <p:cNvPr id="9" name="Rounded Rectangle 8"/>
+          <p:cNvSpPr/>
+          <p:nvPr/>
+        </p:nvSpPr>
+        <p:spPr>
+          <a:xfrm>
+            <a:off x="7406640" y="2148840"/>
+            <a:ext cx="3931920" cy="1097280"/>
+          </a:xfrm>
+          <a:prstGeom prst="roundRect">
+            <a:avLst>
+              <a:gd name="adj" fmla="val 10000"/>
+            </a:avLst>
+          </a:prstGeom>
+          <a:solidFill>
+            <a:srgbClr val="F4F7FB"/>
+          </a:solidFill>
+          <a:ln w="22225">
+            <a:solidFill>
+              <a:srgbClr val="2F80ED"/>
+            </a:solidFill>
+          </a:ln>
+          <a:effectLst/>
+        </p:spPr>
+        <p:style>
           <a:lnRef idx="1">
             <a:schemeClr val="accent1"/>
           </a:lnRef>
@@ -3772,14 +3929,14 @@
       </p:sp>
       <p:sp>
         <p:nvSpPr>
-          <p:cNvPr id="7" name="TextBox 6"/>
+          <p:cNvPr id="10" name="TextBox 9"/>
           <p:cNvSpPr txBox="1"/>
           <p:nvPr/>
         </p:nvSpPr>
         <p:spPr>
           <a:xfrm>
-            <a:off x="7315200" y="2240280"/>
-            <a:ext cx="4023360" cy="1143000"/>
+            <a:off x="7406640" y="2148840"/>
+            <a:ext cx="3931920" cy="1097280"/>
           </a:xfrm>
           <a:prstGeom prst="rect">
             <a:avLst/>
@@ -3806,9 +3963,9 @@
             <a:r>
               <a:rPr sz="1800" b="1">
                 <a:solidFill>
-                  <a:srgbClr val="103A50"/>
+                  <a:srgbClr val="162133"/>
                 </a:solidFill>
-                <a:latin typeface="Calibri"/>
+                <a:latin typeface="Segoe UI Semibold"/>
               </a:rPr>
               <a:t>iPhone</a:t>
             </a:r>
@@ -3830,7 +3987,7 @@
                 <a:solidFill>
                   <a:srgbClr val="6B7482"/>
                 </a:solidFill>
-                <a:latin typeface="Calibri"/>
+                <a:latin typeface="Segoe UI"/>
               </a:rPr>
               <a:t>EasyPilot App (SwiftUI)</a:t>
             </a:r>
@@ -3839,26 +3996,26 @@
       </p:sp>
       <p:sp>
         <p:nvSpPr>
-          <p:cNvPr id="8" name="Rounded Rectangle 7"/>
+          <p:cNvPr id="11" name="Rounded Rectangle 10"/>
           <p:cNvSpPr/>
           <p:nvPr/>
         </p:nvSpPr>
         <p:spPr>
           <a:xfrm>
-            <a:off x="7315200" y="4983480"/>
-            <a:ext cx="4023360" cy="1143000"/>
+            <a:off x="7406640" y="4846320"/>
+            <a:ext cx="3931920" cy="1097280"/>
           </a:xfrm>
           <a:prstGeom prst="roundRect">
             <a:avLst>
-              <a:gd name="adj" fmla="val 12000"/>
+              <a:gd name="adj" fmla="val 10000"/>
             </a:avLst>
           </a:prstGeom>
           <a:solidFill>
-            <a:srgbClr val="FFFFFF"/>
+            <a:srgbClr val="F4F7FB"/>
           </a:solidFill>
-          <a:ln w="25400">
+          <a:ln w="22225">
             <a:solidFill>
-              <a:srgbClr val="2C3649"/>
+              <a:srgbClr val="222B3C"/>
             </a:solidFill>
           </a:ln>
           <a:effectLst/>
@@ -3887,14 +4044,14 @@
       </p:sp>
       <p:sp>
         <p:nvSpPr>
-          <p:cNvPr id="9" name="TextBox 8"/>
+          <p:cNvPr id="12" name="TextBox 11"/>
           <p:cNvSpPr txBox="1"/>
           <p:nvPr/>
         </p:nvSpPr>
         <p:spPr>
           <a:xfrm>
-            <a:off x="7315200" y="4983480"/>
-            <a:ext cx="4023360" cy="1143000"/>
+            <a:off x="7406640" y="4846320"/>
+            <a:ext cx="3931920" cy="1097280"/>
           </a:xfrm>
           <a:prstGeom prst="rect">
             <a:avLst/>
@@ -3921,9 +4078,9 @@
             <a:r>
               <a:rPr sz="1800" b="1">
                 <a:solidFill>
-                  <a:srgbClr val="103A50"/>
+                  <a:srgbClr val="162133"/>
                 </a:solidFill>
-                <a:latin typeface="Calibri"/>
+                <a:latin typeface="Segoe UI Semibold"/>
               </a:rPr>
               <a:t>ESP32-C3</a:t>
             </a:r>
@@ -3945,7 +4102,7 @@
                 <a:solidFill>
                   <a:srgbClr val="6B7482"/>
                 </a:solidFill>
-                <a:latin typeface="Calibri"/>
+                <a:latin typeface="Segoe UI"/>
               </a:rPr>
               <a:t>Drohne · WLAN</a:t>
             </a:r>
@@ -3954,13 +4111,13 @@
       </p:sp>
       <p:cxnSp>
         <p:nvCxnSpPr>
-          <p:cNvPr id="10" name="Connector 9"/>
+          <p:cNvPr id="13" name="Connector 12"/>
           <p:cNvCxnSpPr/>
           <p:nvPr/>
         </p:nvCxnSpPr>
         <p:spPr>
           <a:xfrm>
-            <a:off x="8001000" y="3383280"/>
+            <a:off x="8138160" y="3246120"/>
             <a:ext cx="0" cy="1600200"/>
           </a:xfrm>
           <a:prstGeom prst="line">
@@ -3968,7 +4125,7 @@
           </a:prstGeom>
           <a:ln w="28575">
             <a:solidFill>
-              <a:srgbClr val="2C3649"/>
+              <a:srgbClr val="222B3C"/>
             </a:solidFill>
             <a:tailEnd type="triangle" w="med" len="med"/>
           </a:ln>
@@ -3991,13 +4148,13 @@
       </p:cxnSp>
       <p:cxnSp>
         <p:nvCxnSpPr>
-          <p:cNvPr id="11" name="Connector 10"/>
+          <p:cNvPr id="14" name="Connector 13"/>
           <p:cNvCxnSpPr/>
           <p:nvPr/>
         </p:nvCxnSpPr>
         <p:spPr>
           <a:xfrm flipV="1">
-            <a:off x="10652760" y="3383280"/>
+            <a:off x="10607040" y="3246120"/>
             <a:ext cx="0" cy="1600200"/>
           </a:xfrm>
           <a:prstGeom prst="line">
@@ -4005,7 +4162,7 @@
           </a:prstGeom>
           <a:ln w="28575">
             <a:solidFill>
-              <a:srgbClr val="2C3649"/>
+              <a:srgbClr val="222B3C"/>
             </a:solidFill>
             <a:tailEnd type="triangle" w="med" len="med"/>
           </a:ln>
@@ -4028,14 +4185,14 @@
       </p:cxnSp>
       <p:sp>
         <p:nvSpPr>
-          <p:cNvPr id="12" name="TextBox 11"/>
+          <p:cNvPr id="15" name="TextBox 14"/>
           <p:cNvSpPr txBox="1"/>
           <p:nvPr/>
         </p:nvSpPr>
         <p:spPr>
           <a:xfrm>
-            <a:off x="7315200" y="3749039"/>
-            <a:ext cx="4023360" cy="1097280"/>
+            <a:off x="7406640" y="3657600"/>
+            <a:ext cx="3931920" cy="1005840"/>
           </a:xfrm>
           <a:prstGeom prst="rect">
             <a:avLst/>
@@ -4064,9 +4221,9 @@
                 <a:solidFill>
                   <a:srgbClr val="6B7482"/>
                 </a:solidFill>
-                <a:latin typeface="Calibri"/>
+                <a:latin typeface="Segoe UI"/>
               </a:rPr>
-              <a:t>WLAN-Discovery · 10 Hz</a:t>
+              <a:t>Auto-Discovery · 10 Hz</a:t>
             </a:r>
           </a:p>
           <a:p>
@@ -4086,7 +4243,7 @@
                 <a:solidFill>
                   <a:srgbClr val="6B7482"/>
                 </a:solidFill>
-                <a:latin typeface="Calibri"/>
+                <a:latin typeface="Segoe UI"/>
               </a:rPr>
               <a:t>Befehle ↑ · Telemetrie ↓</a:t>
             </a:r>
@@ -4164,13 +4321,13 @@
         <p:spPr>
           <a:xfrm>
             <a:off x="0" y="0"/>
-            <a:ext cx="12191695" cy="1463040"/>
+            <a:ext cx="12191695" cy="1234440"/>
           </a:xfrm>
           <a:prstGeom prst="rect">
             <a:avLst/>
           </a:prstGeom>
           <a:solidFill>
-            <a:srgbClr val="2C3649"/>
+            <a:srgbClr val="222B3C"/>
           </a:solidFill>
           <a:ln>
             <a:noFill/>
@@ -4201,14 +4358,58 @@
       </p:sp>
       <p:sp>
         <p:nvSpPr>
-          <p:cNvPr id="4" name="TextBox 3"/>
+          <p:cNvPr id="4" name="Rectangle 3"/>
+          <p:cNvSpPr/>
+          <p:nvPr/>
+        </p:nvSpPr>
+        <p:spPr>
+          <a:xfrm>
+            <a:off x="777240" y="457200"/>
+            <a:ext cx="310896" cy="310896"/>
+          </a:xfrm>
+          <a:prstGeom prst="rect">
+            <a:avLst/>
+          </a:prstGeom>
+          <a:solidFill>
+            <a:srgbClr val="2F80ED"/>
+          </a:solidFill>
+          <a:ln>
+            <a:noFill/>
+          </a:ln>
+          <a:effectLst/>
+        </p:spPr>
+        <p:style>
+          <a:lnRef idx="1">
+            <a:schemeClr val="accent1"/>
+          </a:lnRef>
+          <a:fillRef idx="3">
+            <a:schemeClr val="accent1"/>
+          </a:fillRef>
+          <a:effectRef idx="2">
+            <a:schemeClr val="accent1"/>
+          </a:effectRef>
+          <a:fontRef idx="minor">
+            <a:schemeClr val="lt1"/>
+          </a:fontRef>
+        </p:style>
+        <p:txBody>
+          <a:bodyPr rtlCol="0" anchor="ctr"/>
+          <a:lstStyle/>
+          <a:p>
+            <a:pPr algn="ctr"/>
+          </a:p>
+        </p:txBody>
+      </p:sp>
+      <p:sp>
+        <p:nvSpPr>
+          <p:cNvPr id="5" name="TextBox 4"/>
           <p:cNvSpPr txBox="1"/>
           <p:nvPr/>
         </p:nvSpPr>
         <p:spPr>
           <a:xfrm>
-            <a:off x="777240" y="0"/>
-            <a:ext cx="10058400" cy="1463040"/>
+            <a:off x="1280160" y="0"/>
+            <a:ext cx="9144000" cy="1234440"/>
           </a:xfrm>
           <a:prstGeom prst="rect">
             <a:avLst/>
@@ -4233,39 +4434,84 @@
               </a:spcAft>
             </a:pPr>
             <a:r>
-              <a:rPr sz="3400" b="0">
+              <a:rPr sz="3000" b="1">
                 <a:solidFill>
                   <a:srgbClr val="FFFFFF"/>
                 </a:solidFill>
-                <a:latin typeface="Georgia"/>
+                <a:latin typeface="Segoe UI Semibold"/>
               </a:rPr>
-              <a:t>EasyPilot iOS – Tech Stack</a:t>
-            </a:r>
-          </a:p>
-        </p:txBody>
-      </p:sp>
-      <p:sp>
-        <p:nvSpPr>
-          <p:cNvPr id="5" name="Rounded Rectangle 4"/>
+              <a:t>Tech Stack</a:t>
+            </a:r>
+          </a:p>
+        </p:txBody>
+      </p:sp>
+      <p:sp>
+        <p:nvSpPr>
+          <p:cNvPr id="6" name="TextBox 5"/>
+          <p:cNvSpPr txBox="1"/>
+          <p:nvPr/>
+        </p:nvSpPr>
+        <p:spPr>
+          <a:xfrm>
+            <a:off x="10972800" y="0"/>
+            <a:ext cx="822960" cy="1234440"/>
+          </a:xfrm>
+          <a:prstGeom prst="rect">
+            <a:avLst/>
+          </a:prstGeom>
+          <a:noFill/>
+        </p:spPr>
+        <p:txBody>
+          <a:bodyPr wrap="square" anchor="ctr" lIns="0" rIns="0" tIns="0" bIns="0">
+            <a:spAutoFit/>
+          </a:bodyPr>
+          <a:lstStyle/>
+          <a:p>
+            <a:pPr algn="r">
+              <a:lnSpc>
+                <a:spcPct val="100000"/>
+              </a:lnSpc>
+              <a:spcBef>
+                <a:spcPts val="0"/>
+              </a:spcBef>
+              <a:spcAft>
+                <a:spcPts val="800"/>
+              </a:spcAft>
+            </a:pPr>
+            <a:r>
+              <a:rPr sz="1600" b="1">
+                <a:solidFill>
+                  <a:srgbClr val="2F80ED"/>
+                </a:solidFill>
+                <a:latin typeface="Segoe UI Semibold"/>
+              </a:rPr>
+              <a:t>03</a:t>
+            </a:r>
+          </a:p>
+        </p:txBody>
+      </p:sp>
+      <p:sp>
+        <p:nvSpPr>
+          <p:cNvPr id="7" name="Rounded Rectangle 6"/>
           <p:cNvSpPr/>
           <p:nvPr/>
         </p:nvSpPr>
         <p:spPr>
           <a:xfrm>
-            <a:off x="777240" y="1828800"/>
-            <a:ext cx="3271418" cy="2148840"/>
+            <a:off x="777240" y="1783080"/>
+            <a:ext cx="3271418" cy="2103120"/>
           </a:xfrm>
           <a:prstGeom prst="roundRect">
             <a:avLst>
-              <a:gd name="adj" fmla="val 6000"/>
+              <a:gd name="adj" fmla="val 5000"/>
             </a:avLst>
           </a:prstGeom>
           <a:solidFill>
-            <a:srgbClr val="F6F8FB"/>
+            <a:srgbClr val="F4F7FB"/>
           </a:solidFill>
           <a:ln w="12700">
             <a:solidFill>
-              <a:srgbClr val="DDE1E7"/>
+              <a:srgbClr val="E2E7EE"/>
             </a:solidFill>
           </a:ln>
           <a:effectLst/>
@@ -4294,7 +4540,7 @@
       </p:sp>
       <p:pic>
         <p:nvPicPr>
-          <p:cNvPr id="6" name="Picture 5" descr="swift.png"/>
+          <p:cNvPr id="8" name="Picture 7" descr="swift.png"/>
           <p:cNvPicPr>
             <a:picLocks noChangeAspect="1"/>
           </p:cNvPicPr>
@@ -4308,8 +4554,8 @@
         </p:blipFill>
         <p:spPr>
           <a:xfrm>
-            <a:off x="1727149" y="2367153"/>
-            <a:ext cx="1371600" cy="422909"/>
+            <a:off x="1750009" y="2287333"/>
+            <a:ext cx="1325880" cy="408812"/>
           </a:xfrm>
           <a:prstGeom prst="rect">
             <a:avLst/>
@@ -4318,14 +4564,14 @@
       </p:pic>
       <p:sp>
         <p:nvSpPr>
-          <p:cNvPr id="7" name="TextBox 6"/>
+          <p:cNvPr id="9" name="TextBox 8"/>
           <p:cNvSpPr txBox="1"/>
           <p:nvPr/>
         </p:nvSpPr>
         <p:spPr>
           <a:xfrm>
-            <a:off x="777240" y="3200400"/>
-            <a:ext cx="3271418" cy="457200"/>
+            <a:off x="777240" y="3081528"/>
+            <a:ext cx="3271418" cy="411480"/>
           </a:xfrm>
           <a:prstGeom prst="rect">
             <a:avLst/>
@@ -4350,11 +4596,11 @@
               </a:spcAft>
             </a:pPr>
             <a:r>
-              <a:rPr sz="1800" b="1">
+              <a:rPr sz="1700" b="1">
                 <a:solidFill>
-                  <a:srgbClr val="103A50"/>
+                  <a:srgbClr val="162133"/>
                 </a:solidFill>
-                <a:latin typeface="Calibri"/>
+                <a:latin typeface="Segoe UI Semibold"/>
               </a:rPr>
               <a:t>Swift</a:t>
             </a:r>
@@ -4363,13 +4609,57 @@
       </p:sp>
       <p:sp>
         <p:nvSpPr>
-          <p:cNvPr id="8" name="TextBox 7"/>
+          <p:cNvPr id="10" name="Rectangle 9"/>
+          <p:cNvSpPr/>
+          <p:nvPr/>
+        </p:nvSpPr>
+        <p:spPr>
+          <a:xfrm>
+            <a:off x="2156917" y="3483864"/>
+            <a:ext cx="512064" cy="31750"/>
+          </a:xfrm>
+          <a:prstGeom prst="rect">
+            <a:avLst/>
+          </a:prstGeom>
+          <a:solidFill>
+            <a:srgbClr val="2F80ED"/>
+          </a:solidFill>
+          <a:ln>
+            <a:noFill/>
+          </a:ln>
+          <a:effectLst/>
+        </p:spPr>
+        <p:style>
+          <a:lnRef idx="1">
+            <a:schemeClr val="accent1"/>
+          </a:lnRef>
+          <a:fillRef idx="3">
+            <a:schemeClr val="accent1"/>
+          </a:fillRef>
+          <a:effectRef idx="2">
+            <a:schemeClr val="accent1"/>
+          </a:effectRef>
+          <a:fontRef idx="minor">
+            <a:schemeClr val="lt1"/>
+          </a:fontRef>
+        </p:style>
+        <p:txBody>
+          <a:bodyPr rtlCol="0" anchor="ctr"/>
+          <a:lstStyle/>
+          <a:p>
+            <a:pPr algn="ctr"/>
+          </a:p>
+        </p:txBody>
+      </p:sp>
+      <p:sp>
+        <p:nvSpPr>
+          <p:cNvPr id="11" name="TextBox 10"/>
           <p:cNvSpPr txBox="1"/>
           <p:nvPr/>
         </p:nvSpPr>
         <p:spPr>
           <a:xfrm>
-            <a:off x="777240" y="3584448"/>
+            <a:off x="777240" y="3566160"/>
             <a:ext cx="3271418" cy="365760"/>
           </a:xfrm>
           <a:prstGeom prst="rect">
@@ -4395,39 +4685,39 @@
               </a:spcAft>
             </a:pPr>
             <a:r>
-              <a:rPr sz="1250" b="0">
+              <a:rPr sz="1200" b="0">
                 <a:solidFill>
                   <a:srgbClr val="6B7482"/>
                 </a:solidFill>
-                <a:latin typeface="Calibri"/>
+                <a:latin typeface="Segoe UI"/>
               </a:rPr>
-              <a:t>Sprache der App</a:t>
-            </a:r>
-          </a:p>
-        </p:txBody>
-      </p:sp>
-      <p:sp>
-        <p:nvSpPr>
-          <p:cNvPr id="9" name="Rounded Rectangle 8"/>
+              <a:t>Programmiersprache</a:t>
+            </a:r>
+          </a:p>
+        </p:txBody>
+      </p:sp>
+      <p:sp>
+        <p:nvSpPr>
+          <p:cNvPr id="12" name="Rounded Rectangle 11"/>
           <p:cNvSpPr/>
           <p:nvPr/>
         </p:nvSpPr>
         <p:spPr>
           <a:xfrm>
-            <a:off x="4460138" y="1828800"/>
-            <a:ext cx="3271418" cy="2148840"/>
+            <a:off x="4460138" y="1783080"/>
+            <a:ext cx="3271418" cy="2103120"/>
           </a:xfrm>
           <a:prstGeom prst="roundRect">
             <a:avLst>
-              <a:gd name="adj" fmla="val 6000"/>
+              <a:gd name="adj" fmla="val 5000"/>
             </a:avLst>
           </a:prstGeom>
           <a:solidFill>
-            <a:srgbClr val="F6F8FB"/>
+            <a:srgbClr val="F4F7FB"/>
           </a:solidFill>
           <a:ln w="12700">
             <a:solidFill>
-              <a:srgbClr val="DDE1E7"/>
+              <a:srgbClr val="E2E7EE"/>
             </a:solidFill>
           </a:ln>
           <a:effectLst/>
@@ -4456,7 +4746,7 @@
       </p:sp>
       <p:pic>
         <p:nvPicPr>
-          <p:cNvPr id="10" name="Picture 9" descr="swiftui.png"/>
+          <p:cNvPr id="13" name="Picture 12" descr="swiftui.png"/>
           <p:cNvPicPr>
             <a:picLocks noChangeAspect="1"/>
           </p:cNvPicPr>
@@ -4470,8 +4760,8 @@
         </p:blipFill>
         <p:spPr>
           <a:xfrm>
-            <a:off x="5638647" y="2121408"/>
-            <a:ext cx="914400" cy="914400"/>
+            <a:off x="5661507" y="2057400"/>
+            <a:ext cx="868680" cy="868680"/>
           </a:xfrm>
           <a:prstGeom prst="rect">
             <a:avLst/>
@@ -4480,14 +4770,14 @@
       </p:pic>
       <p:sp>
         <p:nvSpPr>
-          <p:cNvPr id="11" name="TextBox 10"/>
+          <p:cNvPr id="14" name="TextBox 13"/>
           <p:cNvSpPr txBox="1"/>
           <p:nvPr/>
         </p:nvSpPr>
         <p:spPr>
           <a:xfrm>
-            <a:off x="4460138" y="3200400"/>
-            <a:ext cx="3271418" cy="457200"/>
+            <a:off x="4460138" y="3081528"/>
+            <a:ext cx="3271418" cy="411480"/>
           </a:xfrm>
           <a:prstGeom prst="rect">
             <a:avLst/>
@@ -4512,11 +4802,11 @@
               </a:spcAft>
             </a:pPr>
             <a:r>
-              <a:rPr sz="1800" b="1">
+              <a:rPr sz="1700" b="1">
                 <a:solidFill>
-                  <a:srgbClr val="103A50"/>
+                  <a:srgbClr val="162133"/>
                 </a:solidFill>
-                <a:latin typeface="Calibri"/>
+                <a:latin typeface="Segoe UI Semibold"/>
               </a:rPr>
               <a:t>SwiftUI</a:t>
             </a:r>
@@ -4525,13 +4815,57 @@
       </p:sp>
       <p:sp>
         <p:nvSpPr>
-          <p:cNvPr id="12" name="TextBox 11"/>
+          <p:cNvPr id="15" name="Rectangle 14"/>
+          <p:cNvSpPr/>
+          <p:nvPr/>
+        </p:nvSpPr>
+        <p:spPr>
+          <a:xfrm>
+            <a:off x="5839815" y="3483864"/>
+            <a:ext cx="512064" cy="31750"/>
+          </a:xfrm>
+          <a:prstGeom prst="rect">
+            <a:avLst/>
+          </a:prstGeom>
+          <a:solidFill>
+            <a:srgbClr val="2F80ED"/>
+          </a:solidFill>
+          <a:ln>
+            <a:noFill/>
+          </a:ln>
+          <a:effectLst/>
+        </p:spPr>
+        <p:style>
+          <a:lnRef idx="1">
+            <a:schemeClr val="accent1"/>
+          </a:lnRef>
+          <a:fillRef idx="3">
+            <a:schemeClr val="accent1"/>
+          </a:fillRef>
+          <a:effectRef idx="2">
+            <a:schemeClr val="accent1"/>
+          </a:effectRef>
+          <a:fontRef idx="minor">
+            <a:schemeClr val="lt1"/>
+          </a:fontRef>
+        </p:style>
+        <p:txBody>
+          <a:bodyPr rtlCol="0" anchor="ctr"/>
+          <a:lstStyle/>
+          <a:p>
+            <a:pPr algn="ctr"/>
+          </a:p>
+        </p:txBody>
+      </p:sp>
+      <p:sp>
+        <p:nvSpPr>
+          <p:cNvPr id="16" name="TextBox 15"/>
           <p:cNvSpPr txBox="1"/>
           <p:nvPr/>
         </p:nvSpPr>
         <p:spPr>
           <a:xfrm>
-            <a:off x="4460138" y="3584448"/>
+            <a:off x="4460138" y="3566160"/>
             <a:ext cx="3271418" cy="365760"/>
           </a:xfrm>
           <a:prstGeom prst="rect">
@@ -4557,39 +4891,39 @@
               </a:spcAft>
             </a:pPr>
             <a:r>
-              <a:rPr sz="1250" b="0">
+              <a:rPr sz="1200" b="0">
                 <a:solidFill>
                   <a:srgbClr val="6B7482"/>
                 </a:solidFill>
-                <a:latin typeface="Calibri"/>
+                <a:latin typeface="Segoe UI"/>
               </a:rPr>
-              <a:t>Benutzeroberfläche</a:t>
-            </a:r>
-          </a:p>
-        </p:txBody>
-      </p:sp>
-      <p:sp>
-        <p:nvSpPr>
-          <p:cNvPr id="13" name="Rounded Rectangle 12"/>
+              <a:t>User Interface</a:t>
+            </a:r>
+          </a:p>
+        </p:txBody>
+      </p:sp>
+      <p:sp>
+        <p:nvSpPr>
+          <p:cNvPr id="17" name="Rounded Rectangle 16"/>
           <p:cNvSpPr/>
           <p:nvPr/>
         </p:nvSpPr>
         <p:spPr>
           <a:xfrm>
-            <a:off x="8143036" y="1828800"/>
-            <a:ext cx="3271418" cy="2148840"/>
+            <a:off x="8143036" y="1783080"/>
+            <a:ext cx="3271418" cy="2103120"/>
           </a:xfrm>
           <a:prstGeom prst="roundRect">
             <a:avLst>
-              <a:gd name="adj" fmla="val 6000"/>
+              <a:gd name="adj" fmla="val 5000"/>
             </a:avLst>
           </a:prstGeom>
           <a:solidFill>
-            <a:srgbClr val="F6F8FB"/>
+            <a:srgbClr val="F4F7FB"/>
           </a:solidFill>
           <a:ln w="12700">
             <a:solidFill>
-              <a:srgbClr val="DDE1E7"/>
+              <a:srgbClr val="E2E7EE"/>
             </a:solidFill>
           </a:ln>
           <a:effectLst/>
@@ -4618,7 +4952,7 @@
       </p:sp>
       <p:pic>
         <p:nvPicPr>
-          <p:cNvPr id="14" name="Picture 13" descr="wifi.png"/>
+          <p:cNvPr id="18" name="Picture 17" descr="cube3d.png"/>
           <p:cNvPicPr>
             <a:picLocks noChangeAspect="1"/>
           </p:cNvPicPr>
@@ -4632,8 +4966,8 @@
         </p:blipFill>
         <p:spPr>
           <a:xfrm>
-            <a:off x="9321546" y="2121408"/>
-            <a:ext cx="914400" cy="914400"/>
+            <a:off x="9344406" y="2057400"/>
+            <a:ext cx="868680" cy="868680"/>
           </a:xfrm>
           <a:prstGeom prst="rect">
             <a:avLst/>
@@ -4642,14 +4976,14 @@
       </p:pic>
       <p:sp>
         <p:nvSpPr>
-          <p:cNvPr id="15" name="TextBox 14"/>
+          <p:cNvPr id="19" name="TextBox 18"/>
           <p:cNvSpPr txBox="1"/>
           <p:nvPr/>
         </p:nvSpPr>
         <p:spPr>
           <a:xfrm>
-            <a:off x="8143036" y="3200400"/>
-            <a:ext cx="3271418" cy="457200"/>
+            <a:off x="8143036" y="3081528"/>
+            <a:ext cx="3271418" cy="411480"/>
           </a:xfrm>
           <a:prstGeom prst="rect">
             <a:avLst/>
@@ -4674,26 +5008,70 @@
               </a:spcAft>
             </a:pPr>
             <a:r>
-              <a:rPr sz="1800" b="1">
+              <a:rPr sz="1700" b="1">
                 <a:solidFill>
-                  <a:srgbClr val="103A50"/>
+                  <a:srgbClr val="162133"/>
                 </a:solidFill>
-                <a:latin typeface="Calibri"/>
+                <a:latin typeface="Segoe UI Semibold"/>
               </a:rPr>
-              <a:t>WLAN</a:t>
-            </a:r>
-          </a:p>
-        </p:txBody>
-      </p:sp>
-      <p:sp>
-        <p:nvSpPr>
-          <p:cNvPr id="16" name="TextBox 15"/>
+              <a:t>SceneKit</a:t>
+            </a:r>
+          </a:p>
+        </p:txBody>
+      </p:sp>
+      <p:sp>
+        <p:nvSpPr>
+          <p:cNvPr id="20" name="Rectangle 19"/>
+          <p:cNvSpPr/>
+          <p:nvPr/>
+        </p:nvSpPr>
+        <p:spPr>
+          <a:xfrm>
+            <a:off x="9522714" y="3483864"/>
+            <a:ext cx="512064" cy="31750"/>
+          </a:xfrm>
+          <a:prstGeom prst="rect">
+            <a:avLst/>
+          </a:prstGeom>
+          <a:solidFill>
+            <a:srgbClr val="2F80ED"/>
+          </a:solidFill>
+          <a:ln>
+            <a:noFill/>
+          </a:ln>
+          <a:effectLst/>
+        </p:spPr>
+        <p:style>
+          <a:lnRef idx="1">
+            <a:schemeClr val="accent1"/>
+          </a:lnRef>
+          <a:fillRef idx="3">
+            <a:schemeClr val="accent1"/>
+          </a:fillRef>
+          <a:effectRef idx="2">
+            <a:schemeClr val="accent1"/>
+          </a:effectRef>
+          <a:fontRef idx="minor">
+            <a:schemeClr val="lt1"/>
+          </a:fontRef>
+        </p:style>
+        <p:txBody>
+          <a:bodyPr rtlCol="0" anchor="ctr"/>
+          <a:lstStyle/>
+          <a:p>
+            <a:pPr algn="ctr"/>
+          </a:p>
+        </p:txBody>
+      </p:sp>
+      <p:sp>
+        <p:nvSpPr>
+          <p:cNvPr id="21" name="TextBox 20"/>
           <p:cNvSpPr txBox="1"/>
           <p:nvPr/>
         </p:nvSpPr>
         <p:spPr>
           <a:xfrm>
-            <a:off x="8143036" y="3584448"/>
+            <a:off x="8143036" y="3566160"/>
             <a:ext cx="3271418" cy="365760"/>
           </a:xfrm>
           <a:prstGeom prst="rect">
@@ -4719,39 +5097,39 @@
               </a:spcAft>
             </a:pPr>
             <a:r>
-              <a:rPr sz="1250" b="0">
+              <a:rPr sz="1200" b="0">
                 <a:solidFill>
                   <a:srgbClr val="6B7482"/>
                 </a:solidFill>
-                <a:latin typeface="Calibri"/>
+                <a:latin typeface="Segoe UI"/>
               </a:rPr>
-              <a:t>Findet die Drohne automatisch</a:t>
-            </a:r>
-          </a:p>
-        </p:txBody>
-      </p:sp>
-      <p:sp>
-        <p:nvSpPr>
-          <p:cNvPr id="17" name="Rounded Rectangle 16"/>
+              <a:t>3D-Flugsimulator</a:t>
+            </a:r>
+          </a:p>
+        </p:txBody>
+      </p:sp>
+      <p:sp>
+        <p:nvSpPr>
+          <p:cNvPr id="22" name="Rounded Rectangle 21"/>
           <p:cNvSpPr/>
           <p:nvPr/>
         </p:nvSpPr>
         <p:spPr>
           <a:xfrm>
-            <a:off x="777240" y="4233672"/>
-            <a:ext cx="3271418" cy="2148840"/>
+            <a:off x="777240" y="4142232"/>
+            <a:ext cx="3271418" cy="2103120"/>
           </a:xfrm>
           <a:prstGeom prst="roundRect">
             <a:avLst>
-              <a:gd name="adj" fmla="val 6000"/>
+              <a:gd name="adj" fmla="val 5000"/>
             </a:avLst>
           </a:prstGeom>
           <a:solidFill>
-            <a:srgbClr val="F6F8FB"/>
+            <a:srgbClr val="F4F7FB"/>
           </a:solidFill>
           <a:ln w="12700">
             <a:solidFill>
-              <a:srgbClr val="DDE1E7"/>
+              <a:srgbClr val="E2E7EE"/>
             </a:solidFill>
           </a:ln>
           <a:effectLst/>
@@ -4780,7 +5158,7 @@
       </p:sp>
       <p:pic>
         <p:nvPicPr>
-          <p:cNvPr id="18" name="Picture 17" descr="websocket.png"/>
+          <p:cNvPr id="23" name="Picture 22" descr="websocket.png"/>
           <p:cNvPicPr>
             <a:picLocks noChangeAspect="1"/>
           </p:cNvPicPr>
@@ -4794,8 +5172,8 @@
         </p:blipFill>
         <p:spPr>
           <a:xfrm>
-            <a:off x="1955749" y="4526280"/>
-            <a:ext cx="914400" cy="914400"/>
+            <a:off x="1978609" y="4416552"/>
+            <a:ext cx="868680" cy="868680"/>
           </a:xfrm>
           <a:prstGeom prst="rect">
             <a:avLst/>
@@ -4804,14 +5182,14 @@
       </p:pic>
       <p:sp>
         <p:nvSpPr>
-          <p:cNvPr id="19" name="TextBox 18"/>
+          <p:cNvPr id="24" name="TextBox 23"/>
           <p:cNvSpPr txBox="1"/>
           <p:nvPr/>
         </p:nvSpPr>
         <p:spPr>
           <a:xfrm>
-            <a:off x="777240" y="5605272"/>
-            <a:ext cx="3271418" cy="457200"/>
+            <a:off x="777240" y="5440680"/>
+            <a:ext cx="3271418" cy="411480"/>
           </a:xfrm>
           <a:prstGeom prst="rect">
             <a:avLst/>
@@ -4836,11 +5214,11 @@
               </a:spcAft>
             </a:pPr>
             <a:r>
-              <a:rPr sz="1800" b="1">
+              <a:rPr sz="1700" b="1">
                 <a:solidFill>
-                  <a:srgbClr val="103A50"/>
+                  <a:srgbClr val="162133"/>
                 </a:solidFill>
-                <a:latin typeface="Calibri"/>
+                <a:latin typeface="Segoe UI Semibold"/>
               </a:rPr>
               <a:t>WebSocket</a:t>
             </a:r>
@@ -4849,13 +5227,57 @@
       </p:sp>
       <p:sp>
         <p:nvSpPr>
-          <p:cNvPr id="20" name="TextBox 19"/>
+          <p:cNvPr id="25" name="Rectangle 24"/>
+          <p:cNvSpPr/>
+          <p:nvPr/>
+        </p:nvSpPr>
+        <p:spPr>
+          <a:xfrm>
+            <a:off x="2156917" y="5843016"/>
+            <a:ext cx="512064" cy="31750"/>
+          </a:xfrm>
+          <a:prstGeom prst="rect">
+            <a:avLst/>
+          </a:prstGeom>
+          <a:solidFill>
+            <a:srgbClr val="2F80ED"/>
+          </a:solidFill>
+          <a:ln>
+            <a:noFill/>
+          </a:ln>
+          <a:effectLst/>
+        </p:spPr>
+        <p:style>
+          <a:lnRef idx="1">
+            <a:schemeClr val="accent1"/>
+          </a:lnRef>
+          <a:fillRef idx="3">
+            <a:schemeClr val="accent1"/>
+          </a:fillRef>
+          <a:effectRef idx="2">
+            <a:schemeClr val="accent1"/>
+          </a:effectRef>
+          <a:fontRef idx="minor">
+            <a:schemeClr val="lt1"/>
+          </a:fontRef>
+        </p:style>
+        <p:txBody>
+          <a:bodyPr rtlCol="0" anchor="ctr"/>
+          <a:lstStyle/>
+          <a:p>
+            <a:pPr algn="ctr"/>
+          </a:p>
+        </p:txBody>
+      </p:sp>
+      <p:sp>
+        <p:nvSpPr>
+          <p:cNvPr id="26" name="TextBox 25"/>
           <p:cNvSpPr txBox="1"/>
           <p:nvPr/>
         </p:nvSpPr>
         <p:spPr>
           <a:xfrm>
-            <a:off x="777240" y="5989320"/>
+            <a:off x="777240" y="5925312"/>
             <a:ext cx="3271418" cy="365760"/>
           </a:xfrm>
           <a:prstGeom prst="rect">
@@ -4881,39 +5303,39 @@
               </a:spcAft>
             </a:pPr>
             <a:r>
-              <a:rPr sz="1250" b="0">
+              <a:rPr sz="1200" b="0">
                 <a:solidFill>
                   <a:srgbClr val="6B7482"/>
                 </a:solidFill>
-                <a:latin typeface="Calibri"/>
+                <a:latin typeface="Segoe UI"/>
               </a:rPr>
-              <a:t>Live-Verbindung zur Drohne</a:t>
-            </a:r>
-          </a:p>
-        </p:txBody>
-      </p:sp>
-      <p:sp>
-        <p:nvSpPr>
-          <p:cNvPr id="21" name="Rounded Rectangle 20"/>
+              <a:t>Live-Telemetrie · 10 Hz</a:t>
+            </a:r>
+          </a:p>
+        </p:txBody>
+      </p:sp>
+      <p:sp>
+        <p:nvSpPr>
+          <p:cNvPr id="27" name="Rounded Rectangle 26"/>
           <p:cNvSpPr/>
           <p:nvPr/>
         </p:nvSpPr>
         <p:spPr>
           <a:xfrm>
-            <a:off x="4460138" y="4233672"/>
-            <a:ext cx="3271418" cy="2148840"/>
+            <a:off x="4460138" y="4142232"/>
+            <a:ext cx="3271418" cy="2103120"/>
           </a:xfrm>
           <a:prstGeom prst="roundRect">
             <a:avLst>
-              <a:gd name="adj" fmla="val 6000"/>
+              <a:gd name="adj" fmla="val 5000"/>
             </a:avLst>
           </a:prstGeom>
           <a:solidFill>
-            <a:srgbClr val="F6F8FB"/>
+            <a:srgbClr val="F4F7FB"/>
           </a:solidFill>
           <a:ln w="12700">
             <a:solidFill>
-              <a:srgbClr val="DDE1E7"/>
+              <a:srgbClr val="E2E7EE"/>
             </a:solidFill>
           </a:ln>
           <a:effectLst/>
@@ -4942,7 +5364,7 @@
       </p:sp>
       <p:pic>
         <p:nvPicPr>
-          <p:cNvPr id="22" name="Picture 21" descr="cube3d.png"/>
+          <p:cNvPr id="28" name="Picture 27" descr="wifi.png"/>
           <p:cNvPicPr>
             <a:picLocks noChangeAspect="1"/>
           </p:cNvPicPr>
@@ -4956,8 +5378,8 @@
         </p:blipFill>
         <p:spPr>
           <a:xfrm>
-            <a:off x="5638647" y="4526280"/>
-            <a:ext cx="914400" cy="914400"/>
+            <a:off x="5661507" y="4416552"/>
+            <a:ext cx="868680" cy="868680"/>
           </a:xfrm>
           <a:prstGeom prst="rect">
             <a:avLst/>
@@ -4966,14 +5388,14 @@
       </p:pic>
       <p:sp>
         <p:nvSpPr>
-          <p:cNvPr id="23" name="TextBox 22"/>
+          <p:cNvPr id="29" name="TextBox 28"/>
           <p:cNvSpPr txBox="1"/>
           <p:nvPr/>
         </p:nvSpPr>
         <p:spPr>
           <a:xfrm>
-            <a:off x="4460138" y="5605272"/>
-            <a:ext cx="3271418" cy="457200"/>
+            <a:off x="4460138" y="5440680"/>
+            <a:ext cx="3271418" cy="411480"/>
           </a:xfrm>
           <a:prstGeom prst="rect">
             <a:avLst/>
@@ -4998,26 +5420,70 @@
               </a:spcAft>
             </a:pPr>
             <a:r>
-              <a:rPr sz="1800" b="1">
+              <a:rPr sz="1700" b="1">
                 <a:solidFill>
-                  <a:srgbClr val="103A50"/>
+                  <a:srgbClr val="162133"/>
                 </a:solidFill>
-                <a:latin typeface="Calibri"/>
+                <a:latin typeface="Segoe UI Semibold"/>
               </a:rPr>
-              <a:t>3D-Simulator</a:t>
-            </a:r>
-          </a:p>
-        </p:txBody>
-      </p:sp>
-      <p:sp>
-        <p:nvSpPr>
-          <p:cNvPr id="24" name="TextBox 23"/>
+              <a:t>Network.framework</a:t>
+            </a:r>
+          </a:p>
+        </p:txBody>
+      </p:sp>
+      <p:sp>
+        <p:nvSpPr>
+          <p:cNvPr id="30" name="Rectangle 29"/>
+          <p:cNvSpPr/>
+          <p:nvPr/>
+        </p:nvSpPr>
+        <p:spPr>
+          <a:xfrm>
+            <a:off x="5839815" y="5843016"/>
+            <a:ext cx="512064" cy="31750"/>
+          </a:xfrm>
+          <a:prstGeom prst="rect">
+            <a:avLst/>
+          </a:prstGeom>
+          <a:solidFill>
+            <a:srgbClr val="2F80ED"/>
+          </a:solidFill>
+          <a:ln>
+            <a:noFill/>
+          </a:ln>
+          <a:effectLst/>
+        </p:spPr>
+        <p:style>
+          <a:lnRef idx="1">
+            <a:schemeClr val="accent1"/>
+          </a:lnRef>
+          <a:fillRef idx="3">
+            <a:schemeClr val="accent1"/>
+          </a:fillRef>
+          <a:effectRef idx="2">
+            <a:schemeClr val="accent1"/>
+          </a:effectRef>
+          <a:fontRef idx="minor">
+            <a:schemeClr val="lt1"/>
+          </a:fontRef>
+        </p:style>
+        <p:txBody>
+          <a:bodyPr rtlCol="0" anchor="ctr"/>
+          <a:lstStyle/>
+          <a:p>
+            <a:pPr algn="ctr"/>
+          </a:p>
+        </p:txBody>
+      </p:sp>
+      <p:sp>
+        <p:nvSpPr>
+          <p:cNvPr id="31" name="TextBox 30"/>
           <p:cNvSpPr txBox="1"/>
           <p:nvPr/>
         </p:nvSpPr>
         <p:spPr>
           <a:xfrm>
-            <a:off x="4460138" y="5989320"/>
+            <a:off x="4460138" y="5925312"/>
             <a:ext cx="3271418" cy="365760"/>
           </a:xfrm>
           <a:prstGeom prst="rect">
@@ -5043,39 +5509,39 @@
               </a:spcAft>
             </a:pPr>
             <a:r>
-              <a:rPr sz="1250" b="0">
+              <a:rPr sz="1200" b="0">
                 <a:solidFill>
                   <a:srgbClr val="6B7482"/>
                 </a:solidFill>
-                <a:latin typeface="Calibri"/>
+                <a:latin typeface="Segoe UI"/>
               </a:rPr>
-              <a:t>Flugsimulator am iPhone</a:t>
-            </a:r>
-          </a:p>
-        </p:txBody>
-      </p:sp>
-      <p:sp>
-        <p:nvSpPr>
-          <p:cNvPr id="25" name="Rounded Rectangle 24"/>
+              <a:t>Auto-Discovery im WLAN</a:t>
+            </a:r>
+          </a:p>
+        </p:txBody>
+      </p:sp>
+      <p:sp>
+        <p:nvSpPr>
+          <p:cNvPr id="32" name="Rounded Rectangle 31"/>
           <p:cNvSpPr/>
           <p:nvPr/>
         </p:nvSpPr>
         <p:spPr>
           <a:xfrm>
-            <a:off x="8143036" y="4233672"/>
-            <a:ext cx="3271418" cy="2148840"/>
+            <a:off x="8143036" y="4142232"/>
+            <a:ext cx="3271418" cy="2103120"/>
           </a:xfrm>
           <a:prstGeom prst="roundRect">
             <a:avLst>
-              <a:gd name="adj" fmla="val 6000"/>
+              <a:gd name="adj" fmla="val 5000"/>
             </a:avLst>
           </a:prstGeom>
           <a:solidFill>
-            <a:srgbClr val="F6F8FB"/>
+            <a:srgbClr val="F4F7FB"/>
           </a:solidFill>
           <a:ln w="12700">
             <a:solidFill>
-              <a:srgbClr val="DDE1E7"/>
+              <a:srgbClr val="E2E7EE"/>
             </a:solidFill>
           </a:ln>
           <a:effectLst/>
@@ -5104,7 +5570,7 @@
       </p:sp>
       <p:pic>
         <p:nvPicPr>
-          <p:cNvPr id="26" name="Picture 25" descr="chip.png"/>
+          <p:cNvPr id="33" name="Picture 32" descr="chip.png"/>
           <p:cNvPicPr>
             <a:picLocks noChangeAspect="1"/>
           </p:cNvPicPr>
@@ -5118,8 +5584,8 @@
         </p:blipFill>
         <p:spPr>
           <a:xfrm>
-            <a:off x="9321546" y="4526280"/>
-            <a:ext cx="914400" cy="914400"/>
+            <a:off x="9344406" y="4416552"/>
+            <a:ext cx="868680" cy="868680"/>
           </a:xfrm>
           <a:prstGeom prst="rect">
             <a:avLst/>
@@ -5128,14 +5594,14 @@
       </p:pic>
       <p:sp>
         <p:nvSpPr>
-          <p:cNvPr id="27" name="TextBox 26"/>
+          <p:cNvPr id="34" name="TextBox 33"/>
           <p:cNvSpPr txBox="1"/>
           <p:nvPr/>
         </p:nvSpPr>
         <p:spPr>
           <a:xfrm>
-            <a:off x="8143036" y="5605272"/>
-            <a:ext cx="3271418" cy="457200"/>
+            <a:off x="8143036" y="5440680"/>
+            <a:ext cx="3271418" cy="411480"/>
           </a:xfrm>
           <a:prstGeom prst="rect">
             <a:avLst/>
@@ -5160,26 +5626,70 @@
               </a:spcAft>
             </a:pPr>
             <a:r>
-              <a:rPr sz="1800" b="1">
+              <a:rPr sz="1700" b="1">
                 <a:solidFill>
-                  <a:srgbClr val="103A50"/>
+                  <a:srgbClr val="162133"/>
                 </a:solidFill>
-                <a:latin typeface="Calibri"/>
+                <a:latin typeface="Segoe UI Semibold"/>
               </a:rPr>
-              <a:t>ESP32</a:t>
-            </a:r>
-          </a:p>
-        </p:txBody>
-      </p:sp>
-      <p:sp>
-        <p:nvSpPr>
-          <p:cNvPr id="28" name="TextBox 27"/>
+              <a:t>ESP32-C3</a:t>
+            </a:r>
+          </a:p>
+        </p:txBody>
+      </p:sp>
+      <p:sp>
+        <p:nvSpPr>
+          <p:cNvPr id="35" name="Rectangle 34"/>
+          <p:cNvSpPr/>
+          <p:nvPr/>
+        </p:nvSpPr>
+        <p:spPr>
+          <a:xfrm>
+            <a:off x="9522714" y="5843016"/>
+            <a:ext cx="512064" cy="31750"/>
+          </a:xfrm>
+          <a:prstGeom prst="rect">
+            <a:avLst/>
+          </a:prstGeom>
+          <a:solidFill>
+            <a:srgbClr val="2F80ED"/>
+          </a:solidFill>
+          <a:ln>
+            <a:noFill/>
+          </a:ln>
+          <a:effectLst/>
+        </p:spPr>
+        <p:style>
+          <a:lnRef idx="1">
+            <a:schemeClr val="accent1"/>
+          </a:lnRef>
+          <a:fillRef idx="3">
+            <a:schemeClr val="accent1"/>
+          </a:fillRef>
+          <a:effectRef idx="2">
+            <a:schemeClr val="accent1"/>
+          </a:effectRef>
+          <a:fontRef idx="minor">
+            <a:schemeClr val="lt1"/>
+          </a:fontRef>
+        </p:style>
+        <p:txBody>
+          <a:bodyPr rtlCol="0" anchor="ctr"/>
+          <a:lstStyle/>
+          <a:p>
+            <a:pPr algn="ctr"/>
+          </a:p>
+        </p:txBody>
+      </p:sp>
+      <p:sp>
+        <p:nvSpPr>
+          <p:cNvPr id="36" name="TextBox 35"/>
           <p:cNvSpPr txBox="1"/>
           <p:nvPr/>
         </p:nvSpPr>
         <p:spPr>
           <a:xfrm>
-            <a:off x="8143036" y="5989320"/>
+            <a:off x="8143036" y="5925312"/>
             <a:ext cx="3271418" cy="365760"/>
           </a:xfrm>
           <a:prstGeom prst="rect">
@@ -5205,11 +5715,11 @@
               </a:spcAft>
             </a:pPr>
             <a:r>
-              <a:rPr sz="1250" b="0">
+              <a:rPr sz="1200" b="0">
                 <a:solidFill>
                   <a:srgbClr val="6B7482"/>
                 </a:solidFill>
-                <a:latin typeface="Calibri"/>
+                <a:latin typeface="Segoe UI"/>
               </a:rPr>
               <a:t>Mikrocontroller der Drohne</a:t>
             </a:r>
@@ -5249,7 +5759,7 @@
             <a:avLst/>
           </a:prstGeom>
           <a:solidFill>
-            <a:srgbClr val="2C3649"/>
+            <a:srgbClr val="222B3C"/>
           </a:solidFill>
           <a:ln>
             <a:noFill/>
@@ -5280,14 +5790,58 @@
       </p:sp>
       <p:sp>
         <p:nvSpPr>
-          <p:cNvPr id="3" name="TextBox 2"/>
+          <p:cNvPr id="3" name="Rectangle 2"/>
+          <p:cNvSpPr/>
+          <p:nvPr/>
+        </p:nvSpPr>
+        <p:spPr>
+          <a:xfrm>
+            <a:off x="0" y="0"/>
+            <a:ext cx="146304" cy="6858000"/>
+          </a:xfrm>
+          <a:prstGeom prst="rect">
+            <a:avLst/>
+          </a:prstGeom>
+          <a:solidFill>
+            <a:srgbClr val="2F80ED"/>
+          </a:solidFill>
+          <a:ln>
+            <a:noFill/>
+          </a:ln>
+          <a:effectLst/>
+        </p:spPr>
+        <p:style>
+          <a:lnRef idx="1">
+            <a:schemeClr val="accent1"/>
+          </a:lnRef>
+          <a:fillRef idx="3">
+            <a:schemeClr val="accent1"/>
+          </a:fillRef>
+          <a:effectRef idx="2">
+            <a:schemeClr val="accent1"/>
+          </a:effectRef>
+          <a:fontRef idx="minor">
+            <a:schemeClr val="lt1"/>
+          </a:fontRef>
+        </p:style>
+        <p:txBody>
+          <a:bodyPr rtlCol="0" anchor="ctr"/>
+          <a:lstStyle/>
+          <a:p>
+            <a:pPr algn="ctr"/>
+          </a:p>
+        </p:txBody>
+      </p:sp>
+      <p:sp>
+        <p:nvSpPr>
+          <p:cNvPr id="4" name="TextBox 3"/>
           <p:cNvSpPr txBox="1"/>
           <p:nvPr/>
         </p:nvSpPr>
         <p:spPr>
           <a:xfrm>
-            <a:off x="868680" y="0"/>
-            <a:ext cx="8229600" cy="6858000"/>
+            <a:off x="868680" y="2468880"/>
+            <a:ext cx="7315200" cy="457200"/>
           </a:xfrm>
           <a:prstGeom prst="rect">
             <a:avLst/>
@@ -5295,7 +5849,7 @@
           <a:noFill/>
         </p:spPr>
         <p:txBody>
-          <a:bodyPr wrap="square" anchor="ctr" lIns="0" rIns="0" tIns="0" bIns="0">
+          <a:bodyPr wrap="square" anchor="t" lIns="0" rIns="0" tIns="0" bIns="0">
             <a:spAutoFit/>
           </a:bodyPr>
           <a:lstStyle/>
@@ -5312,11 +5866,56 @@
               </a:spcAft>
             </a:pPr>
             <a:r>
-              <a:rPr sz="6400" b="0">
+              <a:rPr sz="1400" b="1">
+                <a:solidFill>
+                  <a:srgbClr val="2F80ED"/>
+                </a:solidFill>
+                <a:latin typeface="Segoe UI Semibold"/>
+              </a:rPr>
+              <a:t>04  ·  DEMO</a:t>
+            </a:r>
+          </a:p>
+        </p:txBody>
+      </p:sp>
+      <p:sp>
+        <p:nvSpPr>
+          <p:cNvPr id="5" name="TextBox 4"/>
+          <p:cNvSpPr txBox="1"/>
+          <p:nvPr/>
+        </p:nvSpPr>
+        <p:spPr>
+          <a:xfrm>
+            <a:off x="822960" y="2926080"/>
+            <a:ext cx="9144000" cy="1280160"/>
+          </a:xfrm>
+          <a:prstGeom prst="rect">
+            <a:avLst/>
+          </a:prstGeom>
+          <a:noFill/>
+        </p:spPr>
+        <p:txBody>
+          <a:bodyPr wrap="square" anchor="t" lIns="0" rIns="0" tIns="0" bIns="0">
+            <a:spAutoFit/>
+          </a:bodyPr>
+          <a:lstStyle/>
+          <a:p>
+            <a:pPr algn="l">
+              <a:lnSpc>
+                <a:spcPct val="100000"/>
+              </a:lnSpc>
+              <a:spcBef>
+                <a:spcPts val="0"/>
+              </a:spcBef>
+              <a:spcAft>
+                <a:spcPts val="800"/>
+              </a:spcAft>
+            </a:pPr>
+            <a:r>
+              <a:rPr sz="6600" b="1">
                 <a:solidFill>
                   <a:srgbClr val="FFFFFF"/>
                 </a:solidFill>
-                <a:latin typeface="Georgia"/>
+                <a:latin typeface="Segoe UI Semibold"/>
               </a:rPr>
               <a:t>Live Demo</a:t>
             </a:r>
@@ -5325,14 +5924,14 @@
       </p:sp>
       <p:sp>
         <p:nvSpPr>
-          <p:cNvPr id="4" name="Rectangle 3"/>
+          <p:cNvPr id="6" name="Rectangle 5"/>
           <p:cNvSpPr/>
           <p:nvPr/>
         </p:nvSpPr>
         <p:spPr>
           <a:xfrm>
-            <a:off x="914400" y="4160520"/>
-            <a:ext cx="2011680" cy="44450"/>
+            <a:off x="868680" y="4343400"/>
+            <a:ext cx="1463040" cy="50800"/>
           </a:xfrm>
           <a:prstGeom prst="rect">
             <a:avLst/>

</xml_diff>

<commit_message>
docs: accurate content + architecture diagram for EasyPilot iOS deck
- Drone is described as a commercial drone modified with an ESP32 (not built
  from scratch); removed the claim that sending flight commands works (WIP).
- Added CoreMotion (phone gyroscope) incl. a gyro icon.
- Slide 2 reworked into a 2x2 fact grid with a divider through the section.
- Slide 3 is now an architecture diagram showing how the technologies work
  together: ESP32-C3 (WebSocket/UDP) -> WLAN -> iPhone app (Swift/SwiftUI,
  Network.framework, SceneKit, CoreMotion).

Co-Authored-By: Claude Opus 4.8 <noreply@anthropic.com>
</commit_message>
<xml_diff>
--- a/docs/presentation-ios/EasyPilot-iOS.pptx
+++ b/docs/presentation-ios/EasyPilot-iOS.pptx
@@ -3384,7 +3384,7 @@
                 </a:solidFill>
                 <a:latin typeface="Segoe UI"/>
               </a:rPr>
-              <a:t>selbst im WLAN, zeigt Live-Telemetrie und fliegt einen 3D-Flugsimulator.</a:t>
+              <a:t>selbst im WLAN, zeigt Live-Telemetrie und einen 3D-Flugsimulator.</a:t>
             </a:r>
           </a:p>
         </p:txBody>
@@ -3698,210 +3698,23 @@
       </p:sp>
       <p:sp>
         <p:nvSpPr>
-          <p:cNvPr id="7" name="TextBox 6"/>
-          <p:cNvSpPr txBox="1"/>
+          <p:cNvPr id="7" name="Rectangle 6"/>
+          <p:cNvSpPr/>
           <p:nvPr/>
         </p:nvSpPr>
         <p:spPr>
           <a:xfrm>
-            <a:off x="777240" y="1783080"/>
-            <a:ext cx="5760720" cy="4389120"/>
+            <a:off x="868680" y="2185416"/>
+            <a:ext cx="256032" cy="256032"/>
           </a:xfrm>
           <a:prstGeom prst="rect">
             <a:avLst/>
           </a:prstGeom>
-          <a:noFill/>
-        </p:spPr>
-        <p:txBody>
-          <a:bodyPr wrap="square" anchor="t" lIns="0" rIns="0" tIns="0" bIns="0">
-            <a:spAutoFit/>
-          </a:bodyPr>
-          <a:lstStyle/>
-          <a:p>
-            <a:pPr algn="l">
-              <a:lnSpc>
-                <a:spcPct val="110000"/>
-              </a:lnSpc>
-              <a:spcBef>
-                <a:spcPts val="0"/>
-              </a:spcBef>
-              <a:spcAft>
-                <a:spcPts val="1600"/>
-              </a:spcAft>
-            </a:pPr>
-            <a:r>
-              <a:rPr sz="1500" b="1">
-                <a:solidFill>
-                  <a:srgbClr val="2F80ED"/>
-                </a:solidFill>
-                <a:latin typeface="Segoe UI"/>
-              </a:rPr>
-              <a:t>▪  </a:t>
-            </a:r>
-            <a:r>
-              <a:rPr sz="1650" b="0">
-                <a:solidFill>
-                  <a:srgbClr val="2B3340"/>
-                </a:solidFill>
-                <a:latin typeface="Segoe UI"/>
-              </a:rPr>
-              <a:t>EasyPilot ist unser 4AHITM-Drohnenprojekt: eine selbstgebaute Drohne mit ESP32-Steuerung.</a:t>
-            </a:r>
-          </a:p>
-          <a:p>
-            <a:pPr algn="l">
-              <a:lnSpc>
-                <a:spcPct val="110000"/>
-              </a:lnSpc>
-              <a:spcBef>
-                <a:spcPts val="0"/>
-              </a:spcBef>
-              <a:spcAft>
-                <a:spcPts val="1600"/>
-              </a:spcAft>
-            </a:pPr>
-            <a:r>
-              <a:rPr sz="1500" b="1">
-                <a:solidFill>
-                  <a:srgbClr val="2F80ED"/>
-                </a:solidFill>
-                <a:latin typeface="Segoe UI"/>
-              </a:rPr>
-              <a:t>▪  </a:t>
-            </a:r>
-            <a:r>
-              <a:rPr sz="1650" b="0">
-                <a:solidFill>
-                  <a:srgbClr val="2B3340"/>
-                </a:solidFill>
-                <a:latin typeface="Segoe UI"/>
-              </a:rPr>
-              <a:t>Die iOS-App ist der mobile Co-Pilot – komplett in SwiftUI, nur mit Apple-Frameworks.</a:t>
-            </a:r>
-          </a:p>
-          <a:p>
-            <a:pPr algn="l">
-              <a:lnSpc>
-                <a:spcPct val="110000"/>
-              </a:lnSpc>
-              <a:spcBef>
-                <a:spcPts val="0"/>
-              </a:spcBef>
-              <a:spcAft>
-                <a:spcPts val="1600"/>
-              </a:spcAft>
-            </a:pPr>
-            <a:r>
-              <a:rPr sz="1500" b="1">
-                <a:solidFill>
-                  <a:srgbClr val="2F80ED"/>
-                </a:solidFill>
-                <a:latin typeface="Segoe UI"/>
-              </a:rPr>
-              <a:t>▪  </a:t>
-            </a:r>
-            <a:r>
-              <a:rPr sz="1650" b="0">
-                <a:solidFill>
-                  <a:srgbClr val="2B3340"/>
-                </a:solidFill>
-                <a:latin typeface="Segoe UI"/>
-              </a:rPr>
-              <a:t>Sie findet die Drohne automatisch im WLAN – ohne Eintippen einer IP-Adresse.</a:t>
-            </a:r>
-          </a:p>
-          <a:p>
-            <a:pPr algn="l">
-              <a:lnSpc>
-                <a:spcPct val="110000"/>
-              </a:lnSpc>
-              <a:spcBef>
-                <a:spcPts val="0"/>
-              </a:spcBef>
-              <a:spcAft>
-                <a:spcPts val="1600"/>
-              </a:spcAft>
-            </a:pPr>
-            <a:r>
-              <a:rPr sz="1500" b="1">
-                <a:solidFill>
-                  <a:srgbClr val="2F80ED"/>
-                </a:solidFill>
-                <a:latin typeface="Segoe UI"/>
-              </a:rPr>
-              <a:t>▪  </a:t>
-            </a:r>
-            <a:r>
-              <a:rPr sz="1650" b="0">
-                <a:solidFill>
-                  <a:srgbClr val="2B3340"/>
-                </a:solidFill>
-                <a:latin typeface="Segoe UI"/>
-              </a:rPr>
-              <a:t>Live-Telemetrie mit 10 Hz, ein 3D-Flugsimulator und das Senden von Flugbefehlen – alles auf dem iPhone.</a:t>
-            </a:r>
-          </a:p>
-        </p:txBody>
-      </p:sp>
-      <p:cxnSp>
-        <p:nvCxnSpPr>
-          <p:cNvPr id="8" name="Connector 7"/>
-          <p:cNvCxnSpPr/>
-          <p:nvPr/>
-        </p:nvCxnSpPr>
-        <p:spPr>
-          <a:xfrm>
-            <a:off x="6903720" y="1874519"/>
-            <a:ext cx="0" cy="4206240"/>
-          </a:xfrm>
-          <a:prstGeom prst="line">
-            <a:avLst/>
-          </a:prstGeom>
-          <a:ln w="22225">
-            <a:solidFill>
-              <a:srgbClr val="2F80ED"/>
-            </a:solidFill>
-          </a:ln>
-          <a:effectLst/>
-        </p:spPr>
-        <p:style>
-          <a:lnRef idx="2">
-            <a:schemeClr val="accent1"/>
-          </a:lnRef>
-          <a:fillRef idx="0">
-            <a:schemeClr val="accent1"/>
-          </a:fillRef>
-          <a:effectRef idx="1">
-            <a:schemeClr val="accent1"/>
-          </a:effectRef>
-          <a:fontRef idx="minor">
-            <a:schemeClr val="tx1"/>
-          </a:fontRef>
-        </p:style>
-      </p:cxnSp>
-      <p:sp>
-        <p:nvSpPr>
-          <p:cNvPr id="9" name="Rounded Rectangle 8"/>
-          <p:cNvSpPr/>
-          <p:nvPr/>
-        </p:nvSpPr>
-        <p:spPr>
-          <a:xfrm>
-            <a:off x="7406640" y="2148840"/>
-            <a:ext cx="3931920" cy="1097280"/>
-          </a:xfrm>
-          <a:prstGeom prst="roundRect">
-            <a:avLst>
-              <a:gd name="adj" fmla="val 10000"/>
-            </a:avLst>
-          </a:prstGeom>
           <a:solidFill>
-            <a:srgbClr val="F4F7FB"/>
+            <a:srgbClr val="2F80ED"/>
           </a:solidFill>
-          <a:ln w="22225">
-            <a:solidFill>
-              <a:srgbClr val="2F80ED"/>
-            </a:solidFill>
+          <a:ln>
+            <a:noFill/>
           </a:ln>
           <a:effectLst/>
         </p:spPr>
@@ -3929,14 +3742,14 @@
       </p:sp>
       <p:sp>
         <p:nvSpPr>
-          <p:cNvPr id="10" name="TextBox 9"/>
+          <p:cNvPr id="8" name="TextBox 7"/>
           <p:cNvSpPr txBox="1"/>
           <p:nvPr/>
         </p:nvSpPr>
         <p:spPr>
           <a:xfrm>
-            <a:off x="7406640" y="2148840"/>
-            <a:ext cx="3931920" cy="1097280"/>
+            <a:off x="1280160" y="2103120"/>
+            <a:ext cx="4480560" cy="457200"/>
           </a:xfrm>
           <a:prstGeom prst="rect">
             <a:avLst/>
@@ -3944,12 +3757,12 @@
           <a:noFill/>
         </p:spPr>
         <p:txBody>
-          <a:bodyPr wrap="square" anchor="ctr" lIns="0" rIns="0" tIns="0" bIns="0">
+          <a:bodyPr wrap="square" anchor="t" lIns="0" rIns="0" tIns="0" bIns="0">
             <a:spAutoFit/>
           </a:bodyPr>
           <a:lstStyle/>
           <a:p>
-            <a:pPr algn="ctr">
+            <a:pPr algn="l">
               <a:lnSpc>
                 <a:spcPct val="100000"/>
               </a:lnSpc>
@@ -3957,21 +3770,133 @@
                 <a:spcPts val="0"/>
               </a:spcBef>
               <a:spcAft>
-                <a:spcPts val="200"/>
+                <a:spcPts val="800"/>
               </a:spcAft>
             </a:pPr>
             <a:r>
-              <a:rPr sz="1800" b="1">
+              <a:rPr sz="2100" b="1">
                 <a:solidFill>
                   <a:srgbClr val="162133"/>
                 </a:solidFill>
                 <a:latin typeface="Segoe UI Semibold"/>
               </a:rPr>
-              <a:t>iPhone</a:t>
-            </a:r>
-          </a:p>
-          <a:p>
-            <a:pPr algn="ctr">
+              <a:t>Modifizierte Drohne</a:t>
+            </a:r>
+          </a:p>
+        </p:txBody>
+      </p:sp>
+      <p:sp>
+        <p:nvSpPr>
+          <p:cNvPr id="9" name="TextBox 8"/>
+          <p:cNvSpPr txBox="1"/>
+          <p:nvPr/>
+        </p:nvSpPr>
+        <p:spPr>
+          <a:xfrm>
+            <a:off x="1280160" y="2624328"/>
+            <a:ext cx="4526280" cy="1371600"/>
+          </a:xfrm>
+          <a:prstGeom prst="rect">
+            <a:avLst/>
+          </a:prstGeom>
+          <a:noFill/>
+        </p:spPr>
+        <p:txBody>
+          <a:bodyPr wrap="square" anchor="t" lIns="0" rIns="0" tIns="0" bIns="0">
+            <a:spAutoFit/>
+          </a:bodyPr>
+          <a:lstStyle/>
+          <a:p>
+            <a:pPr algn="l">
+              <a:lnSpc>
+                <a:spcPct val="114000"/>
+              </a:lnSpc>
+              <a:spcBef>
+                <a:spcPts val="0"/>
+              </a:spcBef>
+              <a:spcAft>
+                <a:spcPts val="800"/>
+              </a:spcAft>
+            </a:pPr>
+            <a:r>
+              <a:rPr sz="1600" b="0">
+                <a:solidFill>
+                  <a:srgbClr val="2B3340"/>
+                </a:solidFill>
+                <a:latin typeface="Segoe UI"/>
+              </a:rPr>
+              <a:t>Eine handelsübliche Drohne, die wir mit einem ESP32 erweitert haben – nicht selbstgebaut.</a:t>
+            </a:r>
+          </a:p>
+        </p:txBody>
+      </p:sp>
+      <p:sp>
+        <p:nvSpPr>
+          <p:cNvPr id="10" name="Rectangle 9"/>
+          <p:cNvSpPr/>
+          <p:nvPr/>
+        </p:nvSpPr>
+        <p:spPr>
+          <a:xfrm>
+            <a:off x="6537960" y="2185416"/>
+            <a:ext cx="256032" cy="256032"/>
+          </a:xfrm>
+          <a:prstGeom prst="rect">
+            <a:avLst/>
+          </a:prstGeom>
+          <a:solidFill>
+            <a:srgbClr val="2F80ED"/>
+          </a:solidFill>
+          <a:ln>
+            <a:noFill/>
+          </a:ln>
+          <a:effectLst/>
+        </p:spPr>
+        <p:style>
+          <a:lnRef idx="1">
+            <a:schemeClr val="accent1"/>
+          </a:lnRef>
+          <a:fillRef idx="3">
+            <a:schemeClr val="accent1"/>
+          </a:fillRef>
+          <a:effectRef idx="2">
+            <a:schemeClr val="accent1"/>
+          </a:effectRef>
+          <a:fontRef idx="minor">
+            <a:schemeClr val="lt1"/>
+          </a:fontRef>
+        </p:style>
+        <p:txBody>
+          <a:bodyPr rtlCol="0" anchor="ctr"/>
+          <a:lstStyle/>
+          <a:p>
+            <a:pPr algn="ctr"/>
+          </a:p>
+        </p:txBody>
+      </p:sp>
+      <p:sp>
+        <p:nvSpPr>
+          <p:cNvPr id="11" name="TextBox 10"/>
+          <p:cNvSpPr txBox="1"/>
+          <p:nvPr/>
+        </p:nvSpPr>
+        <p:spPr>
+          <a:xfrm>
+            <a:off x="6949440" y="2103120"/>
+            <a:ext cx="4480560" cy="457200"/>
+          </a:xfrm>
+          <a:prstGeom prst="rect">
+            <a:avLst/>
+          </a:prstGeom>
+          <a:noFill/>
+        </p:spPr>
+        <p:txBody>
+          <a:bodyPr wrap="square" anchor="t" lIns="0" rIns="0" tIns="0" bIns="0">
+            <a:spAutoFit/>
+          </a:bodyPr>
+          <a:lstStyle/>
+          <a:p>
+            <a:pPr algn="l">
               <a:lnSpc>
                 <a:spcPct val="100000"/>
               </a:lnSpc>
@@ -3979,44 +3904,85 @@
                 <a:spcPts val="0"/>
               </a:spcBef>
               <a:spcAft>
-                <a:spcPts val="200"/>
+                <a:spcPts val="800"/>
               </a:spcAft>
             </a:pPr>
             <a:r>
-              <a:rPr sz="1200" b="0">
+              <a:rPr sz="2100" b="1">
                 <a:solidFill>
-                  <a:srgbClr val="6B7482"/>
+                  <a:srgbClr val="162133"/>
+                </a:solidFill>
+                <a:latin typeface="Segoe UI Semibold"/>
+              </a:rPr>
+              <a:t>SwiftUI-App</a:t>
+            </a:r>
+          </a:p>
+        </p:txBody>
+      </p:sp>
+      <p:sp>
+        <p:nvSpPr>
+          <p:cNvPr id="12" name="TextBox 11"/>
+          <p:cNvSpPr txBox="1"/>
+          <p:nvPr/>
+        </p:nvSpPr>
+        <p:spPr>
+          <a:xfrm>
+            <a:off x="6949440" y="2624328"/>
+            <a:ext cx="4526280" cy="1371600"/>
+          </a:xfrm>
+          <a:prstGeom prst="rect">
+            <a:avLst/>
+          </a:prstGeom>
+          <a:noFill/>
+        </p:spPr>
+        <p:txBody>
+          <a:bodyPr wrap="square" anchor="t" lIns="0" rIns="0" tIns="0" bIns="0">
+            <a:spAutoFit/>
+          </a:bodyPr>
+          <a:lstStyle/>
+          <a:p>
+            <a:pPr algn="l">
+              <a:lnSpc>
+                <a:spcPct val="114000"/>
+              </a:lnSpc>
+              <a:spcBef>
+                <a:spcPts val="0"/>
+              </a:spcBef>
+              <a:spcAft>
+                <a:spcPts val="800"/>
+              </a:spcAft>
+            </a:pPr>
+            <a:r>
+              <a:rPr sz="1600" b="0">
+                <a:solidFill>
+                  <a:srgbClr val="2B3340"/>
                 </a:solidFill>
                 <a:latin typeface="Segoe UI"/>
               </a:rPr>
-              <a:t>EasyPilot App (SwiftUI)</a:t>
-            </a:r>
-          </a:p>
-        </p:txBody>
-      </p:sp>
-      <p:sp>
-        <p:nvSpPr>
-          <p:cNvPr id="11" name="Rounded Rectangle 10"/>
+              <a:t>Der mobile Co-Pilot, komplett in SwiftUI gebaut – nur mit Apple-Frameworks.</a:t>
+            </a:r>
+          </a:p>
+        </p:txBody>
+      </p:sp>
+      <p:sp>
+        <p:nvSpPr>
+          <p:cNvPr id="13" name="Rectangle 12"/>
           <p:cNvSpPr/>
           <p:nvPr/>
         </p:nvSpPr>
         <p:spPr>
           <a:xfrm>
-            <a:off x="7406640" y="4846320"/>
-            <a:ext cx="3931920" cy="1097280"/>
-          </a:xfrm>
-          <a:prstGeom prst="roundRect">
-            <a:avLst>
-              <a:gd name="adj" fmla="val 10000"/>
-            </a:avLst>
+            <a:off x="868680" y="4288536"/>
+            <a:ext cx="256032" cy="256032"/>
+          </a:xfrm>
+          <a:prstGeom prst="rect">
+            <a:avLst/>
           </a:prstGeom>
           <a:solidFill>
-            <a:srgbClr val="F4F7FB"/>
+            <a:srgbClr val="2F80ED"/>
           </a:solidFill>
-          <a:ln w="22225">
-            <a:solidFill>
-              <a:srgbClr val="222B3C"/>
-            </a:solidFill>
+          <a:ln>
+            <a:noFill/>
           </a:ln>
           <a:effectLst/>
         </p:spPr>
@@ -4044,14 +4010,14 @@
       </p:sp>
       <p:sp>
         <p:nvSpPr>
-          <p:cNvPr id="12" name="TextBox 11"/>
+          <p:cNvPr id="14" name="TextBox 13"/>
           <p:cNvSpPr txBox="1"/>
           <p:nvPr/>
         </p:nvSpPr>
         <p:spPr>
           <a:xfrm>
-            <a:off x="7406640" y="4846320"/>
-            <a:ext cx="3931920" cy="1097280"/>
+            <a:off x="1280160" y="4206240"/>
+            <a:ext cx="4480560" cy="457200"/>
           </a:xfrm>
           <a:prstGeom prst="rect">
             <a:avLst/>
@@ -4059,12 +4025,12 @@
           <a:noFill/>
         </p:spPr>
         <p:txBody>
-          <a:bodyPr wrap="square" anchor="ctr" lIns="0" rIns="0" tIns="0" bIns="0">
+          <a:bodyPr wrap="square" anchor="t" lIns="0" rIns="0" tIns="0" bIns="0">
             <a:spAutoFit/>
           </a:bodyPr>
           <a:lstStyle/>
           <a:p>
-            <a:pPr algn="ctr">
+            <a:pPr algn="l">
               <a:lnSpc>
                 <a:spcPct val="100000"/>
               </a:lnSpc>
@@ -4072,21 +4038,133 @@
                 <a:spcPts val="0"/>
               </a:spcBef>
               <a:spcAft>
-                <a:spcPts val="200"/>
+                <a:spcPts val="800"/>
               </a:spcAft>
             </a:pPr>
             <a:r>
-              <a:rPr sz="1800" b="1">
+              <a:rPr sz="2100" b="1">
                 <a:solidFill>
                   <a:srgbClr val="162133"/>
                 </a:solidFill>
                 <a:latin typeface="Segoe UI Semibold"/>
               </a:rPr>
-              <a:t>ESP32-C3</a:t>
-            </a:r>
-          </a:p>
-          <a:p>
-            <a:pPr algn="ctr">
+              <a:t>Auto-Discovery</a:t>
+            </a:r>
+          </a:p>
+        </p:txBody>
+      </p:sp>
+      <p:sp>
+        <p:nvSpPr>
+          <p:cNvPr id="15" name="TextBox 14"/>
+          <p:cNvSpPr txBox="1"/>
+          <p:nvPr/>
+        </p:nvSpPr>
+        <p:spPr>
+          <a:xfrm>
+            <a:off x="1280160" y="4727448"/>
+            <a:ext cx="4526280" cy="1371600"/>
+          </a:xfrm>
+          <a:prstGeom prst="rect">
+            <a:avLst/>
+          </a:prstGeom>
+          <a:noFill/>
+        </p:spPr>
+        <p:txBody>
+          <a:bodyPr wrap="square" anchor="t" lIns="0" rIns="0" tIns="0" bIns="0">
+            <a:spAutoFit/>
+          </a:bodyPr>
+          <a:lstStyle/>
+          <a:p>
+            <a:pPr algn="l">
+              <a:lnSpc>
+                <a:spcPct val="114000"/>
+              </a:lnSpc>
+              <a:spcBef>
+                <a:spcPts val="0"/>
+              </a:spcBef>
+              <a:spcAft>
+                <a:spcPts val="800"/>
+              </a:spcAft>
+            </a:pPr>
+            <a:r>
+              <a:rPr sz="1600" b="0">
+                <a:solidFill>
+                  <a:srgbClr val="2B3340"/>
+                </a:solidFill>
+                <a:latin typeface="Segoe UI"/>
+              </a:rPr>
+              <a:t>Findet die Drohne automatisch im WLAN – ohne Eintippen einer IP-Adresse.</a:t>
+            </a:r>
+          </a:p>
+        </p:txBody>
+      </p:sp>
+      <p:sp>
+        <p:nvSpPr>
+          <p:cNvPr id="16" name="Rectangle 15"/>
+          <p:cNvSpPr/>
+          <p:nvPr/>
+        </p:nvSpPr>
+        <p:spPr>
+          <a:xfrm>
+            <a:off x="6537960" y="4288536"/>
+            <a:ext cx="256032" cy="256032"/>
+          </a:xfrm>
+          <a:prstGeom prst="rect">
+            <a:avLst/>
+          </a:prstGeom>
+          <a:solidFill>
+            <a:srgbClr val="2F80ED"/>
+          </a:solidFill>
+          <a:ln>
+            <a:noFill/>
+          </a:ln>
+          <a:effectLst/>
+        </p:spPr>
+        <p:style>
+          <a:lnRef idx="1">
+            <a:schemeClr val="accent1"/>
+          </a:lnRef>
+          <a:fillRef idx="3">
+            <a:schemeClr val="accent1"/>
+          </a:fillRef>
+          <a:effectRef idx="2">
+            <a:schemeClr val="accent1"/>
+          </a:effectRef>
+          <a:fontRef idx="minor">
+            <a:schemeClr val="lt1"/>
+          </a:fontRef>
+        </p:style>
+        <p:txBody>
+          <a:bodyPr rtlCol="0" anchor="ctr"/>
+          <a:lstStyle/>
+          <a:p>
+            <a:pPr algn="ctr"/>
+          </a:p>
+        </p:txBody>
+      </p:sp>
+      <p:sp>
+        <p:nvSpPr>
+          <p:cNvPr id="17" name="TextBox 16"/>
+          <p:cNvSpPr txBox="1"/>
+          <p:nvPr/>
+        </p:nvSpPr>
+        <p:spPr>
+          <a:xfrm>
+            <a:off x="6949440" y="4206240"/>
+            <a:ext cx="4480560" cy="457200"/>
+          </a:xfrm>
+          <a:prstGeom prst="rect">
+            <a:avLst/>
+          </a:prstGeom>
+          <a:noFill/>
+        </p:spPr>
+        <p:txBody>
+          <a:bodyPr wrap="square" anchor="t" lIns="0" rIns="0" tIns="0" bIns="0">
+            <a:spAutoFit/>
+          </a:bodyPr>
+          <a:lstStyle/>
+          <a:p>
+            <a:pPr algn="l">
               <a:lnSpc>
                 <a:spcPct val="100000"/>
               </a:lnSpc>
@@ -4094,40 +4172,84 @@
                 <a:spcPts val="0"/>
               </a:spcBef>
               <a:spcAft>
-                <a:spcPts val="200"/>
+                <a:spcPts val="800"/>
               </a:spcAft>
             </a:pPr>
             <a:r>
-              <a:rPr sz="1200" b="0">
+              <a:rPr sz="2100" b="1">
                 <a:solidFill>
-                  <a:srgbClr val="6B7482"/>
+                  <a:srgbClr val="162133"/>
+                </a:solidFill>
+                <a:latin typeface="Segoe UI Semibold"/>
+              </a:rPr>
+              <a:t>Live am iPhone</a:t>
+            </a:r>
+          </a:p>
+        </p:txBody>
+      </p:sp>
+      <p:sp>
+        <p:nvSpPr>
+          <p:cNvPr id="18" name="TextBox 17"/>
+          <p:cNvSpPr txBox="1"/>
+          <p:nvPr/>
+        </p:nvSpPr>
+        <p:spPr>
+          <a:xfrm>
+            <a:off x="6949440" y="4727448"/>
+            <a:ext cx="4526280" cy="1371600"/>
+          </a:xfrm>
+          <a:prstGeom prst="rect">
+            <a:avLst/>
+          </a:prstGeom>
+          <a:noFill/>
+        </p:spPr>
+        <p:txBody>
+          <a:bodyPr wrap="square" anchor="t" lIns="0" rIns="0" tIns="0" bIns="0">
+            <a:spAutoFit/>
+          </a:bodyPr>
+          <a:lstStyle/>
+          <a:p>
+            <a:pPr algn="l">
+              <a:lnSpc>
+                <a:spcPct val="114000"/>
+              </a:lnSpc>
+              <a:spcBef>
+                <a:spcPts val="0"/>
+              </a:spcBef>
+              <a:spcAft>
+                <a:spcPts val="800"/>
+              </a:spcAft>
+            </a:pPr>
+            <a:r>
+              <a:rPr sz="1600" b="0">
+                <a:solidFill>
+                  <a:srgbClr val="2B3340"/>
                 </a:solidFill>
                 <a:latin typeface="Segoe UI"/>
               </a:rPr>
-              <a:t>Drohne · WLAN</a:t>
+              <a:t>Live-Telemetrie mit 10 Hz und ein 3D-Flugsimulator direkt am iPhone.</a:t>
             </a:r>
           </a:p>
         </p:txBody>
       </p:sp>
       <p:cxnSp>
         <p:nvCxnSpPr>
-          <p:cNvPr id="13" name="Connector 12"/>
+          <p:cNvPr id="19" name="Connector 18"/>
           <p:cNvCxnSpPr/>
           <p:nvPr/>
         </p:nvCxnSpPr>
         <p:spPr>
           <a:xfrm>
-            <a:off x="8138160" y="3246120"/>
-            <a:ext cx="0" cy="1600200"/>
+            <a:off x="6126480" y="2057400"/>
+            <a:ext cx="0" cy="3977639"/>
           </a:xfrm>
           <a:prstGeom prst="line">
             <a:avLst/>
           </a:prstGeom>
-          <a:ln w="28575">
+          <a:ln w="22225">
             <a:solidFill>
-              <a:srgbClr val="222B3C"/>
+              <a:srgbClr val="2F80ED"/>
             </a:solidFill>
-            <a:tailEnd type="triangle" w="med" len="med"/>
           </a:ln>
           <a:effectLst/>
         </p:spPr>
@@ -4146,107 +4268,47 @@
           </a:fontRef>
         </p:style>
       </p:cxnSp>
-      <p:cxnSp>
-        <p:nvCxnSpPr>
-          <p:cNvPr id="14" name="Connector 13"/>
-          <p:cNvCxnSpPr/>
+      <p:sp>
+        <p:nvSpPr>
+          <p:cNvPr id="20" name="Rectangle 19"/>
+          <p:cNvSpPr/>
           <p:nvPr/>
-        </p:nvCxnSpPr>
-        <p:spPr>
-          <a:xfrm flipV="1">
-            <a:off x="10607040" y="3246120"/>
-            <a:ext cx="0" cy="1600200"/>
-          </a:xfrm>
-          <a:prstGeom prst="line">
+        </p:nvSpPr>
+        <p:spPr>
+          <a:xfrm>
+            <a:off x="868680" y="4041648"/>
+            <a:ext cx="10469880" cy="15875"/>
+          </a:xfrm>
+          <a:prstGeom prst="rect">
             <a:avLst/>
           </a:prstGeom>
-          <a:ln w="28575">
-            <a:solidFill>
-              <a:srgbClr val="222B3C"/>
-            </a:solidFill>
-            <a:tailEnd type="triangle" w="med" len="med"/>
+          <a:solidFill>
+            <a:srgbClr val="E2E7EE"/>
+          </a:solidFill>
+          <a:ln>
+            <a:noFill/>
           </a:ln>
           <a:effectLst/>
         </p:spPr>
         <p:style>
-          <a:lnRef idx="2">
+          <a:lnRef idx="1">
             <a:schemeClr val="accent1"/>
           </a:lnRef>
-          <a:fillRef idx="0">
+          <a:fillRef idx="3">
             <a:schemeClr val="accent1"/>
           </a:fillRef>
-          <a:effectRef idx="1">
+          <a:effectRef idx="2">
             <a:schemeClr val="accent1"/>
           </a:effectRef>
           <a:fontRef idx="minor">
-            <a:schemeClr val="tx1"/>
+            <a:schemeClr val="lt1"/>
           </a:fontRef>
         </p:style>
-      </p:cxnSp>
-      <p:sp>
-        <p:nvSpPr>
-          <p:cNvPr id="15" name="TextBox 14"/>
-          <p:cNvSpPr txBox="1"/>
-          <p:nvPr/>
-        </p:nvSpPr>
-        <p:spPr>
-          <a:xfrm>
-            <a:off x="7406640" y="3657600"/>
-            <a:ext cx="3931920" cy="1005840"/>
-          </a:xfrm>
-          <a:prstGeom prst="rect">
-            <a:avLst/>
-          </a:prstGeom>
-          <a:noFill/>
-        </p:spPr>
-        <p:txBody>
-          <a:bodyPr wrap="square" anchor="ctr" lIns="0" rIns="0" tIns="0" bIns="0">
-            <a:spAutoFit/>
-          </a:bodyPr>
-          <a:lstStyle/>
-          <a:p>
-            <a:pPr algn="ctr">
-              <a:lnSpc>
-                <a:spcPct val="100000"/>
-              </a:lnSpc>
-              <a:spcBef>
-                <a:spcPts val="0"/>
-              </a:spcBef>
-              <a:spcAft>
-                <a:spcPts val="200"/>
-              </a:spcAft>
-            </a:pPr>
-            <a:r>
-              <a:rPr sz="1250" b="0">
-                <a:solidFill>
-                  <a:srgbClr val="6B7482"/>
-                </a:solidFill>
-                <a:latin typeface="Segoe UI"/>
-              </a:rPr>
-              <a:t>Auto-Discovery · 10 Hz</a:t>
-            </a:r>
-          </a:p>
-          <a:p>
-            <a:pPr algn="ctr">
-              <a:lnSpc>
-                <a:spcPct val="100000"/>
-              </a:lnSpc>
-              <a:spcBef>
-                <a:spcPts val="0"/>
-              </a:spcBef>
-              <a:spcAft>
-                <a:spcPts val="200"/>
-              </a:spcAft>
-            </a:pPr>
-            <a:r>
-              <a:rPr sz="1250" b="0">
-                <a:solidFill>
-                  <a:srgbClr val="6B7482"/>
-                </a:solidFill>
-                <a:latin typeface="Segoe UI"/>
-              </a:rPr>
-              <a:t>Befehle ↑ · Telemetrie ↓</a:t>
-            </a:r>
+        <p:txBody>
+          <a:bodyPr rtlCol="0" anchor="ctr"/>
+          <a:lstStyle/>
+          <a:p>
+            <a:pPr algn="ctr"/>
           </a:p>
         </p:txBody>
       </p:sp>
@@ -4440,7 +4502,7 @@
                 </a:solidFill>
                 <a:latin typeface="Segoe UI Semibold"/>
               </a:rPr>
-              <a:t>Tech Stack</a:t>
+              <a:t>Architektur &amp; Tech-Stack</a:t>
             </a:r>
           </a:p>
         </p:txBody>
@@ -4498,8 +4560,8 @@
         </p:nvSpPr>
         <p:spPr>
           <a:xfrm>
-            <a:off x="777240" y="1783080"/>
-            <a:ext cx="3271418" cy="2103120"/>
+            <a:off x="777240" y="2240280"/>
+            <a:ext cx="2697480" cy="2743200"/>
           </a:xfrm>
           <a:prstGeom prst="roundRect">
             <a:avLst>
@@ -4538,9 +4600,54 @@
           </a:p>
         </p:txBody>
       </p:sp>
+      <p:sp>
+        <p:nvSpPr>
+          <p:cNvPr id="8" name="TextBox 7"/>
+          <p:cNvSpPr txBox="1"/>
+          <p:nvPr/>
+        </p:nvSpPr>
+        <p:spPr>
+          <a:xfrm>
+            <a:off x="777240" y="2395728"/>
+            <a:ext cx="2697480" cy="365760"/>
+          </a:xfrm>
+          <a:prstGeom prst="rect">
+            <a:avLst/>
+          </a:prstGeom>
+          <a:noFill/>
+        </p:spPr>
+        <p:txBody>
+          <a:bodyPr wrap="square" anchor="t" lIns="0" rIns="0" tIns="0" bIns="0">
+            <a:spAutoFit/>
+          </a:bodyPr>
+          <a:lstStyle/>
+          <a:p>
+            <a:pPr algn="ctr">
+              <a:lnSpc>
+                <a:spcPct val="100000"/>
+              </a:lnSpc>
+              <a:spcBef>
+                <a:spcPts val="0"/>
+              </a:spcBef>
+              <a:spcAft>
+                <a:spcPts val="800"/>
+              </a:spcAft>
+            </a:pPr>
+            <a:r>
+              <a:rPr sz="1300" b="1">
+                <a:solidFill>
+                  <a:srgbClr val="6B7482"/>
+                </a:solidFill>
+                <a:latin typeface="Segoe UI Semibold"/>
+              </a:rPr>
+              <a:t>DROHNE</a:t>
+            </a:r>
+          </a:p>
+        </p:txBody>
+      </p:sp>
       <p:pic>
         <p:nvPicPr>
-          <p:cNvPr id="8" name="Picture 7" descr="swift.png"/>
+          <p:cNvPr id="9" name="Picture 8" descr="chip.png"/>
           <p:cNvPicPr>
             <a:picLocks noChangeAspect="1"/>
           </p:cNvPicPr>
@@ -4554,8 +4661,8 @@
         </p:blipFill>
         <p:spPr>
           <a:xfrm>
-            <a:off x="1750009" y="2287333"/>
-            <a:ext cx="1325880" cy="408812"/>
+            <a:off x="1714500" y="2788920"/>
+            <a:ext cx="822960" cy="822960"/>
           </a:xfrm>
           <a:prstGeom prst="rect">
             <a:avLst/>
@@ -4564,14 +4671,14 @@
       </p:pic>
       <p:sp>
         <p:nvSpPr>
-          <p:cNvPr id="9" name="TextBox 8"/>
+          <p:cNvPr id="10" name="TextBox 9"/>
           <p:cNvSpPr txBox="1"/>
           <p:nvPr/>
         </p:nvSpPr>
         <p:spPr>
           <a:xfrm>
-            <a:off x="777240" y="3081528"/>
-            <a:ext cx="3271418" cy="411480"/>
+            <a:off x="777240" y="3749039"/>
+            <a:ext cx="2697480" cy="411480"/>
           </a:xfrm>
           <a:prstGeom prst="rect">
             <a:avLst/>
@@ -4596,58 +4703,14 @@
               </a:spcAft>
             </a:pPr>
             <a:r>
-              <a:rPr sz="1700" b="1">
+              <a:rPr sz="1800" b="1">
                 <a:solidFill>
                   <a:srgbClr val="162133"/>
                 </a:solidFill>
                 <a:latin typeface="Segoe UI Semibold"/>
               </a:rPr>
-              <a:t>Swift</a:t>
-            </a:r>
-          </a:p>
-        </p:txBody>
-      </p:sp>
-      <p:sp>
-        <p:nvSpPr>
-          <p:cNvPr id="10" name="Rectangle 9"/>
-          <p:cNvSpPr/>
-          <p:nvPr/>
-        </p:nvSpPr>
-        <p:spPr>
-          <a:xfrm>
-            <a:off x="2156917" y="3483864"/>
-            <a:ext cx="512064" cy="31750"/>
-          </a:xfrm>
-          <a:prstGeom prst="rect">
-            <a:avLst/>
-          </a:prstGeom>
-          <a:solidFill>
-            <a:srgbClr val="2F80ED"/>
-          </a:solidFill>
-          <a:ln>
-            <a:noFill/>
-          </a:ln>
-          <a:effectLst/>
-        </p:spPr>
-        <p:style>
-          <a:lnRef idx="1">
-            <a:schemeClr val="accent1"/>
-          </a:lnRef>
-          <a:fillRef idx="3">
-            <a:schemeClr val="accent1"/>
-          </a:fillRef>
-          <a:effectRef idx="2">
-            <a:schemeClr val="accent1"/>
-          </a:effectRef>
-          <a:fontRef idx="minor">
-            <a:schemeClr val="lt1"/>
-          </a:fontRef>
-        </p:style>
-        <p:txBody>
-          <a:bodyPr rtlCol="0" anchor="ctr"/>
-          <a:lstStyle/>
-          <a:p>
-            <a:pPr algn="ctr"/>
+              <a:t>ESP32-C3</a:t>
+            </a:r>
           </a:p>
         </p:txBody>
       </p:sp>
@@ -4659,8 +4722,112 @@
         </p:nvSpPr>
         <p:spPr>
           <a:xfrm>
-            <a:off x="777240" y="3566160"/>
-            <a:ext cx="3271418" cy="365760"/>
+            <a:off x="777240" y="4160520"/>
+            <a:ext cx="2697480" cy="731520"/>
+          </a:xfrm>
+          <a:prstGeom prst="rect">
+            <a:avLst/>
+          </a:prstGeom>
+          <a:noFill/>
+        </p:spPr>
+        <p:txBody>
+          <a:bodyPr wrap="square" anchor="t" lIns="0" rIns="0" tIns="0" bIns="0">
+            <a:spAutoFit/>
+          </a:bodyPr>
+          <a:lstStyle/>
+          <a:p>
+            <a:pPr algn="ctr">
+              <a:lnSpc>
+                <a:spcPct val="100000"/>
+              </a:lnSpc>
+              <a:spcBef>
+                <a:spcPts val="0"/>
+              </a:spcBef>
+              <a:spcAft>
+                <a:spcPts val="100"/>
+              </a:spcAft>
+            </a:pPr>
+            <a:r>
+              <a:rPr sz="1250" b="0">
+                <a:solidFill>
+                  <a:srgbClr val="6B7482"/>
+                </a:solidFill>
+                <a:latin typeface="Segoe UI"/>
+              </a:rPr>
+              <a:t>WebSocket-Server</a:t>
+            </a:r>
+          </a:p>
+          <a:p>
+            <a:pPr algn="ctr">
+              <a:lnSpc>
+                <a:spcPct val="100000"/>
+              </a:lnSpc>
+              <a:spcBef>
+                <a:spcPts val="0"/>
+              </a:spcBef>
+              <a:spcAft>
+                <a:spcPts val="100"/>
+              </a:spcAft>
+            </a:pPr>
+            <a:r>
+              <a:rPr sz="1250" b="0">
+                <a:solidFill>
+                  <a:srgbClr val="6B7482"/>
+                </a:solidFill>
+                <a:latin typeface="Segoe UI"/>
+              </a:rPr>
+              <a:t>UDP-Beacon (Discovery)</a:t>
+            </a:r>
+          </a:p>
+        </p:txBody>
+      </p:sp>
+      <p:cxnSp>
+        <p:nvCxnSpPr>
+          <p:cNvPr id="12" name="Connector 11"/>
+          <p:cNvCxnSpPr/>
+          <p:nvPr/>
+        </p:nvCxnSpPr>
+        <p:spPr>
+          <a:xfrm>
+            <a:off x="3474720" y="3310128"/>
+            <a:ext cx="1417320" cy="0"/>
+          </a:xfrm>
+          <a:prstGeom prst="line">
+            <a:avLst/>
+          </a:prstGeom>
+          <a:ln w="28575">
+            <a:solidFill>
+              <a:srgbClr val="222B3C"/>
+            </a:solidFill>
+            <a:tailEnd type="triangle" w="med" len="med"/>
+          </a:ln>
+          <a:effectLst/>
+        </p:spPr>
+        <p:style>
+          <a:lnRef idx="2">
+            <a:schemeClr val="accent1"/>
+          </a:lnRef>
+          <a:fillRef idx="0">
+            <a:schemeClr val="accent1"/>
+          </a:fillRef>
+          <a:effectRef idx="1">
+            <a:schemeClr val="accent1"/>
+          </a:effectRef>
+          <a:fontRef idx="minor">
+            <a:schemeClr val="tx1"/>
+          </a:fontRef>
+        </p:style>
+      </p:cxnSp>
+      <p:sp>
+        <p:nvSpPr>
+          <p:cNvPr id="13" name="TextBox 12"/>
+          <p:cNvSpPr txBox="1"/>
+          <p:nvPr/>
+        </p:nvSpPr>
+        <p:spPr>
+          <a:xfrm>
+            <a:off x="3383280" y="2697480"/>
+            <a:ext cx="1600200" cy="548640"/>
           </a:xfrm>
           <a:prstGeom prst="rect">
             <a:avLst/>
@@ -4685,39 +4852,84 @@
               </a:spcAft>
             </a:pPr>
             <a:r>
-              <a:rPr sz="1200" b="0">
+              <a:rPr sz="1150" b="1">
+                <a:solidFill>
+                  <a:srgbClr val="6B7482"/>
+                </a:solidFill>
+                <a:latin typeface="Segoe UI Semibold"/>
+              </a:rPr>
+              <a:t>WLAN · WebSocket</a:t>
+            </a:r>
+          </a:p>
+        </p:txBody>
+      </p:sp>
+      <p:sp>
+        <p:nvSpPr>
+          <p:cNvPr id="14" name="TextBox 13"/>
+          <p:cNvSpPr txBox="1"/>
+          <p:nvPr/>
+        </p:nvSpPr>
+        <p:spPr>
+          <a:xfrm>
+            <a:off x="3383280" y="3456432"/>
+            <a:ext cx="1600200" cy="457200"/>
+          </a:xfrm>
+          <a:prstGeom prst="rect">
+            <a:avLst/>
+          </a:prstGeom>
+          <a:noFill/>
+        </p:spPr>
+        <p:txBody>
+          <a:bodyPr wrap="square" anchor="t" lIns="0" rIns="0" tIns="0" bIns="0">
+            <a:spAutoFit/>
+          </a:bodyPr>
+          <a:lstStyle/>
+          <a:p>
+            <a:pPr algn="ctr">
+              <a:lnSpc>
+                <a:spcPct val="100000"/>
+              </a:lnSpc>
+              <a:spcBef>
+                <a:spcPts val="0"/>
+              </a:spcBef>
+              <a:spcAft>
+                <a:spcPts val="800"/>
+              </a:spcAft>
+            </a:pPr>
+            <a:r>
+              <a:rPr sz="1150" b="0">
                 <a:solidFill>
                   <a:srgbClr val="6B7482"/>
                 </a:solidFill>
                 <a:latin typeface="Segoe UI"/>
               </a:rPr>
-              <a:t>Programmiersprache</a:t>
-            </a:r>
-          </a:p>
-        </p:txBody>
-      </p:sp>
-      <p:sp>
-        <p:nvSpPr>
-          <p:cNvPr id="12" name="Rounded Rectangle 11"/>
+              <a:t>Telemetrie · 10 Hz</a:t>
+            </a:r>
+          </a:p>
+        </p:txBody>
+      </p:sp>
+      <p:sp>
+        <p:nvSpPr>
+          <p:cNvPr id="15" name="Rounded Rectangle 14"/>
           <p:cNvSpPr/>
           <p:nvPr/>
         </p:nvSpPr>
         <p:spPr>
           <a:xfrm>
-            <a:off x="4460138" y="1783080"/>
-            <a:ext cx="3271418" cy="2103120"/>
+            <a:off x="4892040" y="1783080"/>
+            <a:ext cx="6446520" cy="4526280"/>
           </a:xfrm>
           <a:prstGeom prst="roundRect">
             <a:avLst>
-              <a:gd name="adj" fmla="val 5000"/>
+              <a:gd name="adj" fmla="val 4000"/>
             </a:avLst>
           </a:prstGeom>
           <a:solidFill>
-            <a:srgbClr val="F4F7FB"/>
+            <a:srgbClr val="FFFFFF"/>
           </a:solidFill>
-          <a:ln w="12700">
+          <a:ln w="22225">
             <a:solidFill>
-              <a:srgbClr val="E2E7EE"/>
+              <a:srgbClr val="2F80ED"/>
             </a:solidFill>
           </a:ln>
           <a:effectLst/>
@@ -4744,9 +4956,99 @@
           </a:p>
         </p:txBody>
       </p:sp>
+      <p:sp>
+        <p:nvSpPr>
+          <p:cNvPr id="16" name="TextBox 15"/>
+          <p:cNvSpPr txBox="1"/>
+          <p:nvPr/>
+        </p:nvSpPr>
+        <p:spPr>
+          <a:xfrm>
+            <a:off x="5166359" y="1938528"/>
+            <a:ext cx="3840480" cy="411480"/>
+          </a:xfrm>
+          <a:prstGeom prst="rect">
+            <a:avLst/>
+          </a:prstGeom>
+          <a:noFill/>
+        </p:spPr>
+        <p:txBody>
+          <a:bodyPr wrap="square" anchor="t" lIns="0" rIns="0" tIns="0" bIns="0">
+            <a:spAutoFit/>
+          </a:bodyPr>
+          <a:lstStyle/>
+          <a:p>
+            <a:pPr algn="l">
+              <a:lnSpc>
+                <a:spcPct val="100000"/>
+              </a:lnSpc>
+              <a:spcBef>
+                <a:spcPts val="0"/>
+              </a:spcBef>
+              <a:spcAft>
+                <a:spcPts val="800"/>
+              </a:spcAft>
+            </a:pPr>
+            <a:r>
+              <a:rPr sz="1800" b="1">
+                <a:solidFill>
+                  <a:srgbClr val="162133"/>
+                </a:solidFill>
+                <a:latin typeface="Segoe UI Semibold"/>
+              </a:rPr>
+              <a:t>iPhone-App</a:t>
+            </a:r>
+          </a:p>
+        </p:txBody>
+      </p:sp>
+      <p:sp>
+        <p:nvSpPr>
+          <p:cNvPr id="17" name="TextBox 16"/>
+          <p:cNvSpPr txBox="1"/>
+          <p:nvPr/>
+        </p:nvSpPr>
+        <p:spPr>
+          <a:xfrm>
+            <a:off x="5166359" y="2359152"/>
+            <a:ext cx="3840480" cy="365760"/>
+          </a:xfrm>
+          <a:prstGeom prst="rect">
+            <a:avLst/>
+          </a:prstGeom>
+          <a:noFill/>
+        </p:spPr>
+        <p:txBody>
+          <a:bodyPr wrap="square" anchor="t" lIns="0" rIns="0" tIns="0" bIns="0">
+            <a:spAutoFit/>
+          </a:bodyPr>
+          <a:lstStyle/>
+          <a:p>
+            <a:pPr algn="l">
+              <a:lnSpc>
+                <a:spcPct val="100000"/>
+              </a:lnSpc>
+              <a:spcBef>
+                <a:spcPts val="0"/>
+              </a:spcBef>
+              <a:spcAft>
+                <a:spcPts val="800"/>
+              </a:spcAft>
+            </a:pPr>
+            <a:r>
+              <a:rPr sz="1250" b="0">
+                <a:solidFill>
+                  <a:srgbClr val="6B7482"/>
+                </a:solidFill>
+                <a:latin typeface="Segoe UI"/>
+              </a:rPr>
+              <a:t>gebaut mit Swift &amp; SwiftUI</a:t>
+            </a:r>
+          </a:p>
+        </p:txBody>
+      </p:sp>
       <p:pic>
         <p:nvPicPr>
-          <p:cNvPr id="13" name="Picture 12" descr="swiftui.png"/>
+          <p:cNvPr id="18" name="Picture 17" descr="swift.png"/>
           <p:cNvPicPr>
             <a:picLocks noChangeAspect="1"/>
           </p:cNvPicPr>
@@ -4760,199 +5062,17 @@
         </p:blipFill>
         <p:spPr>
           <a:xfrm>
-            <a:off x="5661507" y="2057400"/>
-            <a:ext cx="868680" cy="868680"/>
+            <a:off x="9258299" y="2068639"/>
+            <a:ext cx="1143000" cy="352424"/>
           </a:xfrm>
           <a:prstGeom prst="rect">
             <a:avLst/>
           </a:prstGeom>
         </p:spPr>
       </p:pic>
-      <p:sp>
-        <p:nvSpPr>
-          <p:cNvPr id="14" name="TextBox 13"/>
-          <p:cNvSpPr txBox="1"/>
-          <p:nvPr/>
-        </p:nvSpPr>
-        <p:spPr>
-          <a:xfrm>
-            <a:off x="4460138" y="3081528"/>
-            <a:ext cx="3271418" cy="411480"/>
-          </a:xfrm>
-          <a:prstGeom prst="rect">
-            <a:avLst/>
-          </a:prstGeom>
-          <a:noFill/>
-        </p:spPr>
-        <p:txBody>
-          <a:bodyPr wrap="square" anchor="t" lIns="0" rIns="0" tIns="0" bIns="0">
-            <a:spAutoFit/>
-          </a:bodyPr>
-          <a:lstStyle/>
-          <a:p>
-            <a:pPr algn="ctr">
-              <a:lnSpc>
-                <a:spcPct val="100000"/>
-              </a:lnSpc>
-              <a:spcBef>
-                <a:spcPts val="0"/>
-              </a:spcBef>
-              <a:spcAft>
-                <a:spcPts val="800"/>
-              </a:spcAft>
-            </a:pPr>
-            <a:r>
-              <a:rPr sz="1700" b="1">
-                <a:solidFill>
-                  <a:srgbClr val="162133"/>
-                </a:solidFill>
-                <a:latin typeface="Segoe UI Semibold"/>
-              </a:rPr>
-              <a:t>SwiftUI</a:t>
-            </a:r>
-          </a:p>
-        </p:txBody>
-      </p:sp>
-      <p:sp>
-        <p:nvSpPr>
-          <p:cNvPr id="15" name="Rectangle 14"/>
-          <p:cNvSpPr/>
-          <p:nvPr/>
-        </p:nvSpPr>
-        <p:spPr>
-          <a:xfrm>
-            <a:off x="5839815" y="3483864"/>
-            <a:ext cx="512064" cy="31750"/>
-          </a:xfrm>
-          <a:prstGeom prst="rect">
-            <a:avLst/>
-          </a:prstGeom>
-          <a:solidFill>
-            <a:srgbClr val="2F80ED"/>
-          </a:solidFill>
-          <a:ln>
-            <a:noFill/>
-          </a:ln>
-          <a:effectLst/>
-        </p:spPr>
-        <p:style>
-          <a:lnRef idx="1">
-            <a:schemeClr val="accent1"/>
-          </a:lnRef>
-          <a:fillRef idx="3">
-            <a:schemeClr val="accent1"/>
-          </a:fillRef>
-          <a:effectRef idx="2">
-            <a:schemeClr val="accent1"/>
-          </a:effectRef>
-          <a:fontRef idx="minor">
-            <a:schemeClr val="lt1"/>
-          </a:fontRef>
-        </p:style>
-        <p:txBody>
-          <a:bodyPr rtlCol="0" anchor="ctr"/>
-          <a:lstStyle/>
-          <a:p>
-            <a:pPr algn="ctr"/>
-          </a:p>
-        </p:txBody>
-      </p:sp>
-      <p:sp>
-        <p:nvSpPr>
-          <p:cNvPr id="16" name="TextBox 15"/>
-          <p:cNvSpPr txBox="1"/>
-          <p:nvPr/>
-        </p:nvSpPr>
-        <p:spPr>
-          <a:xfrm>
-            <a:off x="4460138" y="3566160"/>
-            <a:ext cx="3271418" cy="365760"/>
-          </a:xfrm>
-          <a:prstGeom prst="rect">
-            <a:avLst/>
-          </a:prstGeom>
-          <a:noFill/>
-        </p:spPr>
-        <p:txBody>
-          <a:bodyPr wrap="square" anchor="t" lIns="0" rIns="0" tIns="0" bIns="0">
-            <a:spAutoFit/>
-          </a:bodyPr>
-          <a:lstStyle/>
-          <a:p>
-            <a:pPr algn="ctr">
-              <a:lnSpc>
-                <a:spcPct val="100000"/>
-              </a:lnSpc>
-              <a:spcBef>
-                <a:spcPts val="0"/>
-              </a:spcBef>
-              <a:spcAft>
-                <a:spcPts val="800"/>
-              </a:spcAft>
-            </a:pPr>
-            <a:r>
-              <a:rPr sz="1200" b="0">
-                <a:solidFill>
-                  <a:srgbClr val="6B7482"/>
-                </a:solidFill>
-                <a:latin typeface="Segoe UI"/>
-              </a:rPr>
-              <a:t>User Interface</a:t>
-            </a:r>
-          </a:p>
-        </p:txBody>
-      </p:sp>
-      <p:sp>
-        <p:nvSpPr>
-          <p:cNvPr id="17" name="Rounded Rectangle 16"/>
-          <p:cNvSpPr/>
-          <p:nvPr/>
-        </p:nvSpPr>
-        <p:spPr>
-          <a:xfrm>
-            <a:off x="8143036" y="1783080"/>
-            <a:ext cx="3271418" cy="2103120"/>
-          </a:xfrm>
-          <a:prstGeom prst="roundRect">
-            <a:avLst>
-              <a:gd name="adj" fmla="val 5000"/>
-            </a:avLst>
-          </a:prstGeom>
-          <a:solidFill>
-            <a:srgbClr val="F4F7FB"/>
-          </a:solidFill>
-          <a:ln w="12700">
-            <a:solidFill>
-              <a:srgbClr val="E2E7EE"/>
-            </a:solidFill>
-          </a:ln>
-          <a:effectLst/>
-        </p:spPr>
-        <p:style>
-          <a:lnRef idx="1">
-            <a:schemeClr val="accent1"/>
-          </a:lnRef>
-          <a:fillRef idx="3">
-            <a:schemeClr val="accent1"/>
-          </a:fillRef>
-          <a:effectRef idx="2">
-            <a:schemeClr val="accent1"/>
-          </a:effectRef>
-          <a:fontRef idx="minor">
-            <a:schemeClr val="lt1"/>
-          </a:fontRef>
-        </p:style>
-        <p:txBody>
-          <a:bodyPr rtlCol="0" anchor="ctr"/>
-          <a:lstStyle/>
-          <a:p>
-            <a:pPr algn="ctr"/>
-          </a:p>
-        </p:txBody>
-      </p:sp>
       <p:pic>
         <p:nvPicPr>
-          <p:cNvPr id="18" name="Picture 17" descr="cube3d.png"/>
+          <p:cNvPr id="19" name="Picture 18" descr="swiftui.png"/>
           <p:cNvPicPr>
             <a:picLocks noChangeAspect="1"/>
           </p:cNvPicPr>
@@ -4966,8 +5086,8 @@
         </p:blipFill>
         <p:spPr>
           <a:xfrm>
-            <a:off x="9344406" y="2057400"/>
-            <a:ext cx="868680" cy="868680"/>
+            <a:off x="10552175" y="1938528"/>
+            <a:ext cx="566928" cy="566928"/>
           </a:xfrm>
           <a:prstGeom prst="rect">
             <a:avLst/>
@@ -4976,152 +5096,18 @@
       </p:pic>
       <p:sp>
         <p:nvSpPr>
-          <p:cNvPr id="19" name="TextBox 18"/>
-          <p:cNvSpPr txBox="1"/>
-          <p:nvPr/>
-        </p:nvSpPr>
-        <p:spPr>
-          <a:xfrm>
-            <a:off x="8143036" y="3081528"/>
-            <a:ext cx="3271418" cy="411480"/>
-          </a:xfrm>
-          <a:prstGeom prst="rect">
-            <a:avLst/>
-          </a:prstGeom>
-          <a:noFill/>
-        </p:spPr>
-        <p:txBody>
-          <a:bodyPr wrap="square" anchor="t" lIns="0" rIns="0" tIns="0" bIns="0">
-            <a:spAutoFit/>
-          </a:bodyPr>
-          <a:lstStyle/>
-          <a:p>
-            <a:pPr algn="ctr">
-              <a:lnSpc>
-                <a:spcPct val="100000"/>
-              </a:lnSpc>
-              <a:spcBef>
-                <a:spcPts val="0"/>
-              </a:spcBef>
-              <a:spcAft>
-                <a:spcPts val="800"/>
-              </a:spcAft>
-            </a:pPr>
-            <a:r>
-              <a:rPr sz="1700" b="1">
-                <a:solidFill>
-                  <a:srgbClr val="162133"/>
-                </a:solidFill>
-                <a:latin typeface="Segoe UI Semibold"/>
-              </a:rPr>
-              <a:t>SceneKit</a:t>
-            </a:r>
-          </a:p>
-        </p:txBody>
-      </p:sp>
-      <p:sp>
-        <p:nvSpPr>
-          <p:cNvPr id="20" name="Rectangle 19"/>
+          <p:cNvPr id="20" name="Rounded Rectangle 19"/>
           <p:cNvSpPr/>
           <p:nvPr/>
         </p:nvSpPr>
         <p:spPr>
           <a:xfrm>
-            <a:off x="9522714" y="3483864"/>
-            <a:ext cx="512064" cy="31750"/>
-          </a:xfrm>
-          <a:prstGeom prst="rect">
-            <a:avLst/>
-          </a:prstGeom>
-          <a:solidFill>
-            <a:srgbClr val="2F80ED"/>
-          </a:solidFill>
-          <a:ln>
-            <a:noFill/>
-          </a:ln>
-          <a:effectLst/>
-        </p:spPr>
-        <p:style>
-          <a:lnRef idx="1">
-            <a:schemeClr val="accent1"/>
-          </a:lnRef>
-          <a:fillRef idx="3">
-            <a:schemeClr val="accent1"/>
-          </a:fillRef>
-          <a:effectRef idx="2">
-            <a:schemeClr val="accent1"/>
-          </a:effectRef>
-          <a:fontRef idx="minor">
-            <a:schemeClr val="lt1"/>
-          </a:fontRef>
-        </p:style>
-        <p:txBody>
-          <a:bodyPr rtlCol="0" anchor="ctr"/>
-          <a:lstStyle/>
-          <a:p>
-            <a:pPr algn="ctr"/>
-          </a:p>
-        </p:txBody>
-      </p:sp>
-      <p:sp>
-        <p:nvSpPr>
-          <p:cNvPr id="21" name="TextBox 20"/>
-          <p:cNvSpPr txBox="1"/>
-          <p:nvPr/>
-        </p:nvSpPr>
-        <p:spPr>
-          <a:xfrm>
-            <a:off x="8143036" y="3566160"/>
-            <a:ext cx="3271418" cy="365760"/>
-          </a:xfrm>
-          <a:prstGeom prst="rect">
-            <a:avLst/>
-          </a:prstGeom>
-          <a:noFill/>
-        </p:spPr>
-        <p:txBody>
-          <a:bodyPr wrap="square" anchor="t" lIns="0" rIns="0" tIns="0" bIns="0">
-            <a:spAutoFit/>
-          </a:bodyPr>
-          <a:lstStyle/>
-          <a:p>
-            <a:pPr algn="ctr">
-              <a:lnSpc>
-                <a:spcPct val="100000"/>
-              </a:lnSpc>
-              <a:spcBef>
-                <a:spcPts val="0"/>
-              </a:spcBef>
-              <a:spcAft>
-                <a:spcPts val="800"/>
-              </a:spcAft>
-            </a:pPr>
-            <a:r>
-              <a:rPr sz="1200" b="0">
-                <a:solidFill>
-                  <a:srgbClr val="6B7482"/>
-                </a:solidFill>
-                <a:latin typeface="Segoe UI"/>
-              </a:rPr>
-              <a:t>3D-Flugsimulator</a:t>
-            </a:r>
-          </a:p>
-        </p:txBody>
-      </p:sp>
-      <p:sp>
-        <p:nvSpPr>
-          <p:cNvPr id="22" name="Rounded Rectangle 21"/>
-          <p:cNvSpPr/>
-          <p:nvPr/>
-        </p:nvSpPr>
-        <p:spPr>
-          <a:xfrm>
-            <a:off x="777240" y="4142232"/>
-            <a:ext cx="3271418" cy="2103120"/>
+            <a:off x="5166359" y="2880360"/>
+            <a:ext cx="5897880" cy="960120"/>
           </a:xfrm>
           <a:prstGeom prst="roundRect">
             <a:avLst>
-              <a:gd name="adj" fmla="val 5000"/>
+              <a:gd name="adj" fmla="val 8000"/>
             </a:avLst>
           </a:prstGeom>
           <a:solidFill>
@@ -5158,7 +5144,7 @@
       </p:sp>
       <p:pic>
         <p:nvPicPr>
-          <p:cNvPr id="23" name="Picture 22" descr="websocket.png"/>
+          <p:cNvPr id="21" name="Picture 20" descr="wifi.png"/>
           <p:cNvPicPr>
             <a:picLocks noChangeAspect="1"/>
           </p:cNvPicPr>
@@ -5172,8 +5158,8 @@
         </p:blipFill>
         <p:spPr>
           <a:xfrm>
-            <a:off x="1978609" y="4416552"/>
-            <a:ext cx="868680" cy="868680"/>
+            <a:off x="5436107" y="2990088"/>
+            <a:ext cx="740664" cy="740664"/>
           </a:xfrm>
           <a:prstGeom prst="rect">
             <a:avLst/>
@@ -5182,14 +5168,14 @@
       </p:pic>
       <p:sp>
         <p:nvSpPr>
-          <p:cNvPr id="24" name="TextBox 23"/>
+          <p:cNvPr id="22" name="TextBox 21"/>
           <p:cNvSpPr txBox="1"/>
           <p:nvPr/>
         </p:nvSpPr>
         <p:spPr>
           <a:xfrm>
-            <a:off x="777240" y="5440680"/>
-            <a:ext cx="3271418" cy="411480"/>
+            <a:off x="6446519" y="3044952"/>
+            <a:ext cx="4434840" cy="411480"/>
           </a:xfrm>
           <a:prstGeom prst="rect">
             <a:avLst/>
@@ -5202,7 +5188,7 @@
           </a:bodyPr>
           <a:lstStyle/>
           <a:p>
-            <a:pPr algn="ctr">
+            <a:pPr algn="l">
               <a:lnSpc>
                 <a:spcPct val="100000"/>
               </a:lnSpc>
@@ -5220,65 +5206,21 @@
                 </a:solidFill>
                 <a:latin typeface="Segoe UI Semibold"/>
               </a:rPr>
-              <a:t>WebSocket</a:t>
-            </a:r>
-          </a:p>
-        </p:txBody>
-      </p:sp>
-      <p:sp>
-        <p:nvSpPr>
-          <p:cNvPr id="25" name="Rectangle 24"/>
-          <p:cNvSpPr/>
-          <p:nvPr/>
-        </p:nvSpPr>
-        <p:spPr>
-          <a:xfrm>
-            <a:off x="2156917" y="5843016"/>
-            <a:ext cx="512064" cy="31750"/>
-          </a:xfrm>
-          <a:prstGeom prst="rect">
-            <a:avLst/>
-          </a:prstGeom>
-          <a:solidFill>
-            <a:srgbClr val="2F80ED"/>
-          </a:solidFill>
-          <a:ln>
-            <a:noFill/>
-          </a:ln>
-          <a:effectLst/>
-        </p:spPr>
-        <p:style>
-          <a:lnRef idx="1">
-            <a:schemeClr val="accent1"/>
-          </a:lnRef>
-          <a:fillRef idx="3">
-            <a:schemeClr val="accent1"/>
-          </a:fillRef>
-          <a:effectRef idx="2">
-            <a:schemeClr val="accent1"/>
-          </a:effectRef>
-          <a:fontRef idx="minor">
-            <a:schemeClr val="lt1"/>
-          </a:fontRef>
-        </p:style>
-        <p:txBody>
-          <a:bodyPr rtlCol="0" anchor="ctr"/>
-          <a:lstStyle/>
-          <a:p>
-            <a:pPr algn="ctr"/>
-          </a:p>
-        </p:txBody>
-      </p:sp>
-      <p:sp>
-        <p:nvSpPr>
-          <p:cNvPr id="26" name="TextBox 25"/>
+              <a:t>Network.framework</a:t>
+            </a:r>
+          </a:p>
+        </p:txBody>
+      </p:sp>
+      <p:sp>
+        <p:nvSpPr>
+          <p:cNvPr id="23" name="TextBox 22"/>
           <p:cNvSpPr txBox="1"/>
           <p:nvPr/>
         </p:nvSpPr>
         <p:spPr>
           <a:xfrm>
-            <a:off x="777240" y="5925312"/>
-            <a:ext cx="3271418" cy="365760"/>
+            <a:off x="6446519" y="3429000"/>
+            <a:ext cx="4434840" cy="365760"/>
           </a:xfrm>
           <a:prstGeom prst="rect">
             <a:avLst/>
@@ -5291,7 +5233,7 @@
           </a:bodyPr>
           <a:lstStyle/>
           <a:p>
-            <a:pPr algn="ctr">
+            <a:pPr algn="l">
               <a:lnSpc>
                 <a:spcPct val="100000"/>
               </a:lnSpc>
@@ -5303,31 +5245,31 @@
               </a:spcAft>
             </a:pPr>
             <a:r>
-              <a:rPr sz="1200" b="0">
+              <a:rPr sz="1250" b="0">
                 <a:solidFill>
                   <a:srgbClr val="6B7482"/>
                 </a:solidFill>
                 <a:latin typeface="Segoe UI"/>
               </a:rPr>
-              <a:t>Live-Telemetrie · 10 Hz</a:t>
-            </a:r>
-          </a:p>
-        </p:txBody>
-      </p:sp>
-      <p:sp>
-        <p:nvSpPr>
-          <p:cNvPr id="27" name="Rounded Rectangle 26"/>
+              <a:t>Verbindung &amp; Auto-Discovery zur Drohne</a:t>
+            </a:r>
+          </a:p>
+        </p:txBody>
+      </p:sp>
+      <p:sp>
+        <p:nvSpPr>
+          <p:cNvPr id="24" name="Rounded Rectangle 23"/>
           <p:cNvSpPr/>
           <p:nvPr/>
         </p:nvSpPr>
         <p:spPr>
           <a:xfrm>
-            <a:off x="4460138" y="4142232"/>
-            <a:ext cx="3271418" cy="2103120"/>
+            <a:off x="5166359" y="3959352"/>
+            <a:ext cx="5897880" cy="960120"/>
           </a:xfrm>
           <a:prstGeom prst="roundRect">
             <a:avLst>
-              <a:gd name="adj" fmla="val 5000"/>
+              <a:gd name="adj" fmla="val 8000"/>
             </a:avLst>
           </a:prstGeom>
           <a:solidFill>
@@ -5364,7 +5306,7 @@
       </p:sp>
       <p:pic>
         <p:nvPicPr>
-          <p:cNvPr id="28" name="Picture 27" descr="wifi.png"/>
+          <p:cNvPr id="25" name="Picture 24" descr="cube3d.png"/>
           <p:cNvPicPr>
             <a:picLocks noChangeAspect="1"/>
           </p:cNvPicPr>
@@ -5378,8 +5320,8 @@
         </p:blipFill>
         <p:spPr>
           <a:xfrm>
-            <a:off x="5661507" y="4416552"/>
-            <a:ext cx="868680" cy="868680"/>
+            <a:off x="5436107" y="4069080"/>
+            <a:ext cx="740664" cy="740664"/>
           </a:xfrm>
           <a:prstGeom prst="rect">
             <a:avLst/>
@@ -5388,14 +5330,14 @@
       </p:pic>
       <p:sp>
         <p:nvSpPr>
-          <p:cNvPr id="29" name="TextBox 28"/>
+          <p:cNvPr id="26" name="TextBox 25"/>
           <p:cNvSpPr txBox="1"/>
           <p:nvPr/>
         </p:nvSpPr>
         <p:spPr>
           <a:xfrm>
-            <a:off x="4460138" y="5440680"/>
-            <a:ext cx="3271418" cy="411480"/>
+            <a:off x="6446519" y="4123944"/>
+            <a:ext cx="4434840" cy="411480"/>
           </a:xfrm>
           <a:prstGeom prst="rect">
             <a:avLst/>
@@ -5408,7 +5350,7 @@
           </a:bodyPr>
           <a:lstStyle/>
           <a:p>
-            <a:pPr algn="ctr">
+            <a:pPr algn="l">
               <a:lnSpc>
                 <a:spcPct val="100000"/>
               </a:lnSpc>
@@ -5426,65 +5368,21 @@
                 </a:solidFill>
                 <a:latin typeface="Segoe UI Semibold"/>
               </a:rPr>
-              <a:t>Network.framework</a:t>
-            </a:r>
-          </a:p>
-        </p:txBody>
-      </p:sp>
-      <p:sp>
-        <p:nvSpPr>
-          <p:cNvPr id="30" name="Rectangle 29"/>
-          <p:cNvSpPr/>
-          <p:nvPr/>
-        </p:nvSpPr>
-        <p:spPr>
-          <a:xfrm>
-            <a:off x="5839815" y="5843016"/>
-            <a:ext cx="512064" cy="31750"/>
-          </a:xfrm>
-          <a:prstGeom prst="rect">
-            <a:avLst/>
-          </a:prstGeom>
-          <a:solidFill>
-            <a:srgbClr val="2F80ED"/>
-          </a:solidFill>
-          <a:ln>
-            <a:noFill/>
-          </a:ln>
-          <a:effectLst/>
-        </p:spPr>
-        <p:style>
-          <a:lnRef idx="1">
-            <a:schemeClr val="accent1"/>
-          </a:lnRef>
-          <a:fillRef idx="3">
-            <a:schemeClr val="accent1"/>
-          </a:fillRef>
-          <a:effectRef idx="2">
-            <a:schemeClr val="accent1"/>
-          </a:effectRef>
-          <a:fontRef idx="minor">
-            <a:schemeClr val="lt1"/>
-          </a:fontRef>
-        </p:style>
-        <p:txBody>
-          <a:bodyPr rtlCol="0" anchor="ctr"/>
-          <a:lstStyle/>
-          <a:p>
-            <a:pPr algn="ctr"/>
-          </a:p>
-        </p:txBody>
-      </p:sp>
-      <p:sp>
-        <p:nvSpPr>
-          <p:cNvPr id="31" name="TextBox 30"/>
+              <a:t>SceneKit</a:t>
+            </a:r>
+          </a:p>
+        </p:txBody>
+      </p:sp>
+      <p:sp>
+        <p:nvSpPr>
+          <p:cNvPr id="27" name="TextBox 26"/>
           <p:cNvSpPr txBox="1"/>
           <p:nvPr/>
         </p:nvSpPr>
         <p:spPr>
           <a:xfrm>
-            <a:off x="4460138" y="5925312"/>
-            <a:ext cx="3271418" cy="365760"/>
+            <a:off x="6446519" y="4507992"/>
+            <a:ext cx="4434840" cy="365760"/>
           </a:xfrm>
           <a:prstGeom prst="rect">
             <a:avLst/>
@@ -5497,7 +5395,7 @@
           </a:bodyPr>
           <a:lstStyle/>
           <a:p>
-            <a:pPr algn="ctr">
+            <a:pPr algn="l">
               <a:lnSpc>
                 <a:spcPct val="100000"/>
               </a:lnSpc>
@@ -5509,31 +5407,31 @@
               </a:spcAft>
             </a:pPr>
             <a:r>
-              <a:rPr sz="1200" b="0">
+              <a:rPr sz="1250" b="0">
                 <a:solidFill>
                   <a:srgbClr val="6B7482"/>
                 </a:solidFill>
                 <a:latin typeface="Segoe UI"/>
               </a:rPr>
-              <a:t>Auto-Discovery im WLAN</a:t>
-            </a:r>
-          </a:p>
-        </p:txBody>
-      </p:sp>
-      <p:sp>
-        <p:nvSpPr>
-          <p:cNvPr id="32" name="Rounded Rectangle 31"/>
+              <a:t>Rendert den 3D-Flugsimulator</a:t>
+            </a:r>
+          </a:p>
+        </p:txBody>
+      </p:sp>
+      <p:sp>
+        <p:nvSpPr>
+          <p:cNvPr id="28" name="Rounded Rectangle 27"/>
           <p:cNvSpPr/>
           <p:nvPr/>
         </p:nvSpPr>
         <p:spPr>
           <a:xfrm>
-            <a:off x="8143036" y="4142232"/>
-            <a:ext cx="3271418" cy="2103120"/>
+            <a:off x="5166359" y="5038344"/>
+            <a:ext cx="5897880" cy="960120"/>
           </a:xfrm>
           <a:prstGeom prst="roundRect">
             <a:avLst>
-              <a:gd name="adj" fmla="val 5000"/>
+              <a:gd name="adj" fmla="val 8000"/>
             </a:avLst>
           </a:prstGeom>
           <a:solidFill>
@@ -5570,7 +5468,7 @@
       </p:sp>
       <p:pic>
         <p:nvPicPr>
-          <p:cNvPr id="33" name="Picture 32" descr="chip.png"/>
+          <p:cNvPr id="29" name="Picture 28" descr="gyro.png"/>
           <p:cNvPicPr>
             <a:picLocks noChangeAspect="1"/>
           </p:cNvPicPr>
@@ -5584,8 +5482,8 @@
         </p:blipFill>
         <p:spPr>
           <a:xfrm>
-            <a:off x="9344406" y="4416552"/>
-            <a:ext cx="868680" cy="868680"/>
+            <a:off x="5436107" y="5148072"/>
+            <a:ext cx="740664" cy="740664"/>
           </a:xfrm>
           <a:prstGeom prst="rect">
             <a:avLst/>
@@ -5594,14 +5492,14 @@
       </p:pic>
       <p:sp>
         <p:nvSpPr>
-          <p:cNvPr id="34" name="TextBox 33"/>
+          <p:cNvPr id="30" name="TextBox 29"/>
           <p:cNvSpPr txBox="1"/>
           <p:nvPr/>
         </p:nvSpPr>
         <p:spPr>
           <a:xfrm>
-            <a:off x="8143036" y="5440680"/>
-            <a:ext cx="3271418" cy="411480"/>
+            <a:off x="6446519" y="5202936"/>
+            <a:ext cx="4434840" cy="411480"/>
           </a:xfrm>
           <a:prstGeom prst="rect">
             <a:avLst/>
@@ -5614,7 +5512,7 @@
           </a:bodyPr>
           <a:lstStyle/>
           <a:p>
-            <a:pPr algn="ctr">
+            <a:pPr algn="l">
               <a:lnSpc>
                 <a:spcPct val="100000"/>
               </a:lnSpc>
@@ -5632,65 +5530,21 @@
                 </a:solidFill>
                 <a:latin typeface="Segoe UI Semibold"/>
               </a:rPr>
-              <a:t>ESP32-C3</a:t>
-            </a:r>
-          </a:p>
-        </p:txBody>
-      </p:sp>
-      <p:sp>
-        <p:nvSpPr>
-          <p:cNvPr id="35" name="Rectangle 34"/>
-          <p:cNvSpPr/>
-          <p:nvPr/>
-        </p:nvSpPr>
-        <p:spPr>
-          <a:xfrm>
-            <a:off x="9522714" y="5843016"/>
-            <a:ext cx="512064" cy="31750"/>
-          </a:xfrm>
-          <a:prstGeom prst="rect">
-            <a:avLst/>
-          </a:prstGeom>
-          <a:solidFill>
-            <a:srgbClr val="2F80ED"/>
-          </a:solidFill>
-          <a:ln>
-            <a:noFill/>
-          </a:ln>
-          <a:effectLst/>
-        </p:spPr>
-        <p:style>
-          <a:lnRef idx="1">
-            <a:schemeClr val="accent1"/>
-          </a:lnRef>
-          <a:fillRef idx="3">
-            <a:schemeClr val="accent1"/>
-          </a:fillRef>
-          <a:effectRef idx="2">
-            <a:schemeClr val="accent1"/>
-          </a:effectRef>
-          <a:fontRef idx="minor">
-            <a:schemeClr val="lt1"/>
-          </a:fontRef>
-        </p:style>
-        <p:txBody>
-          <a:bodyPr rtlCol="0" anchor="ctr"/>
-          <a:lstStyle/>
-          <a:p>
-            <a:pPr algn="ctr"/>
-          </a:p>
-        </p:txBody>
-      </p:sp>
-      <p:sp>
-        <p:nvSpPr>
-          <p:cNvPr id="36" name="TextBox 35"/>
+              <a:t>CoreMotion</a:t>
+            </a:r>
+          </a:p>
+        </p:txBody>
+      </p:sp>
+      <p:sp>
+        <p:nvSpPr>
+          <p:cNvPr id="31" name="TextBox 30"/>
           <p:cNvSpPr txBox="1"/>
           <p:nvPr/>
         </p:nvSpPr>
         <p:spPr>
           <a:xfrm>
-            <a:off x="8143036" y="5925312"/>
-            <a:ext cx="3271418" cy="365760"/>
+            <a:off x="6446519" y="5586983"/>
+            <a:ext cx="4434840" cy="365760"/>
           </a:xfrm>
           <a:prstGeom prst="rect">
             <a:avLst/>
@@ -5703,7 +5557,7 @@
           </a:bodyPr>
           <a:lstStyle/>
           <a:p>
-            <a:pPr algn="ctr">
+            <a:pPr algn="l">
               <a:lnSpc>
                 <a:spcPct val="100000"/>
               </a:lnSpc>
@@ -5715,13 +5569,13 @@
               </a:spcAft>
             </a:pPr>
             <a:r>
-              <a:rPr sz="1200" b="0">
+              <a:rPr sz="1250" b="0">
                 <a:solidFill>
                   <a:srgbClr val="6B7482"/>
                 </a:solidFill>
                 <a:latin typeface="Segoe UI"/>
               </a:rPr>
-              <a:t>Mikrocontroller der Drohne</a:t>
+              <a:t>Liest das Gyroskop des Handys</a:t>
             </a:r>
           </a:p>
         </p:txBody>

</xml_diff>

<commit_message>
docs: slide 2 as flowing presentation text (less bullet-y)
Replace the abstract 2x2 keyword grid with a big key statement plus three calm
full-sentence paragraphs (blue tick marks for rhythm); right half left empty.

Co-Authored-By: Claude Opus 4.8 <noreply@anthropic.com>
</commit_message>
<xml_diff>
--- a/docs/presentation-ios/EasyPilot-iOS.pptx
+++ b/docs/presentation-ios/EasyPilot-iOS.pptx
@@ -3698,58 +3698,14 @@
       </p:sp>
       <p:sp>
         <p:nvSpPr>
-          <p:cNvPr id="7" name="Rectangle 6"/>
-          <p:cNvSpPr/>
-          <p:nvPr/>
-        </p:nvSpPr>
-        <p:spPr>
-          <a:xfrm>
-            <a:off x="868680" y="2185416"/>
-            <a:ext cx="256032" cy="256032"/>
-          </a:xfrm>
-          <a:prstGeom prst="rect">
-            <a:avLst/>
-          </a:prstGeom>
-          <a:solidFill>
-            <a:srgbClr val="2F80ED"/>
-          </a:solidFill>
-          <a:ln>
-            <a:noFill/>
-          </a:ln>
-          <a:effectLst/>
-        </p:spPr>
-        <p:style>
-          <a:lnRef idx="1">
-            <a:schemeClr val="accent1"/>
-          </a:lnRef>
-          <a:fillRef idx="3">
-            <a:schemeClr val="accent1"/>
-          </a:fillRef>
-          <a:effectRef idx="2">
-            <a:schemeClr val="accent1"/>
-          </a:effectRef>
-          <a:fontRef idx="minor">
-            <a:schemeClr val="lt1"/>
-          </a:fontRef>
-        </p:style>
-        <p:txBody>
-          <a:bodyPr rtlCol="0" anchor="ctr"/>
-          <a:lstStyle/>
-          <a:p>
-            <a:pPr algn="ctr"/>
-          </a:p>
-        </p:txBody>
-      </p:sp>
-      <p:sp>
-        <p:nvSpPr>
-          <p:cNvPr id="8" name="TextBox 7"/>
+          <p:cNvPr id="7" name="TextBox 6"/>
           <p:cNvSpPr txBox="1"/>
           <p:nvPr/>
         </p:nvSpPr>
         <p:spPr>
           <a:xfrm>
-            <a:off x="1280160" y="2103120"/>
-            <a:ext cx="4480560" cy="457200"/>
+            <a:off x="868680" y="1691640"/>
+            <a:ext cx="7315200" cy="1280160"/>
           </a:xfrm>
           <a:prstGeom prst="rect">
             <a:avLst/>
@@ -3764,7 +3720,7 @@
           <a:p>
             <a:pPr algn="l">
               <a:lnSpc>
-                <a:spcPct val="100000"/>
+                <a:spcPct val="108000"/>
               </a:lnSpc>
               <a:spcBef>
                 <a:spcPts val="0"/>
@@ -3774,27 +3730,115 @@
               </a:spcAft>
             </a:pPr>
             <a:r>
-              <a:rPr sz="2100" b="1">
+              <a:rPr sz="2700" b="1">
                 <a:solidFill>
                   <a:srgbClr val="162133"/>
                 </a:solidFill>
                 <a:latin typeface="Segoe UI Semibold"/>
               </a:rPr>
-              <a:t>Modifizierte Drohne</a:t>
-            </a:r>
-          </a:p>
-        </p:txBody>
-      </p:sp>
-      <p:sp>
-        <p:nvSpPr>
-          <p:cNvPr id="9" name="TextBox 8"/>
+              <a:t>Das iPhone wird zur Anzeige- und Steuerzentrale für unsere Drohne.</a:t>
+            </a:r>
+          </a:p>
+        </p:txBody>
+      </p:sp>
+      <p:sp>
+        <p:nvSpPr>
+          <p:cNvPr id="8" name="Rectangle 7"/>
+          <p:cNvSpPr/>
+          <p:nvPr/>
+        </p:nvSpPr>
+        <p:spPr>
+          <a:xfrm>
+            <a:off x="886968" y="2852928"/>
+            <a:ext cx="1463040" cy="50800"/>
+          </a:xfrm>
+          <a:prstGeom prst="rect">
+            <a:avLst/>
+          </a:prstGeom>
+          <a:solidFill>
+            <a:srgbClr val="2F80ED"/>
+          </a:solidFill>
+          <a:ln>
+            <a:noFill/>
+          </a:ln>
+          <a:effectLst/>
+        </p:spPr>
+        <p:style>
+          <a:lnRef idx="1">
+            <a:schemeClr val="accent1"/>
+          </a:lnRef>
+          <a:fillRef idx="3">
+            <a:schemeClr val="accent1"/>
+          </a:fillRef>
+          <a:effectRef idx="2">
+            <a:schemeClr val="accent1"/>
+          </a:effectRef>
+          <a:fontRef idx="minor">
+            <a:schemeClr val="lt1"/>
+          </a:fontRef>
+        </p:style>
+        <p:txBody>
+          <a:bodyPr rtlCol="0" anchor="ctr"/>
+          <a:lstStyle/>
+          <a:p>
+            <a:pPr algn="ctr"/>
+          </a:p>
+        </p:txBody>
+      </p:sp>
+      <p:sp>
+        <p:nvSpPr>
+          <p:cNvPr id="9" name="Rectangle 8"/>
+          <p:cNvSpPr/>
+          <p:nvPr/>
+        </p:nvSpPr>
+        <p:spPr>
+          <a:xfrm>
+            <a:off x="868680" y="3273551"/>
+            <a:ext cx="54864" cy="566928"/>
+          </a:xfrm>
+          <a:prstGeom prst="rect">
+            <a:avLst/>
+          </a:prstGeom>
+          <a:solidFill>
+            <a:srgbClr val="2F80ED"/>
+          </a:solidFill>
+          <a:ln>
+            <a:noFill/>
+          </a:ln>
+          <a:effectLst/>
+        </p:spPr>
+        <p:style>
+          <a:lnRef idx="1">
+            <a:schemeClr val="accent1"/>
+          </a:lnRef>
+          <a:fillRef idx="3">
+            <a:schemeClr val="accent1"/>
+          </a:fillRef>
+          <a:effectRef idx="2">
+            <a:schemeClr val="accent1"/>
+          </a:effectRef>
+          <a:fontRef idx="minor">
+            <a:schemeClr val="lt1"/>
+          </a:fontRef>
+        </p:style>
+        <p:txBody>
+          <a:bodyPr rtlCol="0" anchor="ctr"/>
+          <a:lstStyle/>
+          <a:p>
+            <a:pPr algn="ctr"/>
+          </a:p>
+        </p:txBody>
+      </p:sp>
+      <p:sp>
+        <p:nvSpPr>
+          <p:cNvPr id="10" name="TextBox 9"/>
           <p:cNvSpPr txBox="1"/>
           <p:nvPr/>
         </p:nvSpPr>
         <p:spPr>
           <a:xfrm>
-            <a:off x="1280160" y="2624328"/>
-            <a:ext cx="4526280" cy="1371600"/>
+            <a:off x="1188720" y="3246120"/>
+            <a:ext cx="6309360" cy="1371600"/>
           </a:xfrm>
           <a:prstGeom prst="rect">
             <a:avLst/>
@@ -3809,7 +3853,7 @@
           <a:p>
             <a:pPr algn="l">
               <a:lnSpc>
-                <a:spcPct val="114000"/>
+                <a:spcPct val="116000"/>
               </a:lnSpc>
               <a:spcBef>
                 <a:spcPts val="0"/>
@@ -3819,27 +3863,27 @@
               </a:spcAft>
             </a:pPr>
             <a:r>
-              <a:rPr sz="1600" b="0">
+              <a:rPr sz="1650" b="0">
                 <a:solidFill>
                   <a:srgbClr val="2B3340"/>
                 </a:solidFill>
                 <a:latin typeface="Segoe UI"/>
               </a:rPr>
-              <a:t>Eine handelsübliche Drohne, die wir mit einem ESP32 erweitert haben – nicht selbstgebaut.</a:t>
-            </a:r>
-          </a:p>
-        </p:txBody>
-      </p:sp>
-      <p:sp>
-        <p:nvSpPr>
-          <p:cNvPr id="10" name="Rectangle 9"/>
+              <a:t>EasyPilot ist unser Drohnenprojekt der 4AHITM – eine handelsübliche Drohne, die wir mit einem ESP32 erweitert haben.</a:t>
+            </a:r>
+          </a:p>
+        </p:txBody>
+      </p:sp>
+      <p:sp>
+        <p:nvSpPr>
+          <p:cNvPr id="11" name="Rectangle 10"/>
           <p:cNvSpPr/>
           <p:nvPr/>
         </p:nvSpPr>
         <p:spPr>
           <a:xfrm>
-            <a:off x="6537960" y="2185416"/>
-            <a:ext cx="256032" cy="256032"/>
+            <a:off x="868680" y="4251960"/>
+            <a:ext cx="54864" cy="777240"/>
           </a:xfrm>
           <a:prstGeom prst="rect">
             <a:avLst/>
@@ -3876,14 +3920,14 @@
       </p:sp>
       <p:sp>
         <p:nvSpPr>
-          <p:cNvPr id="11" name="TextBox 10"/>
+          <p:cNvPr id="12" name="TextBox 11"/>
           <p:cNvSpPr txBox="1"/>
           <p:nvPr/>
         </p:nvSpPr>
         <p:spPr>
           <a:xfrm>
-            <a:off x="6949440" y="2103120"/>
-            <a:ext cx="4480560" cy="457200"/>
+            <a:off x="1188720" y="4224528"/>
+            <a:ext cx="6309360" cy="1371600"/>
           </a:xfrm>
           <a:prstGeom prst="rect">
             <a:avLst/>
@@ -3898,7 +3942,7 @@
           <a:p>
             <a:pPr algn="l">
               <a:lnSpc>
-                <a:spcPct val="100000"/>
+                <a:spcPct val="116000"/>
               </a:lnSpc>
               <a:spcBef>
                 <a:spcPts val="0"/>
@@ -3908,27 +3952,71 @@
               </a:spcAft>
             </a:pPr>
             <a:r>
-              <a:rPr sz="2100" b="1">
+              <a:rPr sz="1650" b="0">
                 <a:solidFill>
-                  <a:srgbClr val="162133"/>
+                  <a:srgbClr val="2B3340"/>
                 </a:solidFill>
-                <a:latin typeface="Segoe UI Semibold"/>
+                <a:latin typeface="Segoe UI"/>
               </a:rPr>
-              <a:t>SwiftUI-App</a:t>
-            </a:r>
-          </a:p>
-        </p:txBody>
-      </p:sp>
-      <p:sp>
-        <p:nvSpPr>
-          <p:cNvPr id="12" name="TextBox 11"/>
+              <a:t>Die iOS-App ist der mobile Co-Pilot: Sie verbindet sich von selbst über das WLAN mit der Drohne, ganz ohne Eingabe einer IP-Adresse.</a:t>
+            </a:r>
+          </a:p>
+        </p:txBody>
+      </p:sp>
+      <p:sp>
+        <p:nvSpPr>
+          <p:cNvPr id="13" name="Rectangle 12"/>
+          <p:cNvSpPr/>
+          <p:nvPr/>
+        </p:nvSpPr>
+        <p:spPr>
+          <a:xfrm>
+            <a:off x="868680" y="5376672"/>
+            <a:ext cx="54864" cy="868680"/>
+          </a:xfrm>
+          <a:prstGeom prst="rect">
+            <a:avLst/>
+          </a:prstGeom>
+          <a:solidFill>
+            <a:srgbClr val="2F80ED"/>
+          </a:solidFill>
+          <a:ln>
+            <a:noFill/>
+          </a:ln>
+          <a:effectLst/>
+        </p:spPr>
+        <p:style>
+          <a:lnRef idx="1">
+            <a:schemeClr val="accent1"/>
+          </a:lnRef>
+          <a:fillRef idx="3">
+            <a:schemeClr val="accent1"/>
+          </a:fillRef>
+          <a:effectRef idx="2">
+            <a:schemeClr val="accent1"/>
+          </a:effectRef>
+          <a:fontRef idx="minor">
+            <a:schemeClr val="lt1"/>
+          </a:fontRef>
+        </p:style>
+        <p:txBody>
+          <a:bodyPr rtlCol="0" anchor="ctr"/>
+          <a:lstStyle/>
+          <a:p>
+            <a:pPr algn="ctr"/>
+          </a:p>
+        </p:txBody>
+      </p:sp>
+      <p:sp>
+        <p:nvSpPr>
+          <p:cNvPr id="14" name="TextBox 13"/>
           <p:cNvSpPr txBox="1"/>
           <p:nvPr/>
         </p:nvSpPr>
         <p:spPr>
           <a:xfrm>
-            <a:off x="6949440" y="2624328"/>
-            <a:ext cx="4526280" cy="1371600"/>
+            <a:off x="1188720" y="5349240"/>
+            <a:ext cx="6309360" cy="1371600"/>
           </a:xfrm>
           <a:prstGeom prst="rect">
             <a:avLst/>
@@ -3943,7 +4031,7 @@
           <a:p>
             <a:pPr algn="l">
               <a:lnSpc>
-                <a:spcPct val="114000"/>
+                <a:spcPct val="116000"/>
               </a:lnSpc>
               <a:spcBef>
                 <a:spcPts val="0"/>
@@ -3953,362 +4041,14 @@
               </a:spcAft>
             </a:pPr>
             <a:r>
-              <a:rPr sz="1600" b="0">
+              <a:rPr sz="1650" b="0">
                 <a:solidFill>
                   <a:srgbClr val="2B3340"/>
                 </a:solidFill>
                 <a:latin typeface="Segoe UI"/>
               </a:rPr>
-              <a:t>Der mobile Co-Pilot, komplett in SwiftUI gebaut – nur mit Apple-Frameworks.</a:t>
-            </a:r>
-          </a:p>
-        </p:txBody>
-      </p:sp>
-      <p:sp>
-        <p:nvSpPr>
-          <p:cNvPr id="13" name="Rectangle 12"/>
-          <p:cNvSpPr/>
-          <p:nvPr/>
-        </p:nvSpPr>
-        <p:spPr>
-          <a:xfrm>
-            <a:off x="868680" y="4288536"/>
-            <a:ext cx="256032" cy="256032"/>
-          </a:xfrm>
-          <a:prstGeom prst="rect">
-            <a:avLst/>
-          </a:prstGeom>
-          <a:solidFill>
-            <a:srgbClr val="2F80ED"/>
-          </a:solidFill>
-          <a:ln>
-            <a:noFill/>
-          </a:ln>
-          <a:effectLst/>
-        </p:spPr>
-        <p:style>
-          <a:lnRef idx="1">
-            <a:schemeClr val="accent1"/>
-          </a:lnRef>
-          <a:fillRef idx="3">
-            <a:schemeClr val="accent1"/>
-          </a:fillRef>
-          <a:effectRef idx="2">
-            <a:schemeClr val="accent1"/>
-          </a:effectRef>
-          <a:fontRef idx="minor">
-            <a:schemeClr val="lt1"/>
-          </a:fontRef>
-        </p:style>
-        <p:txBody>
-          <a:bodyPr rtlCol="0" anchor="ctr"/>
-          <a:lstStyle/>
-          <a:p>
-            <a:pPr algn="ctr"/>
-          </a:p>
-        </p:txBody>
-      </p:sp>
-      <p:sp>
-        <p:nvSpPr>
-          <p:cNvPr id="14" name="TextBox 13"/>
-          <p:cNvSpPr txBox="1"/>
-          <p:nvPr/>
-        </p:nvSpPr>
-        <p:spPr>
-          <a:xfrm>
-            <a:off x="1280160" y="4206240"/>
-            <a:ext cx="4480560" cy="457200"/>
-          </a:xfrm>
-          <a:prstGeom prst="rect">
-            <a:avLst/>
-          </a:prstGeom>
-          <a:noFill/>
-        </p:spPr>
-        <p:txBody>
-          <a:bodyPr wrap="square" anchor="t" lIns="0" rIns="0" tIns="0" bIns="0">
-            <a:spAutoFit/>
-          </a:bodyPr>
-          <a:lstStyle/>
-          <a:p>
-            <a:pPr algn="l">
-              <a:lnSpc>
-                <a:spcPct val="100000"/>
-              </a:lnSpc>
-              <a:spcBef>
-                <a:spcPts val="0"/>
-              </a:spcBef>
-              <a:spcAft>
-                <a:spcPts val="800"/>
-              </a:spcAft>
-            </a:pPr>
-            <a:r>
-              <a:rPr sz="2100" b="1">
-                <a:solidFill>
-                  <a:srgbClr val="162133"/>
-                </a:solidFill>
-                <a:latin typeface="Segoe UI Semibold"/>
-              </a:rPr>
-              <a:t>Auto-Discovery</a:t>
-            </a:r>
-          </a:p>
-        </p:txBody>
-      </p:sp>
-      <p:sp>
-        <p:nvSpPr>
-          <p:cNvPr id="15" name="TextBox 14"/>
-          <p:cNvSpPr txBox="1"/>
-          <p:nvPr/>
-        </p:nvSpPr>
-        <p:spPr>
-          <a:xfrm>
-            <a:off x="1280160" y="4727448"/>
-            <a:ext cx="4526280" cy="1371600"/>
-          </a:xfrm>
-          <a:prstGeom prst="rect">
-            <a:avLst/>
-          </a:prstGeom>
-          <a:noFill/>
-        </p:spPr>
-        <p:txBody>
-          <a:bodyPr wrap="square" anchor="t" lIns="0" rIns="0" tIns="0" bIns="0">
-            <a:spAutoFit/>
-          </a:bodyPr>
-          <a:lstStyle/>
-          <a:p>
-            <a:pPr algn="l">
-              <a:lnSpc>
-                <a:spcPct val="114000"/>
-              </a:lnSpc>
-              <a:spcBef>
-                <a:spcPts val="0"/>
-              </a:spcBef>
-              <a:spcAft>
-                <a:spcPts val="800"/>
-              </a:spcAft>
-            </a:pPr>
-            <a:r>
-              <a:rPr sz="1600" b="0">
-                <a:solidFill>
-                  <a:srgbClr val="2B3340"/>
-                </a:solidFill>
-                <a:latin typeface="Segoe UI"/>
-              </a:rPr>
-              <a:t>Findet die Drohne automatisch im WLAN – ohne Eintippen einer IP-Adresse.</a:t>
-            </a:r>
-          </a:p>
-        </p:txBody>
-      </p:sp>
-      <p:sp>
-        <p:nvSpPr>
-          <p:cNvPr id="16" name="Rectangle 15"/>
-          <p:cNvSpPr/>
-          <p:nvPr/>
-        </p:nvSpPr>
-        <p:spPr>
-          <a:xfrm>
-            <a:off x="6537960" y="4288536"/>
-            <a:ext cx="256032" cy="256032"/>
-          </a:xfrm>
-          <a:prstGeom prst="rect">
-            <a:avLst/>
-          </a:prstGeom>
-          <a:solidFill>
-            <a:srgbClr val="2F80ED"/>
-          </a:solidFill>
-          <a:ln>
-            <a:noFill/>
-          </a:ln>
-          <a:effectLst/>
-        </p:spPr>
-        <p:style>
-          <a:lnRef idx="1">
-            <a:schemeClr val="accent1"/>
-          </a:lnRef>
-          <a:fillRef idx="3">
-            <a:schemeClr val="accent1"/>
-          </a:fillRef>
-          <a:effectRef idx="2">
-            <a:schemeClr val="accent1"/>
-          </a:effectRef>
-          <a:fontRef idx="minor">
-            <a:schemeClr val="lt1"/>
-          </a:fontRef>
-        </p:style>
-        <p:txBody>
-          <a:bodyPr rtlCol="0" anchor="ctr"/>
-          <a:lstStyle/>
-          <a:p>
-            <a:pPr algn="ctr"/>
-          </a:p>
-        </p:txBody>
-      </p:sp>
-      <p:sp>
-        <p:nvSpPr>
-          <p:cNvPr id="17" name="TextBox 16"/>
-          <p:cNvSpPr txBox="1"/>
-          <p:nvPr/>
-        </p:nvSpPr>
-        <p:spPr>
-          <a:xfrm>
-            <a:off x="6949440" y="4206240"/>
-            <a:ext cx="4480560" cy="457200"/>
-          </a:xfrm>
-          <a:prstGeom prst="rect">
-            <a:avLst/>
-          </a:prstGeom>
-          <a:noFill/>
-        </p:spPr>
-        <p:txBody>
-          <a:bodyPr wrap="square" anchor="t" lIns="0" rIns="0" tIns="0" bIns="0">
-            <a:spAutoFit/>
-          </a:bodyPr>
-          <a:lstStyle/>
-          <a:p>
-            <a:pPr algn="l">
-              <a:lnSpc>
-                <a:spcPct val="100000"/>
-              </a:lnSpc>
-              <a:spcBef>
-                <a:spcPts val="0"/>
-              </a:spcBef>
-              <a:spcAft>
-                <a:spcPts val="800"/>
-              </a:spcAft>
-            </a:pPr>
-            <a:r>
-              <a:rPr sz="2100" b="1">
-                <a:solidFill>
-                  <a:srgbClr val="162133"/>
-                </a:solidFill>
-                <a:latin typeface="Segoe UI Semibold"/>
-              </a:rPr>
-              <a:t>Live am iPhone</a:t>
-            </a:r>
-          </a:p>
-        </p:txBody>
-      </p:sp>
-      <p:sp>
-        <p:nvSpPr>
-          <p:cNvPr id="18" name="TextBox 17"/>
-          <p:cNvSpPr txBox="1"/>
-          <p:nvPr/>
-        </p:nvSpPr>
-        <p:spPr>
-          <a:xfrm>
-            <a:off x="6949440" y="4727448"/>
-            <a:ext cx="4526280" cy="1371600"/>
-          </a:xfrm>
-          <a:prstGeom prst="rect">
-            <a:avLst/>
-          </a:prstGeom>
-          <a:noFill/>
-        </p:spPr>
-        <p:txBody>
-          <a:bodyPr wrap="square" anchor="t" lIns="0" rIns="0" tIns="0" bIns="0">
-            <a:spAutoFit/>
-          </a:bodyPr>
-          <a:lstStyle/>
-          <a:p>
-            <a:pPr algn="l">
-              <a:lnSpc>
-                <a:spcPct val="114000"/>
-              </a:lnSpc>
-              <a:spcBef>
-                <a:spcPts val="0"/>
-              </a:spcBef>
-              <a:spcAft>
-                <a:spcPts val="800"/>
-              </a:spcAft>
-            </a:pPr>
-            <a:r>
-              <a:rPr sz="1600" b="0">
-                <a:solidFill>
-                  <a:srgbClr val="2B3340"/>
-                </a:solidFill>
-                <a:latin typeface="Segoe UI"/>
-              </a:rPr>
-              <a:t>Live-Telemetrie mit 10 Hz und ein 3D-Flugsimulator direkt am iPhone.</a:t>
-            </a:r>
-          </a:p>
-        </p:txBody>
-      </p:sp>
-      <p:cxnSp>
-        <p:nvCxnSpPr>
-          <p:cNvPr id="19" name="Connector 18"/>
-          <p:cNvCxnSpPr/>
-          <p:nvPr/>
-        </p:nvCxnSpPr>
-        <p:spPr>
-          <a:xfrm>
-            <a:off x="6126480" y="2057400"/>
-            <a:ext cx="0" cy="3977639"/>
-          </a:xfrm>
-          <a:prstGeom prst="line">
-            <a:avLst/>
-          </a:prstGeom>
-          <a:ln w="22225">
-            <a:solidFill>
-              <a:srgbClr val="2F80ED"/>
-            </a:solidFill>
-          </a:ln>
-          <a:effectLst/>
-        </p:spPr>
-        <p:style>
-          <a:lnRef idx="2">
-            <a:schemeClr val="accent1"/>
-          </a:lnRef>
-          <a:fillRef idx="0">
-            <a:schemeClr val="accent1"/>
-          </a:fillRef>
-          <a:effectRef idx="1">
-            <a:schemeClr val="accent1"/>
-          </a:effectRef>
-          <a:fontRef idx="minor">
-            <a:schemeClr val="tx1"/>
-          </a:fontRef>
-        </p:style>
-      </p:cxnSp>
-      <p:sp>
-        <p:nvSpPr>
-          <p:cNvPr id="20" name="Rectangle 19"/>
-          <p:cNvSpPr/>
-          <p:nvPr/>
-        </p:nvSpPr>
-        <p:spPr>
-          <a:xfrm>
-            <a:off x="868680" y="4041648"/>
-            <a:ext cx="10469880" cy="15875"/>
-          </a:xfrm>
-          <a:prstGeom prst="rect">
-            <a:avLst/>
-          </a:prstGeom>
-          <a:solidFill>
-            <a:srgbClr val="E2E7EE"/>
-          </a:solidFill>
-          <a:ln>
-            <a:noFill/>
-          </a:ln>
-          <a:effectLst/>
-        </p:spPr>
-        <p:style>
-          <a:lnRef idx="1">
-            <a:schemeClr val="accent1"/>
-          </a:lnRef>
-          <a:fillRef idx="3">
-            <a:schemeClr val="accent1"/>
-          </a:fillRef>
-          <a:effectRef idx="2">
-            <a:schemeClr val="accent1"/>
-          </a:effectRef>
-          <a:fontRef idx="minor">
-            <a:schemeClr val="lt1"/>
-          </a:fontRef>
-        </p:style>
-        <p:txBody>
-          <a:bodyPr rtlCol="0" anchor="ctr"/>
-          <a:lstStyle/>
-          <a:p>
-            <a:pPr algn="ctr"/>
+              <a:t>Sobald die Verbindung steht, zeigt sie die Telemetrie zehnmal pro Sekunde in Echtzeit an und bringt einen eigenen 3D-Flugsimulator direkt aufs Handy. Gebaut ist alles in SwiftUI – nur mit Apple-eigenen Frameworks.</a:t>
+            </a:r>
           </a:p>
         </p:txBody>
       </p:sp>

</xml_diff>

<commit_message>
docs: add extended deck with a "Das Projekt EasyPilot" purpose slide
Refactor both build scripts into per-slide functions that emit two decks each:
- EasyPilot-iOS.(pptx|pdf)          4 slides
- EasyPilot-iOS-Extended.(pptx|pdf) 5 slides, adds a short, crisp slide on the
  purpose of the whole EasyPilot project (drone -> networked telemetry/control
  platform; ESP32-C3, iOS app + web viewer; 4AHITM school project).

Co-Authored-By: Claude Opus 4.8 <noreply@anthropic.com>
</commit_message>
<xml_diff>
--- a/docs/presentation-ios/EasyPilot-iOS.pptx
+++ b/docs/presentation-ios/EasyPilot-iOS.pptx
@@ -3705,7 +3705,7 @@
         <p:spPr>
           <a:xfrm>
             <a:off x="868680" y="1691640"/>
-            <a:ext cx="7315200" cy="1280160"/>
+            <a:ext cx="7498079" cy="1280160"/>
           </a:xfrm>
           <a:prstGeom prst="rect">
             <a:avLst/>
@@ -3838,7 +3838,7 @@
         <p:spPr>
           <a:xfrm>
             <a:off x="1188720" y="3246120"/>
-            <a:ext cx="6309360" cy="1371600"/>
+            <a:ext cx="6766560" cy="1371600"/>
           </a:xfrm>
           <a:prstGeom prst="rect">
             <a:avLst/>
@@ -3927,7 +3927,7 @@
         <p:spPr>
           <a:xfrm>
             <a:off x="1188720" y="4224528"/>
-            <a:ext cx="6309360" cy="1371600"/>
+            <a:ext cx="6766560" cy="1371600"/>
           </a:xfrm>
           <a:prstGeom prst="rect">
             <a:avLst/>
@@ -4016,7 +4016,7 @@
         <p:spPr>
           <a:xfrm>
             <a:off x="1188720" y="5349240"/>
-            <a:ext cx="6309360" cy="1371600"/>
+            <a:ext cx="6766560" cy="1371600"/>
           </a:xfrm>
           <a:prstGeom prst="rect">
             <a:avLst/>

</xml_diff>

<commit_message>
docs: mention stabilization/helper algorithms on the 4-slide deck
Add a short fourth sentence to "Was ist EasyPilot iOS" (standard deck only):
the app can also control the drone's stabilization and helper algorithms.
The extended deck keeps its three-paragraph version.

Co-Authored-By: Claude Opus 4.8 <noreply@anthropic.com>
</commit_message>
<xml_diff>
--- a/docs/presentation-ios/EasyPilot-iOS.pptx
+++ b/docs/presentation-ios/EasyPilot-iOS.pptx
@@ -3793,7 +3793,7 @@
         </p:nvSpPr>
         <p:spPr>
           <a:xfrm>
-            <a:off x="868680" y="3273551"/>
+            <a:off x="868680" y="3182112"/>
             <a:ext cx="54864" cy="566928"/>
           </a:xfrm>
           <a:prstGeom prst="rect">
@@ -3837,7 +3837,7 @@
         </p:nvSpPr>
         <p:spPr>
           <a:xfrm>
-            <a:off x="1188720" y="3246120"/>
+            <a:off x="1188720" y="3154680"/>
             <a:ext cx="6766560" cy="1371600"/>
           </a:xfrm>
           <a:prstGeom prst="rect">
@@ -3882,8 +3882,8 @@
         </p:nvSpPr>
         <p:spPr>
           <a:xfrm>
-            <a:off x="868680" y="4251960"/>
-            <a:ext cx="54864" cy="777240"/>
+            <a:off x="868680" y="4096512"/>
+            <a:ext cx="54864" cy="566928"/>
           </a:xfrm>
           <a:prstGeom prst="rect">
             <a:avLst/>
@@ -3926,7 +3926,7 @@
         </p:nvSpPr>
         <p:spPr>
           <a:xfrm>
-            <a:off x="1188720" y="4224528"/>
+            <a:off x="1188720" y="4069080"/>
             <a:ext cx="6766560" cy="1371600"/>
           </a:xfrm>
           <a:prstGeom prst="rect">
@@ -3958,7 +3958,7 @@
                 </a:solidFill>
                 <a:latin typeface="Segoe UI"/>
               </a:rPr>
-              <a:t>Die iOS-App ist der mobile Co-Pilot: Sie verbindet sich von selbst über das WLAN mit der Drohne, ganz ohne Eingabe einer IP-Adresse.</a:t>
+              <a:t>Die iOS-App ist der mobile Co-Pilot: Sie verbindet sich von selbst über das WLAN mit der Drohne – ohne Eingabe einer IP-Adresse.</a:t>
             </a:r>
           </a:p>
         </p:txBody>
@@ -3971,8 +3971,8 @@
         </p:nvSpPr>
         <p:spPr>
           <a:xfrm>
-            <a:off x="868680" y="5376672"/>
-            <a:ext cx="54864" cy="868680"/>
+            <a:off x="868680" y="5010912"/>
+            <a:ext cx="54864" cy="566928"/>
           </a:xfrm>
           <a:prstGeom prst="rect">
             <a:avLst/>
@@ -4015,7 +4015,7 @@
         </p:nvSpPr>
         <p:spPr>
           <a:xfrm>
-            <a:off x="1188720" y="5349240"/>
+            <a:off x="1188720" y="4983480"/>
             <a:ext cx="6766560" cy="1371600"/>
           </a:xfrm>
           <a:prstGeom prst="rect">
@@ -4047,7 +4047,96 @@
                 </a:solidFill>
                 <a:latin typeface="Segoe UI"/>
               </a:rPr>
-              <a:t>Sobald die Verbindung steht, zeigt sie die Telemetrie zehnmal pro Sekunde in Echtzeit an und bringt einen eigenen 3D-Flugsimulator direkt aufs Handy. Gebaut ist alles in SwiftUI – nur mit Apple-eigenen Frameworks.</a:t>
+              <a:t>Sie zeigt die Telemetrie zehnmal pro Sekunde in Echtzeit an und bringt einen eigenen 3D-Flugsimulator direkt aufs Handy.</a:t>
+            </a:r>
+          </a:p>
+        </p:txBody>
+      </p:sp>
+      <p:sp>
+        <p:nvSpPr>
+          <p:cNvPr id="15" name="Rectangle 14"/>
+          <p:cNvSpPr/>
+          <p:nvPr/>
+        </p:nvSpPr>
+        <p:spPr>
+          <a:xfrm>
+            <a:off x="868680" y="5925312"/>
+            <a:ext cx="54864" cy="566928"/>
+          </a:xfrm>
+          <a:prstGeom prst="rect">
+            <a:avLst/>
+          </a:prstGeom>
+          <a:solidFill>
+            <a:srgbClr val="2F80ED"/>
+          </a:solidFill>
+          <a:ln>
+            <a:noFill/>
+          </a:ln>
+          <a:effectLst/>
+        </p:spPr>
+        <p:style>
+          <a:lnRef idx="1">
+            <a:schemeClr val="accent1"/>
+          </a:lnRef>
+          <a:fillRef idx="3">
+            <a:schemeClr val="accent1"/>
+          </a:fillRef>
+          <a:effectRef idx="2">
+            <a:schemeClr val="accent1"/>
+          </a:effectRef>
+          <a:fontRef idx="minor">
+            <a:schemeClr val="lt1"/>
+          </a:fontRef>
+        </p:style>
+        <p:txBody>
+          <a:bodyPr rtlCol="0" anchor="ctr"/>
+          <a:lstStyle/>
+          <a:p>
+            <a:pPr algn="ctr"/>
+          </a:p>
+        </p:txBody>
+      </p:sp>
+      <p:sp>
+        <p:nvSpPr>
+          <p:cNvPr id="16" name="TextBox 15"/>
+          <p:cNvSpPr txBox="1"/>
+          <p:nvPr/>
+        </p:nvSpPr>
+        <p:spPr>
+          <a:xfrm>
+            <a:off x="1188720" y="5897880"/>
+            <a:ext cx="6766560" cy="1371600"/>
+          </a:xfrm>
+          <a:prstGeom prst="rect">
+            <a:avLst/>
+          </a:prstGeom>
+          <a:noFill/>
+        </p:spPr>
+        <p:txBody>
+          <a:bodyPr wrap="square" anchor="t" lIns="0" rIns="0" tIns="0" bIns="0">
+            <a:spAutoFit/>
+          </a:bodyPr>
+          <a:lstStyle/>
+          <a:p>
+            <a:pPr algn="l">
+              <a:lnSpc>
+                <a:spcPct val="116000"/>
+              </a:lnSpc>
+              <a:spcBef>
+                <a:spcPts val="0"/>
+              </a:spcBef>
+              <a:spcAft>
+                <a:spcPts val="800"/>
+              </a:spcAft>
+            </a:pPr>
+            <a:r>
+              <a:rPr sz="1650" b="0">
+                <a:solidFill>
+                  <a:srgbClr val="2B3340"/>
+                </a:solidFill>
+                <a:latin typeface="Segoe UI"/>
+              </a:rPr>
+              <a:t>Über die App lassen sich außerdem Stabilisierungs- und Hilfsalgorithmen der Drohne steuern.</a:t>
             </a:r>
           </a:p>
         </p:txBody>

</xml_diff>